<commit_message>
Add design-normalized productivity projection and 6 backup slides
Stage 29: fleet MPG re-expressed at constant 2024 weight/HP using the
stage-19 elasticities. The 1987-2004 trough vanishes; productivity grows
+1.94%/yr for 50 years (R^2 = 0.984); projected 40-44 MPG-equivalent by
2045 (fig42, reports/29_productivity.md, outputs/productivity.csv).

Deck: six claim-titled backup slides (15-20) covering changepoints, the
gas-price audit, offered-vs-bought, MSRP history, cost-per-mile trends,
and the productivity projection. SHORTSTORY.md updated for the 25-minute
ceiling and titles-tell-the-story grading criterion.

Co-Authored-By: Claude Fable 5 <noreply@anthropic.com>
</commit_message>
<xml_diff>
--- a/MPG Prediction Deck.pptx
+++ b/MPG Prediction Deck.pptx
@@ -19,9 +19,15 @@
     <p:sldId id="267" r:id="rId13"/>
     <p:sldId id="268" r:id="rId14"/>
     <p:sldId id="269" r:id="rId15"/>
+    <p:sldId id="270" r:id="rId16"/>
+    <p:sldId id="271" r:id="rId17"/>
+    <p:sldId id="272" r:id="rId18"/>
+    <p:sldId id="273" r:id="rId19"/>
+    <p:sldId id="274" r:id="rId20"/>
+    <p:sldId id="275" r:id="rId21"/>
   </p:sldIdLst>
   <p:notesMasterIdLst>
-    <p:notesMasterId r:id="rId16"/>
+    <p:notesMasterId r:id="rId22"/>
   </p:notesMasterIdLst>
   <p:sldSz cx="12192000" cy="6858000"/>
   <p:notesSz cx="6858000" cy="12192000"/>
@@ -997,6 +1003,446 @@
 </p:notes>
 </file>
 
+<file path=ppt/notesSlides/notesSlide15.xml><?xml version="1.0" encoding="utf-8"?>
+<p:notes xmlns:a="http://schemas.openxmlformats.org/drawingml/2006/main" xmlns:r="http://schemas.openxmlformats.org/officeDocument/2006/relationships" xmlns:p="http://schemas.openxmlformats.org/presentationml/2006/main">
+  <p:cSld>
+    <p:spTree>
+      <p:nvGrpSpPr>
+        <p:cNvPr id="1" name=""/>
+        <p:cNvGrpSpPr/>
+        <p:nvPr/>
+      </p:nvGrpSpPr>
+      <p:grpSpPr>
+        <a:xfrm>
+          <a:off x="0" y="0"/>
+          <a:ext cx="0" cy="0"/>
+          <a:chOff x="0" y="0"/>
+          <a:chExt cx="0" cy="0"/>
+        </a:xfrm>
+      </p:grpSpPr>
+      <p:sp>
+        <p:nvSpPr>
+          <p:cNvPr id="2" name="Slide Image Placeholder 1"/>
+          <p:cNvSpPr>
+            <a:spLocks noGrp="1" noRot="1" noChangeAspect="1"/>
+          </p:cNvSpPr>
+          <p:nvPr>
+            <p:ph type="sldImg"/>
+          </p:nvPr>
+        </p:nvSpPr>
+        <p:spPr/>
+      </p:sp>
+      <p:sp>
+        <p:nvSpPr>
+          <p:cNvPr id="3" name="Notes Placeholder 2"/>
+          <p:cNvSpPr>
+            <a:spLocks noGrp="1"/>
+          </p:cNvSpPr>
+          <p:nvPr>
+            <p:ph type="body" idx="1"/>
+          </p:nvPr>
+        </p:nvSpPr>
+        <p:spPr/>
+        <p:txBody>
+          <a:bodyPr/>
+          <a:lstStyle/>
+          <a:p>
+            <a:r>
+              <a:rPr lang="en-US" dirty="0"/>
+              <a:t>Use if asked how the eras on slide 3 were chosen: exhaustive changepoint search, BIC model order, Chow tests at the chosen breaks.</a:t>
+            </a:r>
+            <a:endParaRPr lang="en-US" dirty="0"/>
+          </a:p>
+        </p:txBody>
+      </p:sp>
+      <p:sp>
+        <p:nvSpPr>
+          <p:cNvPr id="4" name="Slide Number Placeholder 3"/>
+          <p:cNvSpPr>
+            <a:spLocks noGrp="1"/>
+          </p:cNvSpPr>
+          <p:nvPr>
+            <p:ph type="sldNum" sz="quarter" idx="10"/>
+          </p:nvPr>
+        </p:nvSpPr>
+        <p:spPr/>
+        <p:txBody>
+          <a:bodyPr/>
+          <a:lstStyle/>
+          <a:p>
+            <a:fld id="{F7021451-1387-4CA6-816F-3879F97B5CBC}" type="slidenum">
+              <a:rPr lang="en-US"/>
+              <a:t>15</a:t>
+            </a:fld>
+            <a:endParaRPr lang="en-US"/>
+          </a:p>
+        </p:txBody>
+      </p:sp>
+    </p:spTree>
+    <p:extLst>
+      <p:ext uri="{BB962C8B-B14F-4D97-AF65-F5344CB8AC3E}">
+        <p14:creationId xmlns:p14="http://schemas.microsoft.com/office/powerpoint/2010/main" val="1024086991"/>
+      </p:ext>
+    </p:extLst>
+  </p:cSld>
+  <p:clrMapOvr>
+    <a:masterClrMapping/>
+  </p:clrMapOvr>
+</p:notes>
+</file>
+
+<file path=ppt/notesSlides/notesSlide16.xml><?xml version="1.0" encoding="utf-8"?>
+<p:notes xmlns:a="http://schemas.openxmlformats.org/drawingml/2006/main" xmlns:r="http://schemas.openxmlformats.org/officeDocument/2006/relationships" xmlns:p="http://schemas.openxmlformats.org/presentationml/2006/main">
+  <p:cSld>
+    <p:spTree>
+      <p:nvGrpSpPr>
+        <p:cNvPr id="1" name=""/>
+        <p:cNvGrpSpPr/>
+        <p:nvPr/>
+      </p:nvGrpSpPr>
+      <p:grpSpPr>
+        <a:xfrm>
+          <a:off x="0" y="0"/>
+          <a:ext cx="0" cy="0"/>
+          <a:chOff x="0" y="0"/>
+          <a:chExt cx="0" cy="0"/>
+        </a:xfrm>
+      </p:grpSpPr>
+      <p:sp>
+        <p:nvSpPr>
+          <p:cNvPr id="2" name="Slide Image Placeholder 1"/>
+          <p:cNvSpPr>
+            <a:spLocks noGrp="1" noRot="1" noChangeAspect="1"/>
+          </p:cNvSpPr>
+          <p:nvPr>
+            <p:ph type="sldImg"/>
+          </p:nvPr>
+        </p:nvSpPr>
+        <p:spPr/>
+      </p:sp>
+      <p:sp>
+        <p:nvSpPr>
+          <p:cNvPr id="3" name="Notes Placeholder 2"/>
+          <p:cNvSpPr>
+            <a:spLocks noGrp="1"/>
+          </p:cNvSpPr>
+          <p:nvPr>
+            <p:ph type="body" idx="1"/>
+          </p:nvPr>
+        </p:nvSpPr>
+        <p:spPr/>
+        <p:txBody>
+          <a:bodyPr/>
+          <a:lstStyle/>
+          <a:p>
+            <a:r>
+              <a:rPr lang="en-US" dirty="0"/>
+              <a:t>Use for any causal question about gas prices or interest rates driving buying patterns: we tested both, both fail the differenced audit. Event study rescued exactly one episode, 1979.</a:t>
+            </a:r>
+            <a:endParaRPr lang="en-US" dirty="0"/>
+          </a:p>
+        </p:txBody>
+      </p:sp>
+      <p:sp>
+        <p:nvSpPr>
+          <p:cNvPr id="4" name="Slide Number Placeholder 3"/>
+          <p:cNvSpPr>
+            <a:spLocks noGrp="1"/>
+          </p:cNvSpPr>
+          <p:nvPr>
+            <p:ph type="sldNum" sz="quarter" idx="10"/>
+          </p:nvPr>
+        </p:nvSpPr>
+        <p:spPr/>
+        <p:txBody>
+          <a:bodyPr/>
+          <a:lstStyle/>
+          <a:p>
+            <a:fld id="{F7021451-1387-4CA6-816F-3879F97B5CBC}" type="slidenum">
+              <a:rPr lang="en-US"/>
+              <a:t>16</a:t>
+            </a:fld>
+            <a:endParaRPr lang="en-US"/>
+          </a:p>
+        </p:txBody>
+      </p:sp>
+    </p:spTree>
+    <p:extLst>
+      <p:ext uri="{BB962C8B-B14F-4D97-AF65-F5344CB8AC3E}">
+        <p14:creationId xmlns:p14="http://schemas.microsoft.com/office/powerpoint/2010/main" val="1024086991"/>
+      </p:ext>
+    </p:extLst>
+  </p:cSld>
+  <p:clrMapOvr>
+    <a:masterClrMapping/>
+  </p:clrMapOvr>
+</p:notes>
+</file>
+
+<file path=ppt/notesSlides/notesSlide17.xml><?xml version="1.0" encoding="utf-8"?>
+<p:notes xmlns:a="http://schemas.openxmlformats.org/drawingml/2006/main" xmlns:r="http://schemas.openxmlformats.org/officeDocument/2006/relationships" xmlns:p="http://schemas.openxmlformats.org/presentationml/2006/main">
+  <p:cSld>
+    <p:spTree>
+      <p:nvGrpSpPr>
+        <p:cNvPr id="1" name=""/>
+        <p:cNvGrpSpPr/>
+        <p:nvPr/>
+      </p:nvGrpSpPr>
+      <p:grpSpPr>
+        <a:xfrm>
+          <a:off x="0" y="0"/>
+          <a:ext cx="0" cy="0"/>
+          <a:chOff x="0" y="0"/>
+          <a:chExt cx="0" cy="0"/>
+        </a:xfrm>
+      </p:grpSpPr>
+      <p:sp>
+        <p:nvSpPr>
+          <p:cNvPr id="2" name="Slide Image Placeholder 1"/>
+          <p:cNvSpPr>
+            <a:spLocks noGrp="1" noRot="1" noChangeAspect="1"/>
+          </p:cNvSpPr>
+          <p:nvPr>
+            <p:ph type="sldImg"/>
+          </p:nvPr>
+        </p:nvSpPr>
+        <p:spPr/>
+      </p:sp>
+      <p:sp>
+        <p:nvSpPr>
+          <p:cNvPr id="3" name="Notes Placeholder 2"/>
+          <p:cNvSpPr>
+            <a:spLocks noGrp="1"/>
+          </p:cNvSpPr>
+          <p:nvPr>
+            <p:ph type="body" idx="1"/>
+          </p:nvPr>
+        </p:nvSpPr>
+        <p:spPr/>
+        <p:txBody>
+          <a:bodyPr/>
+          <a:lstStyle/>
+          <a:p>
+            <a:r>
+              <a:rPr lang="en-US" dirty="0"/>
+              <a:t>Use for consumer-behavior questions: demand tilts toward efficiency relative to the catalog, and volume concentrates hard.</a:t>
+            </a:r>
+            <a:endParaRPr lang="en-US" dirty="0"/>
+          </a:p>
+        </p:txBody>
+      </p:sp>
+      <p:sp>
+        <p:nvSpPr>
+          <p:cNvPr id="4" name="Slide Number Placeholder 3"/>
+          <p:cNvSpPr>
+            <a:spLocks noGrp="1"/>
+          </p:cNvSpPr>
+          <p:nvPr>
+            <p:ph type="sldNum" sz="quarter" idx="10"/>
+          </p:nvPr>
+        </p:nvSpPr>
+        <p:spPr/>
+        <p:txBody>
+          <a:bodyPr/>
+          <a:lstStyle/>
+          <a:p>
+            <a:fld id="{F7021451-1387-4CA6-816F-3879F97B5CBC}" type="slidenum">
+              <a:rPr lang="en-US"/>
+              <a:t>17</a:t>
+            </a:fld>
+            <a:endParaRPr lang="en-US"/>
+          </a:p>
+        </p:txBody>
+      </p:sp>
+    </p:spTree>
+    <p:extLst>
+      <p:ext uri="{BB962C8B-B14F-4D97-AF65-F5344CB8AC3E}">
+        <p14:creationId xmlns:p14="http://schemas.microsoft.com/office/powerpoint/2010/main" val="1024086991"/>
+      </p:ext>
+    </p:extLst>
+  </p:cSld>
+  <p:clrMapOvr>
+    <a:masterClrMapping/>
+  </p:clrMapOvr>
+</p:notes>
+</file>
+
+<file path=ppt/notesSlides/notesSlide18.xml><?xml version="1.0" encoding="utf-8"?>
+<p:notes xmlns:a="http://schemas.openxmlformats.org/drawingml/2006/main" xmlns:r="http://schemas.openxmlformats.org/officeDocument/2006/relationships" xmlns:p="http://schemas.openxmlformats.org/presentationml/2006/main">
+  <p:cSld>
+    <p:spTree>
+      <p:nvGrpSpPr>
+        <p:cNvPr id="1" name=""/>
+        <p:cNvGrpSpPr/>
+        <p:nvPr/>
+      </p:nvGrpSpPr>
+      <p:grpSpPr>
+        <a:xfrm>
+          <a:off x="0" y="0"/>
+          <a:ext cx="0" cy="0"/>
+          <a:chOff x="0" y="0"/>
+          <a:chExt cx="0" cy="0"/>
+        </a:xfrm>
+      </p:grpSpPr>
+      <p:sp>
+        <p:nvSpPr>
+          <p:cNvPr id="2" name="Slide Image Placeholder 1"/>
+          <p:cNvSpPr>
+            <a:spLocks noGrp="1" noRot="1" noChangeAspect="1"/>
+          </p:cNvSpPr>
+          <p:nvPr>
+            <p:ph type="sldImg"/>
+          </p:nvPr>
+        </p:nvSpPr>
+        <p:spPr/>
+      </p:sp>
+      <p:sp>
+        <p:nvSpPr>
+          <p:cNvPr id="3" name="Notes Placeholder 2"/>
+          <p:cNvSpPr>
+            <a:spLocks noGrp="1"/>
+          </p:cNvSpPr>
+          <p:nvPr>
+            <p:ph type="body" idx="1"/>
+          </p:nvPr>
+        </p:nvSpPr>
+        <p:spPr/>
+        <p:txBody>
+          <a:bodyPr/>
+          <a:lstStyle/>
+          <a:p>
+            <a:r>
+              <a:rPr lang="en-US" dirty="0"/>
+              <a:t>Use for price-history questions. Emphasize MSRP vs ATP distinction: asking price vs price paid.</a:t>
+            </a:r>
+            <a:endParaRPr lang="en-US" dirty="0"/>
+          </a:p>
+        </p:txBody>
+      </p:sp>
+      <p:sp>
+        <p:nvSpPr>
+          <p:cNvPr id="4" name="Slide Number Placeholder 3"/>
+          <p:cNvSpPr>
+            <a:spLocks noGrp="1"/>
+          </p:cNvSpPr>
+          <p:nvPr>
+            <p:ph type="sldNum" sz="quarter" idx="10"/>
+          </p:nvPr>
+        </p:nvSpPr>
+        <p:spPr/>
+        <p:txBody>
+          <a:bodyPr/>
+          <a:lstStyle/>
+          <a:p>
+            <a:fld id="{F7021451-1387-4CA6-816F-3879F97B5CBC}" type="slidenum">
+              <a:rPr lang="en-US"/>
+              <a:t>18</a:t>
+            </a:fld>
+            <a:endParaRPr lang="en-US"/>
+          </a:p>
+        </p:txBody>
+      </p:sp>
+    </p:spTree>
+    <p:extLst>
+      <p:ext uri="{BB962C8B-B14F-4D97-AF65-F5344CB8AC3E}">
+        <p14:creationId xmlns:p14="http://schemas.microsoft.com/office/powerpoint/2010/main" val="1024086991"/>
+      </p:ext>
+    </p:extLst>
+  </p:cSld>
+  <p:clrMapOvr>
+    <a:masterClrMapping/>
+  </p:clrMapOvr>
+</p:notes>
+</file>
+
+<file path=ppt/notesSlides/notesSlide19.xml><?xml version="1.0" encoding="utf-8"?>
+<p:notes xmlns:a="http://schemas.openxmlformats.org/drawingml/2006/main" xmlns:r="http://schemas.openxmlformats.org/officeDocument/2006/relationships" xmlns:p="http://schemas.openxmlformats.org/presentationml/2006/main">
+  <p:cSld>
+    <p:spTree>
+      <p:nvGrpSpPr>
+        <p:cNvPr id="1" name=""/>
+        <p:cNvGrpSpPr/>
+        <p:nvPr/>
+      </p:nvGrpSpPr>
+      <p:grpSpPr>
+        <a:xfrm>
+          <a:off x="0" y="0"/>
+          <a:ext cx="0" cy="0"/>
+          <a:chOff x="0" y="0"/>
+          <a:chExt cx="0" cy="0"/>
+        </a:xfrm>
+      </p:grpSpPr>
+      <p:sp>
+        <p:nvSpPr>
+          <p:cNvPr id="2" name="Slide Image Placeholder 1"/>
+          <p:cNvSpPr>
+            <a:spLocks noGrp="1" noRot="1" noChangeAspect="1"/>
+          </p:cNvSpPr>
+          <p:nvPr>
+            <p:ph type="sldImg"/>
+          </p:nvPr>
+        </p:nvSpPr>
+        <p:spPr/>
+      </p:sp>
+      <p:sp>
+        <p:nvSpPr>
+          <p:cNvPr id="3" name="Notes Placeholder 2"/>
+          <p:cNvSpPr>
+            <a:spLocks noGrp="1"/>
+          </p:cNvSpPr>
+          <p:nvPr>
+            <p:ph type="body" idx="1"/>
+          </p:nvPr>
+        </p:nvSpPr>
+        <p:spPr/>
+        <p:txBody>
+          <a:bodyPr/>
+          <a:lstStyle/>
+          <a:p>
+            <a:r>
+              <a:rPr lang="en-US" dirty="0"/>
+              <a:t>Use for fuel-cost trend questions. Energy only; excludes purchase, depreciation, DC-fast premiums; PHEV and diesel excluded with reasons.</a:t>
+            </a:r>
+            <a:endParaRPr lang="en-US" dirty="0"/>
+          </a:p>
+        </p:txBody>
+      </p:sp>
+      <p:sp>
+        <p:nvSpPr>
+          <p:cNvPr id="4" name="Slide Number Placeholder 3"/>
+          <p:cNvSpPr>
+            <a:spLocks noGrp="1"/>
+          </p:cNvSpPr>
+          <p:nvPr>
+            <p:ph type="sldNum" sz="quarter" idx="10"/>
+          </p:nvPr>
+        </p:nvSpPr>
+        <p:spPr/>
+        <p:txBody>
+          <a:bodyPr/>
+          <a:lstStyle/>
+          <a:p>
+            <a:fld id="{F7021451-1387-4CA6-816F-3879F97B5CBC}" type="slidenum">
+              <a:rPr lang="en-US"/>
+              <a:t>19</a:t>
+            </a:fld>
+            <a:endParaRPr lang="en-US"/>
+          </a:p>
+        </p:txBody>
+      </p:sp>
+    </p:spTree>
+    <p:extLst>
+      <p:ext uri="{BB962C8B-B14F-4D97-AF65-F5344CB8AC3E}">
+        <p14:creationId xmlns:p14="http://schemas.microsoft.com/office/powerpoint/2010/main" val="1024086991"/>
+      </p:ext>
+    </p:extLst>
+  </p:cSld>
+  <p:clrMapOvr>
+    <a:masterClrMapping/>
+  </p:clrMapOvr>
+</p:notes>
+</file>
+
 <file path=ppt/notesSlides/notesSlide2.xml><?xml version="1.0" encoding="utf-8"?>
 <p:notes xmlns:a="http://schemas.openxmlformats.org/drawingml/2006/main" xmlns:r="http://schemas.openxmlformats.org/officeDocument/2006/relationships" xmlns:p="http://schemas.openxmlformats.org/presentationml/2006/main">
   <p:cSld>
@@ -1067,6 +1513,94 @@
             <a:fld id="{F7021451-1387-4CA6-816F-3879F97B5CBC}" type="slidenum">
               <a:rPr lang="en-US"/>
               <a:t>2</a:t>
+            </a:fld>
+            <a:endParaRPr lang="en-US"/>
+          </a:p>
+        </p:txBody>
+      </p:sp>
+    </p:spTree>
+    <p:extLst>
+      <p:ext uri="{BB962C8B-B14F-4D97-AF65-F5344CB8AC3E}">
+        <p14:creationId xmlns:p14="http://schemas.microsoft.com/office/powerpoint/2010/main" val="1024086991"/>
+      </p:ext>
+    </p:extLst>
+  </p:cSld>
+  <p:clrMapOvr>
+    <a:masterClrMapping/>
+  </p:clrMapOvr>
+</p:notes>
+</file>
+
+<file path=ppt/notesSlides/notesSlide20.xml><?xml version="1.0" encoding="utf-8"?>
+<p:notes xmlns:a="http://schemas.openxmlformats.org/drawingml/2006/main" xmlns:r="http://schemas.openxmlformats.org/officeDocument/2006/relationships" xmlns:p="http://schemas.openxmlformats.org/presentationml/2006/main">
+  <p:cSld>
+    <p:spTree>
+      <p:nvGrpSpPr>
+        <p:cNvPr id="1" name=""/>
+        <p:cNvGrpSpPr/>
+        <p:nvPr/>
+      </p:nvGrpSpPr>
+      <p:grpSpPr>
+        <a:xfrm>
+          <a:off x="0" y="0"/>
+          <a:ext cx="0" cy="0"/>
+          <a:chOff x="0" y="0"/>
+          <a:chExt cx="0" cy="0"/>
+        </a:xfrm>
+      </p:grpSpPr>
+      <p:sp>
+        <p:nvSpPr>
+          <p:cNvPr id="2" name="Slide Image Placeholder 1"/>
+          <p:cNvSpPr>
+            <a:spLocks noGrp="1" noRot="1" noChangeAspect="1"/>
+          </p:cNvSpPr>
+          <p:nvPr>
+            <p:ph type="sldImg"/>
+          </p:nvPr>
+        </p:nvSpPr>
+        <p:spPr/>
+      </p:sp>
+      <p:sp>
+        <p:nvSpPr>
+          <p:cNvPr id="3" name="Notes Placeholder 2"/>
+          <p:cNvSpPr>
+            <a:spLocks noGrp="1"/>
+          </p:cNvSpPr>
+          <p:nvPr>
+            <p:ph type="body" idx="1"/>
+          </p:nvPr>
+        </p:nvSpPr>
+        <p:spPr/>
+        <p:txBody>
+          <a:bodyPr/>
+          <a:lstStyle/>
+          <a:p>
+            <a:r>
+              <a:rPr lang="en-US" dirty="0"/>
+              <a:t>The forward-looking backup: normalization built from our own regression coefficients. Lead with the vanished trough, then the projection, then the caveats in order.</a:t>
+            </a:r>
+            <a:endParaRPr lang="en-US" dirty="0"/>
+          </a:p>
+        </p:txBody>
+      </p:sp>
+      <p:sp>
+        <p:nvSpPr>
+          <p:cNvPr id="4" name="Slide Number Placeholder 3"/>
+          <p:cNvSpPr>
+            <a:spLocks noGrp="1"/>
+          </p:cNvSpPr>
+          <p:nvPr>
+            <p:ph type="sldNum" sz="quarter" idx="10"/>
+          </p:nvPr>
+        </p:nvSpPr>
+        <p:spPr/>
+        <p:txBody>
+          <a:bodyPr/>
+          <a:lstStyle/>
+          <a:p>
+            <a:fld id="{F7021451-1387-4CA6-816F-3879F97B5CBC}" type="slidenum">
+              <a:rPr lang="en-US"/>
+              <a:t>20</a:t>
             </a:fld>
             <a:endParaRPr lang="en-US"/>
           </a:p>
@@ -5814,6 +6348,906 @@
 </p:sld>
 </file>
 
+<file path=ppt/slides/slide15.xml><?xml version="1.0" encoding="utf-8"?>
+<p:sld xmlns:a="http://schemas.openxmlformats.org/drawingml/2006/main" xmlns:r="http://schemas.openxmlformats.org/officeDocument/2006/relationships" xmlns:p="http://schemas.openxmlformats.org/presentationml/2006/main">
+  <p:cSld name="Slide 15">
+    <p:spTree>
+      <p:nvGrpSpPr>
+        <p:cNvPr id="1" name=""/>
+        <p:cNvGrpSpPr/>
+        <p:nvPr/>
+      </p:nvGrpSpPr>
+      <p:grpSpPr>
+        <a:xfrm>
+          <a:off x="0" y="0"/>
+          <a:ext cx="0" cy="0"/>
+          <a:chOff x="0" y="0"/>
+          <a:chExt cx="0" cy="0"/>
+        </a:xfrm>
+      </p:grpSpPr>
+      <p:sp>
+        <p:nvSpPr>
+          <p:cNvPr id="2" name="Text 0"/>
+          <p:cNvSpPr txBox="1"/>
+          <p:nvPr/>
+        </p:nvSpPr>
+        <p:spPr>
+          <a:xfrm>
+            <a:off x="502920" y="292608"/>
+            <a:ext cx="11155680" cy="685800"/>
+          </a:xfrm>
+          <a:prstGeom prst="rect">
+            <a:avLst/>
+          </a:prstGeom>
+          <a:noFill/>
+          <a:ln/>
+        </p:spPr>
+        <p:txBody>
+          <a:bodyPr wrap="square" lIns="0" tIns="0" rIns="0" bIns="0" rtlCol="0" anchor="ctr"/>
+          <a:lstStyle/>
+          <a:p>
+            <a:pPr indent="0" marL="0">
+              <a:buNone/>
+            </a:pPr>
+            <a:r>
+              <a:rPr lang="en-US" sz="1300" b="1" dirty="0">
+                <a:solidFill>
+                  <a:srgbClr val="EB6834"/>
+                </a:solidFill>
+                <a:latin typeface="Calibri" pitchFamily="34" charset="0"/>
+                <a:ea typeface="Calibri" pitchFamily="34" charset="-122"/>
+                <a:cs typeface="Calibri" pitchFamily="34" charset="-120"/>
+              </a:rPr>
+              <a:t>BACKUP   </a:t>
+            </a:r>
+            <a:pPr indent="0" marL="0">
+              <a:buNone/>
+            </a:pPr>
+            <a:r>
+              <a:rPr lang="en-US" sz="2600" b="1" dirty="0">
+                <a:solidFill>
+                  <a:srgbClr val="0B0B0B"/>
+                </a:solidFill>
+                <a:latin typeface="Calibri" pitchFamily="34" charset="0"/>
+                <a:ea typeface="Calibri" pitchFamily="34" charset="-122"/>
+                <a:cs typeface="Calibri" pitchFamily="34" charset="-120"/>
+              </a:rPr>
+              <a:t>The eras were found by algorithm, not by eye</a:t>
+            </a:r>
+            <a:endParaRPr lang="en-US" sz="1300" dirty="0"/>
+          </a:p>
+        </p:txBody>
+      </p:sp>
+      <p:pic>
+        <p:nvPicPr>
+          <p:cNvPr id="3" name="Image 0" descr="C:\Users\Samson\Desktop\Homework\OS3180\Final Project\charts\fig16_changepoints.png">    </p:cNvPr>
+          <p:cNvPicPr>
+            <a:picLocks noChangeAspect="1"/>
+          </p:cNvPicPr>
+          <p:nvPr/>
+        </p:nvPicPr>
+        <p:blipFill>
+          <a:blip r:embed="rId1"/>
+          <a:stretch>
+            <a:fillRect/>
+          </a:stretch>
+        </p:blipFill>
+        <p:spPr>
+          <a:xfrm>
+            <a:off x="502920" y="1234440"/>
+            <a:ext cx="7498080" cy="4362519"/>
+          </a:xfrm>
+          <a:prstGeom prst="rect">
+            <a:avLst/>
+          </a:prstGeom>
+        </p:spPr>
+      </p:pic>
+      <p:sp>
+        <p:nvSpPr>
+          <p:cNvPr id="4" name="Text 1"/>
+          <p:cNvSpPr txBox="1"/>
+          <p:nvPr/>
+        </p:nvSpPr>
+        <p:spPr>
+          <a:xfrm>
+            <a:off x="8321040" y="1463040"/>
+            <a:ext cx="3337560" cy="4206240"/>
+          </a:xfrm>
+          <a:prstGeom prst="rect">
+            <a:avLst/>
+          </a:prstGeom>
+          <a:noFill/>
+          <a:ln/>
+        </p:spPr>
+        <p:txBody>
+          <a:bodyPr wrap="square" lIns="0" tIns="0" rIns="0" bIns="0" rtlCol="0" anchor="ctr"/>
+          <a:lstStyle/>
+          <a:p>
+            <a:pPr indent="0" marL="0">
+              <a:buNone/>
+            </a:pPr>
+            <a:r>
+              <a:rPr lang="en-US" sz="1450" dirty="0">
+                <a:solidFill>
+                  <a:srgbClr val="0B0B0B"/>
+                </a:solidFill>
+                <a:latin typeface="Calibri" pitchFamily="34" charset="0"/>
+                <a:ea typeface="Calibri" pitchFamily="34" charset="-122"/>
+                <a:cs typeface="Calibri" pitchFamily="34" charset="-120"/>
+              </a:rPr>
+              <a:t>BIC-selected piecewise-linear breaks land at 1983, 2003, and 2013, each significant by Chow test (F = 13.7, 6.1, 3.5). The three-act story on slide 3 is a model-selection result, not an annotation choice.</a:t>
+            </a:r>
+            <a:endParaRPr lang="en-US" sz="1450" dirty="0"/>
+          </a:p>
+        </p:txBody>
+      </p:sp>
+      <p:sp>
+        <p:nvSpPr>
+          <p:cNvPr id="5" name="Text 2"/>
+          <p:cNvSpPr txBox="1"/>
+          <p:nvPr/>
+        </p:nvSpPr>
+        <p:spPr>
+          <a:xfrm>
+            <a:off x="502920" y="6446520"/>
+            <a:ext cx="11155680" cy="292608"/>
+          </a:xfrm>
+          <a:prstGeom prst="rect">
+            <a:avLst/>
+          </a:prstGeom>
+          <a:noFill/>
+          <a:ln/>
+        </p:spPr>
+        <p:txBody>
+          <a:bodyPr wrap="square" lIns="0" tIns="0" rIns="0" bIns="0" rtlCol="0" anchor="ctr"/>
+          <a:lstStyle/>
+          <a:p>
+            <a:pPr indent="0" marL="0">
+              <a:buNone/>
+            </a:pPr>
+            <a:r>
+              <a:rPr lang="en-US" sz="1000" dirty="0">
+                <a:solidFill>
+                  <a:srgbClr val="6E6C66"/>
+                </a:solidFill>
+                <a:latin typeface="Calibri" pitchFamily="34" charset="0"/>
+                <a:ea typeface="Calibri" pitchFamily="34" charset="-122"/>
+                <a:cs typeface="Calibri" pitchFamily="34" charset="-120"/>
+              </a:rPr>
+              <a:t>Exhaustive SSE search over break locations, order by BIC; reports/10_statistics.md.</a:t>
+            </a:r>
+            <a:endParaRPr lang="en-US" sz="1000" dirty="0"/>
+          </a:p>
+        </p:txBody>
+      </p:sp>
+    </p:spTree>
+  </p:cSld>
+  <p:clrMapOvr>
+    <a:masterClrMapping/>
+  </p:clrMapOvr>
+</p:sld>
+</file>
+
+<file path=ppt/slides/slide16.xml><?xml version="1.0" encoding="utf-8"?>
+<p:sld xmlns:a="http://schemas.openxmlformats.org/drawingml/2006/main" xmlns:r="http://schemas.openxmlformats.org/officeDocument/2006/relationships" xmlns:p="http://schemas.openxmlformats.org/presentationml/2006/main">
+  <p:cSld name="Slide 16">
+    <p:spTree>
+      <p:nvGrpSpPr>
+        <p:cNvPr id="1" name=""/>
+        <p:cNvGrpSpPr/>
+        <p:nvPr/>
+      </p:nvGrpSpPr>
+      <p:grpSpPr>
+        <a:xfrm>
+          <a:off x="0" y="0"/>
+          <a:ext cx="0" cy="0"/>
+          <a:chOff x="0" y="0"/>
+          <a:chExt cx="0" cy="0"/>
+        </a:xfrm>
+      </p:grpSpPr>
+      <p:sp>
+        <p:nvSpPr>
+          <p:cNvPr id="2" name="Text 0"/>
+          <p:cNvSpPr txBox="1"/>
+          <p:nvPr/>
+        </p:nvSpPr>
+        <p:spPr>
+          <a:xfrm>
+            <a:off x="502920" y="292608"/>
+            <a:ext cx="11155680" cy="685800"/>
+          </a:xfrm>
+          <a:prstGeom prst="rect">
+            <a:avLst/>
+          </a:prstGeom>
+          <a:noFill/>
+          <a:ln/>
+        </p:spPr>
+        <p:txBody>
+          <a:bodyPr wrap="square" lIns="0" tIns="0" rIns="0" bIns="0" rtlCol="0" anchor="ctr"/>
+          <a:lstStyle/>
+          <a:p>
+            <a:pPr indent="0" marL="0">
+              <a:buNone/>
+            </a:pPr>
+            <a:r>
+              <a:rPr lang="en-US" sz="1300" b="1" dirty="0">
+                <a:solidFill>
+                  <a:srgbClr val="EB6834"/>
+                </a:solidFill>
+                <a:latin typeface="Calibri" pitchFamily="34" charset="0"/>
+                <a:ea typeface="Calibri" pitchFamily="34" charset="-122"/>
+                <a:cs typeface="Calibri" pitchFamily="34" charset="-120"/>
+              </a:rPr>
+              <a:t>BACKUP   </a:t>
+            </a:r>
+            <a:pPr indent="0" marL="0">
+              <a:buNone/>
+            </a:pPr>
+            <a:r>
+              <a:rPr lang="en-US" sz="2600" b="1" dirty="0">
+                <a:solidFill>
+                  <a:srgbClr val="0B0B0B"/>
+                </a:solidFill>
+                <a:latin typeface="Calibri" pitchFamily="34" charset="0"/>
+                <a:ea typeface="Calibri" pitchFamily="34" charset="-122"/>
+                <a:cs typeface="Calibri" pitchFamily="34" charset="-120"/>
+              </a:rPr>
+              <a:t>We audited our own story: gas prices explain almost none of the mix shift</a:t>
+            </a:r>
+            <a:endParaRPr lang="en-US" sz="1300" dirty="0"/>
+          </a:p>
+        </p:txBody>
+      </p:sp>
+      <p:pic>
+        <p:nvPicPr>
+          <p:cNvPr id="3" name="Image 0" descr="C:\Users\Samson\Desktop\Homework\OS3180\Final Project\charts\fig19_correlation_that_wasnt.png">    </p:cNvPr>
+          <p:cNvPicPr>
+            <a:picLocks noChangeAspect="1"/>
+          </p:cNvPicPr>
+          <p:nvPr/>
+        </p:nvPicPr>
+        <p:blipFill>
+          <a:blip r:embed="rId1"/>
+          <a:stretch>
+            <a:fillRect/>
+          </a:stretch>
+        </p:blipFill>
+        <p:spPr>
+          <a:xfrm>
+            <a:off x="502920" y="1234440"/>
+            <a:ext cx="7498080" cy="4362519"/>
+          </a:xfrm>
+          <a:prstGeom prst="rect">
+            <a:avLst/>
+          </a:prstGeom>
+        </p:spPr>
+      </p:pic>
+      <p:sp>
+        <p:nvSpPr>
+          <p:cNvPr id="4" name="Text 1"/>
+          <p:cNvSpPr txBox="1"/>
+          <p:nvPr/>
+        </p:nvSpPr>
+        <p:spPr>
+          <a:xfrm>
+            <a:off x="8321040" y="1463040"/>
+            <a:ext cx="3337560" cy="4206240"/>
+          </a:xfrm>
+          <a:prstGeom prst="rect">
+            <a:avLst/>
+          </a:prstGeom>
+          <a:noFill/>
+          <a:ln/>
+        </p:spPr>
+        <p:txBody>
+          <a:bodyPr wrap="square" lIns="0" tIns="0" rIns="0" bIns="0" rtlCol="0" anchor="ctr"/>
+          <a:lstStyle/>
+          <a:p>
+            <a:pPr indent="0" marL="0">
+              <a:buNone/>
+            </a:pPr>
+            <a:r>
+              <a:rPr lang="en-US" sz="1450" dirty="0">
+                <a:solidFill>
+                  <a:srgbClr val="0B0B0B"/>
+                </a:solidFill>
+                <a:latin typeface="Calibri" pitchFamily="34" charset="0"/>
+                <a:ea typeface="Calibri" pitchFamily="34" charset="-122"/>
+                <a:cs typeface="Calibri" pitchFamily="34" charset="-120"/>
+              </a:rPr>
+              <a:t>The overlay chart everyone believes: cheap gas killed the sedan. The regression: levels r-squared 0.007, differenced 0.003. Truck share is a monotone trend, gas price oscillates; the co-movement is visual, not statistical. Same audit later killed the cheap-credit story (levels 0.57, differenced not significant).</a:t>
+            </a:r>
+            <a:endParaRPr lang="en-US" sz="1450" dirty="0"/>
+          </a:p>
+        </p:txBody>
+      </p:sp>
+      <p:sp>
+        <p:nvSpPr>
+          <p:cNvPr id="5" name="Text 2"/>
+          <p:cNvSpPr txBox="1"/>
+          <p:nvPr/>
+        </p:nvSpPr>
+        <p:spPr>
+          <a:xfrm>
+            <a:off x="502920" y="6446520"/>
+            <a:ext cx="11155680" cy="292608"/>
+          </a:xfrm>
+          <a:prstGeom prst="rect">
+            <a:avLst/>
+          </a:prstGeom>
+          <a:noFill/>
+          <a:ln/>
+        </p:spPr>
+        <p:txBody>
+          <a:bodyPr wrap="square" lIns="0" tIns="0" rIns="0" bIns="0" rtlCol="0" anchor="ctr"/>
+          <a:lstStyle/>
+          <a:p>
+            <a:pPr indent="0" marL="0">
+              <a:buNone/>
+            </a:pPr>
+            <a:r>
+              <a:rPr lang="en-US" sz="1000" dirty="0">
+                <a:solidFill>
+                  <a:srgbClr val="6E6C66"/>
+                </a:solidFill>
+                <a:latin typeface="Calibri" pitchFamily="34" charset="0"/>
+                <a:ea typeface="Calibri" pitchFamily="34" charset="-122"/>
+                <a:cs typeface="Calibri" pitchFamily="34" charset="-120"/>
+              </a:rPr>
+              <a:t>1976-2024 annual, real gas price vs truck production share; reports/10_statistics.md section 4.</a:t>
+            </a:r>
+            <a:endParaRPr lang="en-US" sz="1000" dirty="0"/>
+          </a:p>
+        </p:txBody>
+      </p:sp>
+    </p:spTree>
+  </p:cSld>
+  <p:clrMapOvr>
+    <a:masterClrMapping/>
+  </p:clrMapOvr>
+</p:sld>
+</file>
+
+<file path=ppt/slides/slide17.xml><?xml version="1.0" encoding="utf-8"?>
+<p:sld xmlns:a="http://schemas.openxmlformats.org/drawingml/2006/main" xmlns:r="http://schemas.openxmlformats.org/officeDocument/2006/relationships" xmlns:p="http://schemas.openxmlformats.org/presentationml/2006/main">
+  <p:cSld name="Slide 17">
+    <p:spTree>
+      <p:nvGrpSpPr>
+        <p:cNvPr id="1" name=""/>
+        <p:cNvGrpSpPr/>
+        <p:nvPr/>
+      </p:nvGrpSpPr>
+      <p:grpSpPr>
+        <a:xfrm>
+          <a:off x="0" y="0"/>
+          <a:ext cx="0" cy="0"/>
+          <a:chOff x="0" y="0"/>
+          <a:chExt cx="0" cy="0"/>
+        </a:xfrm>
+      </p:grpSpPr>
+      <p:sp>
+        <p:nvSpPr>
+          <p:cNvPr id="2" name="Text 0"/>
+          <p:cNvSpPr txBox="1"/>
+          <p:nvPr/>
+        </p:nvSpPr>
+        <p:spPr>
+          <a:xfrm>
+            <a:off x="502920" y="292608"/>
+            <a:ext cx="11155680" cy="685800"/>
+          </a:xfrm>
+          <a:prstGeom prst="rect">
+            <a:avLst/>
+          </a:prstGeom>
+          <a:noFill/>
+          <a:ln/>
+        </p:spPr>
+        <p:txBody>
+          <a:bodyPr wrap="square" lIns="0" tIns="0" rIns="0" bIns="0" rtlCol="0" anchor="ctr"/>
+          <a:lstStyle/>
+          <a:p>
+            <a:pPr indent="0" marL="0">
+              <a:buNone/>
+            </a:pPr>
+            <a:r>
+              <a:rPr lang="en-US" sz="1300" b="1" dirty="0">
+                <a:solidFill>
+                  <a:srgbClr val="EB6834"/>
+                </a:solidFill>
+                <a:latin typeface="Calibri" pitchFamily="34" charset="0"/>
+                <a:ea typeface="Calibri" pitchFamily="34" charset="-122"/>
+                <a:cs typeface="Calibri" pitchFamily="34" charset="-120"/>
+              </a:rPr>
+              <a:t>BACKUP   </a:t>
+            </a:r>
+            <a:pPr indent="0" marL="0">
+              <a:buNone/>
+            </a:pPr>
+            <a:r>
+              <a:rPr lang="en-US" sz="2600" b="1" dirty="0">
+                <a:solidFill>
+                  <a:srgbClr val="0B0B0B"/>
+                </a:solidFill>
+                <a:latin typeface="Calibri" pitchFamily="34" charset="0"/>
+                <a:ea typeface="Calibri" pitchFamily="34" charset="-122"/>
+                <a:cs typeface="Calibri" pitchFamily="34" charset="-120"/>
+              </a:rPr>
+              <a:t>Buyers systematically choose better MPG than the catalog median</a:t>
+            </a:r>
+            <a:endParaRPr lang="en-US" sz="1300" dirty="0"/>
+          </a:p>
+        </p:txBody>
+      </p:sp>
+      <p:pic>
+        <p:nvPicPr>
+          <p:cNvPr id="3" name="Image 0" descr="C:\Users\Samson\Desktop\Homework\OS3180\Final Project\charts\fig17_distribution_shift.png">    </p:cNvPr>
+          <p:cNvPicPr>
+            <a:picLocks noChangeAspect="1"/>
+          </p:cNvPicPr>
+          <p:nvPr/>
+        </p:nvPicPr>
+        <p:blipFill>
+          <a:blip r:embed="rId1"/>
+          <a:stretch>
+            <a:fillRect/>
+          </a:stretch>
+        </p:blipFill>
+        <p:spPr>
+          <a:xfrm>
+            <a:off x="502920" y="1234440"/>
+            <a:ext cx="7498080" cy="3953533"/>
+          </a:xfrm>
+          <a:prstGeom prst="rect">
+            <a:avLst/>
+          </a:prstGeom>
+        </p:spPr>
+      </p:pic>
+      <p:sp>
+        <p:nvSpPr>
+          <p:cNvPr id="4" name="Text 1"/>
+          <p:cNvSpPr txBox="1"/>
+          <p:nvPr/>
+        </p:nvSpPr>
+        <p:spPr>
+          <a:xfrm>
+            <a:off x="8321040" y="1463040"/>
+            <a:ext cx="3337560" cy="4206240"/>
+          </a:xfrm>
+          <a:prstGeom prst="rect">
+            <a:avLst/>
+          </a:prstGeom>
+          <a:noFill/>
+          <a:ln/>
+        </p:spPr>
+        <p:txBody>
+          <a:bodyPr wrap="square" lIns="0" tIns="0" rIns="0" bIns="0" rtlCol="0" anchor="ctr"/>
+          <a:lstStyle/>
+          <a:p>
+            <a:pPr indent="0" marL="0">
+              <a:buNone/>
+            </a:pPr>
+            <a:r>
+              <a:rPr lang="en-US" sz="1450" dirty="0">
+                <a:solidFill>
+                  <a:srgbClr val="0B0B0B"/>
+                </a:solidFill>
+                <a:latin typeface="Calibri" pitchFamily="34" charset="0"/>
+                <a:ea typeface="Calibri" pitchFamily="34" charset="-122"/>
+                <a:cs typeface="Calibri" pitchFamily="34" charset="-120"/>
+              </a:rPr>
+              <a:t>Offered vs production-weighted MPG distributions, MY2024: KS D = 0.211, a 3.5-MPG median shift in the efficient direction, Wasserstein distance 3.06 MPG. And production is concentrated: Gini 0.731, with 23% of carlines carrying 80% of volume.</a:t>
+            </a:r>
+            <a:endParaRPr lang="en-US" sz="1450" dirty="0"/>
+          </a:p>
+        </p:txBody>
+      </p:sp>
+      <p:sp>
+        <p:nvSpPr>
+          <p:cNvPr id="5" name="Text 2"/>
+          <p:cNvSpPr txBox="1"/>
+          <p:nvPr/>
+        </p:nvSpPr>
+        <p:spPr>
+          <a:xfrm>
+            <a:off x="502920" y="6446520"/>
+            <a:ext cx="11155680" cy="292608"/>
+          </a:xfrm>
+          <a:prstGeom prst="rect">
+            <a:avLst/>
+          </a:prstGeom>
+          <a:noFill/>
+          <a:ln/>
+        </p:spPr>
+        <p:txBody>
+          <a:bodyPr wrap="square" lIns="0" tIns="0" rIns="0" bIns="0" rtlCol="0" anchor="ctr"/>
+          <a:lstStyle/>
+          <a:p>
+            <a:pPr indent="0" marL="0">
+              <a:buNone/>
+            </a:pPr>
+            <a:r>
+              <a:rPr lang="en-US" sz="1000" dirty="0">
+                <a:solidFill>
+                  <a:srgbClr val="6E6C66"/>
+                </a:solidFill>
+                <a:latin typeface="Calibri" pitchFamily="34" charset="0"/>
+                <a:ea typeface="Calibri" pitchFamily="34" charset="-122"/>
+                <a:cs typeface="Calibri" pitchFamily="34" charset="-120"/>
+              </a:rPr>
+              <a:t>MY2024 combustion model types; weighted ECDFs and Lorenz curve; reports/10_statistics.md section 2.</a:t>
+            </a:r>
+            <a:endParaRPr lang="en-US" sz="1000" dirty="0"/>
+          </a:p>
+        </p:txBody>
+      </p:sp>
+    </p:spTree>
+  </p:cSld>
+  <p:clrMapOvr>
+    <a:masterClrMapping/>
+  </p:clrMapOvr>
+</p:sld>
+</file>
+
+<file path=ppt/slides/slide18.xml><?xml version="1.0" encoding="utf-8"?>
+<p:sld xmlns:a="http://schemas.openxmlformats.org/drawingml/2006/main" xmlns:r="http://schemas.openxmlformats.org/officeDocument/2006/relationships" xmlns:p="http://schemas.openxmlformats.org/presentationml/2006/main">
+  <p:cSld name="Slide 18">
+    <p:spTree>
+      <p:nvGrpSpPr>
+        <p:cNvPr id="1" name=""/>
+        <p:cNvGrpSpPr/>
+        <p:nvPr/>
+      </p:nvGrpSpPr>
+      <p:grpSpPr>
+        <a:xfrm>
+          <a:off x="0" y="0"/>
+          <a:ext cx="0" cy="0"/>
+          <a:chOff x="0" y="0"/>
+          <a:chExt cx="0" cy="0"/>
+        </a:xfrm>
+      </p:grpSpPr>
+      <p:sp>
+        <p:nvSpPr>
+          <p:cNvPr id="2" name="Text 0"/>
+          <p:cNvSpPr txBox="1"/>
+          <p:nvPr/>
+        </p:nvSpPr>
+        <p:spPr>
+          <a:xfrm>
+            <a:off x="502920" y="292608"/>
+            <a:ext cx="11155680" cy="685800"/>
+          </a:xfrm>
+          <a:prstGeom prst="rect">
+            <a:avLst/>
+          </a:prstGeom>
+          <a:noFill/>
+          <a:ln/>
+        </p:spPr>
+        <p:txBody>
+          <a:bodyPr wrap="square" lIns="0" tIns="0" rIns="0" bIns="0" rtlCol="0" anchor="ctr"/>
+          <a:lstStyle/>
+          <a:p>
+            <a:pPr indent="0" marL="0">
+              <a:buNone/>
+            </a:pPr>
+            <a:r>
+              <a:rPr lang="en-US" sz="1300" b="1" dirty="0">
+                <a:solidFill>
+                  <a:srgbClr val="EB6834"/>
+                </a:solidFill>
+                <a:latin typeface="Calibri" pitchFamily="34" charset="0"/>
+                <a:ea typeface="Calibri" pitchFamily="34" charset="-122"/>
+                <a:cs typeface="Calibri" pitchFamily="34" charset="-120"/>
+              </a:rPr>
+              <a:t>BACKUP   </a:t>
+            </a:r>
+            <a:pPr indent="0" marL="0">
+              <a:buNone/>
+            </a:pPr>
+            <a:r>
+              <a:rPr lang="en-US" sz="2600" b="1" dirty="0">
+                <a:solidFill>
+                  <a:srgbClr val="0B0B0B"/>
+                </a:solidFill>
+                <a:latin typeface="Calibri" pitchFamily="34" charset="0"/>
+                <a:ea typeface="Calibri" pitchFamily="34" charset="-122"/>
+                <a:cs typeface="Calibri" pitchFamily="34" charset="-120"/>
+              </a:rPr>
+              <a:t>Sticker history: the era when electric meant expensive</a:t>
+            </a:r>
+            <a:endParaRPr lang="en-US" sz="1300" dirty="0"/>
+          </a:p>
+        </p:txBody>
+      </p:sp>
+      <p:pic>
+        <p:nvPicPr>
+          <p:cNvPr id="3" name="Image 0" descr="C:\Users\Samson\Desktop\Homework\OS3180\Final Project\charts\fig41_msrp_by_powertrain.png">    </p:cNvPr>
+          <p:cNvPicPr>
+            <a:picLocks noChangeAspect="1"/>
+          </p:cNvPicPr>
+          <p:nvPr/>
+        </p:nvPicPr>
+        <p:blipFill>
+          <a:blip r:embed="rId1"/>
+          <a:stretch>
+            <a:fillRect/>
+          </a:stretch>
+        </p:blipFill>
+        <p:spPr>
+          <a:xfrm>
+            <a:off x="502920" y="1234440"/>
+            <a:ext cx="7498080" cy="4362519"/>
+          </a:xfrm>
+          <a:prstGeom prst="rect">
+            <a:avLst/>
+          </a:prstGeom>
+        </p:spPr>
+      </p:pic>
+      <p:sp>
+        <p:nvSpPr>
+          <p:cNvPr id="4" name="Text 1"/>
+          <p:cNvSpPr txBox="1"/>
+          <p:nvPr/>
+        </p:nvSpPr>
+        <p:spPr>
+          <a:xfrm>
+            <a:off x="8321040" y="1463040"/>
+            <a:ext cx="3337560" cy="4206240"/>
+          </a:xfrm>
+          <a:prstGeom prst="rect">
+            <a:avLst/>
+          </a:prstGeom>
+          <a:noFill/>
+          <a:ln/>
+        </p:spPr>
+        <p:txBody>
+          <a:bodyPr wrap="square" lIns="0" tIns="0" rIns="0" bIns="0" rtlCol="0" anchor="ctr"/>
+          <a:lstStyle/>
+          <a:p>
+            <a:pPr indent="0" marL="0">
+              <a:buNone/>
+            </a:pPr>
+            <a:r>
+              <a:rPr lang="en-US" sz="1450" dirty="0">
+                <a:solidFill>
+                  <a:srgbClr val="0B0B0B"/>
+                </a:solidFill>
+                <a:latin typeface="Calibri" pitchFamily="34" charset="0"/>
+                <a:ea typeface="Calibri" pitchFamily="34" charset="-122"/>
+                <a:cs typeface="Calibri" pitchFamily="34" charset="-120"/>
+              </a:rPr>
+              <a:t>Trim-level MSRPs, 2015-2020 (17.5k trims): hybrids were the budget powertrain at $24-39k, gasoline drifted $35-40k, the hydrogen Mirai sat at $58.5k, and the BEV median swung $29-60k on a catalog of 11-31 trims a year. Pairs with the July 2026 transaction picture: the EV premium has compressed to $6,477.</a:t>
+            </a:r>
+            <a:endParaRPr lang="en-US" sz="1450" dirty="0"/>
+          </a:p>
+        </p:txBody>
+      </p:sp>
+      <p:sp>
+        <p:nvSpPr>
+          <p:cNvPr id="5" name="Text 2"/>
+          <p:cNvSpPr txBox="1"/>
+          <p:nvPr/>
+        </p:nvSpPr>
+        <p:spPr>
+          <a:xfrm>
+            <a:off x="502920" y="6446520"/>
+            <a:ext cx="11155680" cy="292608"/>
+          </a:xfrm>
+          <a:prstGeom prst="rect">
+            <a:avLst/>
+          </a:prstGeom>
+          <a:noFill/>
+          <a:ln/>
+        </p:spPr>
+        <p:txBody>
+          <a:bodyPr wrap="square" lIns="0" tIns="0" rIns="0" bIns="0" rtlCol="0" anchor="ctr"/>
+          <a:lstStyle/>
+          <a:p>
+            <a:pPr indent="0" marL="0">
+              <a:buNone/>
+            </a:pPr>
+            <a:r>
+              <a:rPr lang="en-US" sz="1000" dirty="0">
+                <a:solidFill>
+                  <a:srgbClr val="6E6C66"/>
+                </a:solidFill>
+                <a:latin typeface="Calibri" pitchFamily="34" charset="0"/>
+                <a:ea typeface="Calibri" pitchFamily="34" charset="-122"/>
+                <a:cs typeface="Calibri" pitchFamily="34" charset="-120"/>
+              </a:rPr>
+              <a:t>CarAPI sample data feed, powertrain classified via fueleconomy.gov join (80.1%); reports/28_msrp.md.</a:t>
+            </a:r>
+            <a:endParaRPr lang="en-US" sz="1000" dirty="0"/>
+          </a:p>
+        </p:txBody>
+      </p:sp>
+    </p:spTree>
+  </p:cSld>
+  <p:clrMapOvr>
+    <a:masterClrMapping/>
+  </p:clrMapOvr>
+</p:sld>
+</file>
+
+<file path=ppt/slides/slide19.xml><?xml version="1.0" encoding="utf-8"?>
+<p:sld xmlns:a="http://schemas.openxmlformats.org/drawingml/2006/main" xmlns:r="http://schemas.openxmlformats.org/officeDocument/2006/relationships" xmlns:p="http://schemas.openxmlformats.org/presentationml/2006/main">
+  <p:cSld name="Slide 19">
+    <p:spTree>
+      <p:nvGrpSpPr>
+        <p:cNvPr id="1" name=""/>
+        <p:cNvGrpSpPr/>
+        <p:nvPr/>
+      </p:nvGrpSpPr>
+      <p:grpSpPr>
+        <a:xfrm>
+          <a:off x="0" y="0"/>
+          <a:ext cx="0" cy="0"/>
+          <a:chOff x="0" y="0"/>
+          <a:chExt cx="0" cy="0"/>
+        </a:xfrm>
+      </p:grpSpPr>
+      <p:sp>
+        <p:nvSpPr>
+          <p:cNvPr id="2" name="Text 0"/>
+          <p:cNvSpPr txBox="1"/>
+          <p:nvPr/>
+        </p:nvSpPr>
+        <p:spPr>
+          <a:xfrm>
+            <a:off x="502920" y="292608"/>
+            <a:ext cx="11155680" cy="685800"/>
+          </a:xfrm>
+          <a:prstGeom prst="rect">
+            <a:avLst/>
+          </a:prstGeom>
+          <a:noFill/>
+          <a:ln/>
+        </p:spPr>
+        <p:txBody>
+          <a:bodyPr wrap="square" lIns="0" tIns="0" rIns="0" bIns="0" rtlCol="0" anchor="ctr"/>
+          <a:lstStyle/>
+          <a:p>
+            <a:pPr indent="0" marL="0">
+              <a:buNone/>
+            </a:pPr>
+            <a:r>
+              <a:rPr lang="en-US" sz="1300" b="1" dirty="0">
+                <a:solidFill>
+                  <a:srgbClr val="EB6834"/>
+                </a:solidFill>
+                <a:latin typeface="Calibri" pitchFamily="34" charset="0"/>
+                <a:ea typeface="Calibri" pitchFamily="34" charset="-122"/>
+                <a:cs typeface="Calibri" pitchFamily="34" charset="-120"/>
+              </a:rPr>
+              <a:t>BACKUP   </a:t>
+            </a:r>
+            <a:pPr indent="0" marL="0">
+              <a:buNone/>
+            </a:pPr>
+            <a:r>
+              <a:rPr lang="en-US" sz="2600" b="1" dirty="0">
+                <a:solidFill>
+                  <a:srgbClr val="0B0B0B"/>
+                </a:solidFill>
+                <a:latin typeface="Calibri" pitchFamily="34" charset="0"/>
+                <a:ea typeface="Calibri" pitchFamily="34" charset="-122"/>
+                <a:cs typeface="Calibri" pitchFamily="34" charset="-120"/>
+              </a:rPr>
+              <a:t>Driving on electrons has cost half as much for a decade</a:t>
+            </a:r>
+            <a:endParaRPr lang="en-US" sz="1300" dirty="0"/>
+          </a:p>
+        </p:txBody>
+      </p:sp>
+      <p:pic>
+        <p:nvPicPr>
+          <p:cNvPr id="3" name="Image 0" descr="C:\Users\Samson\Desktop\Homework\OS3180\Final Project\charts\fig33_cost_trends.png">    </p:cNvPr>
+          <p:cNvPicPr>
+            <a:picLocks noChangeAspect="1"/>
+          </p:cNvPicPr>
+          <p:nvPr/>
+        </p:nvPicPr>
+        <p:blipFill>
+          <a:blip r:embed="rId1"/>
+          <a:stretch>
+            <a:fillRect/>
+          </a:stretch>
+        </p:blipFill>
+        <p:spPr>
+          <a:xfrm>
+            <a:off x="502920" y="1234440"/>
+            <a:ext cx="7498080" cy="4362519"/>
+          </a:xfrm>
+          <a:prstGeom prst="rect">
+            <a:avLst/>
+          </a:prstGeom>
+        </p:spPr>
+      </p:pic>
+      <p:sp>
+        <p:nvSpPr>
+          <p:cNvPr id="4" name="Text 1"/>
+          <p:cNvSpPr txBox="1"/>
+          <p:nvPr/>
+        </p:nvSpPr>
+        <p:spPr>
+          <a:xfrm>
+            <a:off x="8321040" y="1463040"/>
+            <a:ext cx="3337560" cy="4206240"/>
+          </a:xfrm>
+          <a:prstGeom prst="rect">
+            <a:avLst/>
+          </a:prstGeom>
+          <a:noFill/>
+          <a:ln/>
+        </p:spPr>
+        <p:txBody>
+          <a:bodyPr wrap="square" lIns="0" tIns="0" rIns="0" bIns="0" rtlCol="0" anchor="ctr"/>
+          <a:lstStyle/>
+          <a:p>
+            <a:pPr indent="0" marL="0">
+              <a:buNone/>
+            </a:pPr>
+            <a:r>
+              <a:rPr lang="en-US" sz="1450" dirty="0">
+                <a:solidFill>
+                  <a:srgbClr val="0B0B0B"/>
+                </a:solidFill>
+                <a:latin typeface="Calibri" pitchFamily="34" charset="0"/>
+                <a:ea typeface="Calibri" pitchFamily="34" charset="-122"/>
+                <a:cs typeface="Calibri" pitchFamily="34" charset="-120"/>
+              </a:rPr>
+              <a:t>Median energy cost per mile at each year's national prices: BEV around 5-7 cents, gasoline 10-19 cents. 2024 gap: $1,007 vs $2,463 per 15,000 miles. The gap narrows late as electricity prices climb and gas cars improve; the price-shock exposure chart (slide 12) is the companion.</a:t>
+            </a:r>
+            <a:endParaRPr lang="en-US" sz="1450" dirty="0"/>
+          </a:p>
+        </p:txBody>
+      </p:sp>
+      <p:sp>
+        <p:nvSpPr>
+          <p:cNvPr id="5" name="Text 2"/>
+          <p:cNvSpPr txBox="1"/>
+          <p:nvPr/>
+        </p:nvSpPr>
+        <p:spPr>
+          <a:xfrm>
+            <a:off x="502920" y="6446520"/>
+            <a:ext cx="11155680" cy="292608"/>
+          </a:xfrm>
+          <a:prstGeom prst="rect">
+            <a:avLst/>
+          </a:prstGeom>
+          <a:noFill/>
+          <a:ln/>
+        </p:spPr>
+        <p:txBody>
+          <a:bodyPr wrap="square" lIns="0" tIns="0" rIns="0" bIns="0" rtlCol="0" anchor="ctr"/>
+          <a:lstStyle/>
+          <a:p>
+            <a:pPr indent="0" marL="0">
+              <a:buNone/>
+            </a:pPr>
+            <a:r>
+              <a:rPr lang="en-US" sz="1000" dirty="0">
+                <a:solidFill>
+                  <a:srgbClr val="6E6C66"/>
+                </a:solidFill>
+                <a:latin typeface="Calibri" pitchFamily="34" charset="0"/>
+                <a:ea typeface="Calibri" pitchFamily="34" charset="-122"/>
+                <a:cs typeface="Calibri" pitchFamily="34" charset="-120"/>
+              </a:rPr>
+              <a:t>fueleconomy.gov catalog x BLS prices via FRED; reports/23_powertrain.md.</a:t>
+            </a:r>
+            <a:endParaRPr lang="en-US" sz="1000" dirty="0"/>
+          </a:p>
+        </p:txBody>
+      </p:sp>
+    </p:spTree>
+  </p:cSld>
+  <p:clrMapOvr>
+    <a:masterClrMapping/>
+  </p:clrMapOvr>
+</p:sld>
+</file>
+
 <file path=ppt/slides/slide2.xml><?xml version="1.0" encoding="utf-8"?>
 <p:sld xmlns:a="http://schemas.openxmlformats.org/drawingml/2006/main" xmlns:r="http://schemas.openxmlformats.org/officeDocument/2006/relationships" xmlns:p="http://schemas.openxmlformats.org/presentationml/2006/main">
   <p:cSld name="Slide 2">
@@ -6252,6 +7686,186 @@
                 <a:cs typeface="Calibri" pitchFamily="34" charset="-120"/>
               </a:rPr>
               <a:t>Costs: fueleconomy.gov catalog efficiency x BLS national prices (reports/23_powertrain.md). ATP: Kelley Blue Book / Cox Automotive, July 2026.</a:t>
+            </a:r>
+            <a:endParaRPr lang="en-US" sz="1000" dirty="0"/>
+          </a:p>
+        </p:txBody>
+      </p:sp>
+    </p:spTree>
+  </p:cSld>
+  <p:clrMapOvr>
+    <a:masterClrMapping/>
+  </p:clrMapOvr>
+</p:sld>
+</file>
+
+<file path=ppt/slides/slide20.xml><?xml version="1.0" encoding="utf-8"?>
+<p:sld xmlns:a="http://schemas.openxmlformats.org/drawingml/2006/main" xmlns:r="http://schemas.openxmlformats.org/officeDocument/2006/relationships" xmlns:p="http://schemas.openxmlformats.org/presentationml/2006/main">
+  <p:cSld name="Slide 20">
+    <p:spTree>
+      <p:nvGrpSpPr>
+        <p:cNvPr id="1" name=""/>
+        <p:cNvGrpSpPr/>
+        <p:nvPr/>
+      </p:nvGrpSpPr>
+      <p:grpSpPr>
+        <a:xfrm>
+          <a:off x="0" y="0"/>
+          <a:ext cx="0" cy="0"/>
+          <a:chOff x="0" y="0"/>
+          <a:chExt cx="0" cy="0"/>
+        </a:xfrm>
+      </p:grpSpPr>
+      <p:sp>
+        <p:nvSpPr>
+          <p:cNvPr id="2" name="Text 0"/>
+          <p:cNvSpPr txBox="1"/>
+          <p:nvPr/>
+        </p:nvSpPr>
+        <p:spPr>
+          <a:xfrm>
+            <a:off x="502920" y="292608"/>
+            <a:ext cx="11155680" cy="685800"/>
+          </a:xfrm>
+          <a:prstGeom prst="rect">
+            <a:avLst/>
+          </a:prstGeom>
+          <a:noFill/>
+          <a:ln/>
+        </p:spPr>
+        <p:txBody>
+          <a:bodyPr wrap="square" lIns="0" tIns="0" rIns="0" bIns="0" rtlCol="0" anchor="ctr"/>
+          <a:lstStyle/>
+          <a:p>
+            <a:pPr indent="0" marL="0">
+              <a:buNone/>
+            </a:pPr>
+            <a:r>
+              <a:rPr lang="en-US" sz="1300" b="1" dirty="0">
+                <a:solidFill>
+                  <a:srgbClr val="EB6834"/>
+                </a:solidFill>
+                <a:latin typeface="Calibri" pitchFamily="34" charset="0"/>
+                <a:ea typeface="Calibri" pitchFamily="34" charset="-122"/>
+                <a:cs typeface="Calibri" pitchFamily="34" charset="-120"/>
+              </a:rPr>
+              <a:t>BACKUP   </a:t>
+            </a:r>
+            <a:pPr indent="0" marL="0">
+              <a:buNone/>
+            </a:pPr>
+            <a:r>
+              <a:rPr lang="en-US" sz="2600" b="1" dirty="0">
+                <a:solidFill>
+                  <a:srgbClr val="0B0B0B"/>
+                </a:solidFill>
+                <a:latin typeface="Calibri" pitchFamily="34" charset="0"/>
+                <a:ea typeface="Calibri" pitchFamily="34" charset="-122"/>
+                <a:cs typeface="Calibri" pitchFamily="34" charset="-120"/>
+              </a:rPr>
+              <a:t>Hold design constant and the trend says ~44 MPG by 2045</a:t>
+            </a:r>
+            <a:endParaRPr lang="en-US" sz="1300" dirty="0"/>
+          </a:p>
+        </p:txBody>
+      </p:sp>
+      <p:pic>
+        <p:nvPicPr>
+          <p:cNvPr id="3" name="Image 0" descr="C:\Users\Samson\Desktop\Homework\OS3180\Final Project\charts\fig42_productivity_projection.png">    </p:cNvPr>
+          <p:cNvPicPr>
+            <a:picLocks noChangeAspect="1"/>
+          </p:cNvPicPr>
+          <p:nvPr/>
+        </p:nvPicPr>
+        <p:blipFill>
+          <a:blip r:embed="rId1"/>
+          <a:stretch>
+            <a:fillRect/>
+          </a:stretch>
+        </p:blipFill>
+        <p:spPr>
+          <a:xfrm>
+            <a:off x="502920" y="1234440"/>
+            <a:ext cx="7498080" cy="4362519"/>
+          </a:xfrm>
+          <a:prstGeom prst="rect">
+            <a:avLst/>
+          </a:prstGeom>
+        </p:spPr>
+      </p:pic>
+      <p:sp>
+        <p:nvSpPr>
+          <p:cNvPr id="4" name="Text 1"/>
+          <p:cNvSpPr txBox="1"/>
+          <p:nvPr/>
+        </p:nvSpPr>
+        <p:spPr>
+          <a:xfrm>
+            <a:off x="8321040" y="1463040"/>
+            <a:ext cx="3337560" cy="4206240"/>
+          </a:xfrm>
+          <a:prstGeom prst="rect">
+            <a:avLst/>
+          </a:prstGeom>
+          <a:noFill/>
+          <a:ln/>
+        </p:spPr>
+        <p:txBody>
+          <a:bodyPr wrap="square" lIns="0" tIns="0" rIns="0" bIns="0" rtlCol="0" anchor="ctr"/>
+          <a:lstStyle/>
+          <a:p>
+            <a:pPr indent="0" marL="0">
+              <a:buNone/>
+            </a:pPr>
+            <a:r>
+              <a:rPr lang="en-US" sz="1450" dirty="0">
+                <a:solidFill>
+                  <a:srgbClr val="0B0B0B"/>
+                </a:solidFill>
+                <a:latin typeface="Calibri" pitchFamily="34" charset="0"/>
+                <a:ea typeface="Calibri" pitchFamily="34" charset="-122"/>
+                <a:cs typeface="Calibri" pitchFamily="34" charset="-120"/>
+              </a:rPr>
+              <a:t>Re-express each year's fleet MPG at constant 2024 weight and horsepower using this deck's own elasticities: the 1987-2004 trough vanishes and technology productivity grows +1.94%/yr for fifty years (R-squared 0.984). Projected forward: about 35 by 2035 and 40-44 by 2045, bracketed by the 50-year and 2005+ rates. Caveats: 2024 elasticities assumed stable; EV mix folded in; log-linear extrapolation with no physics ceiling.</a:t>
+            </a:r>
+            <a:endParaRPr lang="en-US" sz="1450" dirty="0"/>
+          </a:p>
+        </p:txBody>
+      </p:sp>
+      <p:sp>
+        <p:nvSpPr>
+          <p:cNvPr id="5" name="Text 2"/>
+          <p:cNvSpPr txBox="1"/>
+          <p:nvPr/>
+        </p:nvSpPr>
+        <p:spPr>
+          <a:xfrm>
+            <a:off x="502920" y="6446520"/>
+            <a:ext cx="11155680" cy="292608"/>
+          </a:xfrm>
+          <a:prstGeom prst="rect">
+            <a:avLst/>
+          </a:prstGeom>
+          <a:noFill/>
+          <a:ln/>
+        </p:spPr>
+        <p:txBody>
+          <a:bodyPr wrap="square" lIns="0" tIns="0" rIns="0" bIns="0" rtlCol="0" anchor="ctr"/>
+          <a:lstStyle/>
+          <a:p>
+            <a:pPr indent="0" marL="0">
+              <a:buNone/>
+            </a:pPr>
+            <a:r>
+              <a:rPr lang="en-US" sz="1000" dirty="0">
+                <a:solidFill>
+                  <a:srgbClr val="6E6C66"/>
+                </a:solidFill>
+                <a:latin typeface="Calibri" pitchFamily="34" charset="0"/>
+                <a:ea typeface="Calibri" pitchFamily="34" charset="-122"/>
+                <a:cs typeface="Calibri" pitchFamily="34" charset="-120"/>
+              </a:rPr>
+              <a:t>outputs/productivity.csv, reports/29_productivity.md; band = slope 95% CI, scenario uncertainty dominates.</a:t>
             </a:r>
             <a:endParaRPr lang="en-US" sz="1000" dirty="0"/>
           </a:p>

</xml_diff>

<commit_message>
Add class-level and EV productivity breakouts (figs 43-44)
Stage 30: fig42's design normalization per EPA Trends vehicle class, each
at its own constant 2024 weight/HP. Every class grows 2.0-2.6%/yr with
log-linear R^2 0.93-0.99; Car SUV fastest, pickups slowest. EV version
uses the Trends Tesla series (the only production-weighted EV series with
weight) at the BEV model's -0.975 elasticity: +2.36%/yr, inside the same
band. No coupe class exists in Trends; recorded rather than approximated.

Co-Authored-By: Claude Fable 5 <noreply@anthropic.com>
</commit_message>
<xml_diff>
--- a/MPG Prediction Deck.pptx
+++ b/MPG Prediction Deck.pptx
@@ -4,6 +4,9 @@
   <p:sldMasterIdLst>
     <p:sldMasterId id="2147483648" r:id="rId1"/>
   </p:sldMasterIdLst>
+  <p:notesMasterIdLst>
+    <p:notesMasterId r:id="rId22"/>
+  </p:notesMasterIdLst>
   <p:sldIdLst>
     <p:sldId id="256" r:id="rId2"/>
     <p:sldId id="257" r:id="rId3"/>
@@ -26,9 +29,6 @@
     <p:sldId id="274" r:id="rId20"/>
     <p:sldId id="275" r:id="rId21"/>
   </p:sldIdLst>
-  <p:notesMasterIdLst>
-    <p:notesMasterId r:id="rId22"/>
-  </p:notesMasterIdLst>
   <p:sldSz cx="12192000" cy="6858000"/>
   <p:notesSz cx="6858000" cy="12192000"/>
   <p:defaultTextStyle>
@@ -123,6 +123,11 @@
       </a:defRPr>
     </a:lvl9pPr>
   </p:defaultTextStyle>
+  <p:extLst>
+    <p:ext uri="{EFAFB233-063F-42B5-8137-9DF3F51BA10A}">
+      <p15:sldGuideLst xmlns:p15="http://schemas.microsoft.com/office/powerpoint/2012/main"/>
+    </p:ext>
+  </p:extLst>
 </p:presentation>
 </file>
 
@@ -148,234 +153,10 @@
           <a:chExt cx="0" cy="0"/>
         </a:xfrm>
       </p:grpSpPr>
-      <p:sp>
-        <p:nvSpPr>
-          <p:cNvPr id="2" name="Header Placeholder 1"/>
-          <p:cNvSpPr>
-            <a:spLocks noGrp="1"/>
-          </p:cNvSpPr>
-          <p:nvPr>
-            <p:ph type="hdr" sz="quarter"/>
-          </p:nvPr>
-        </p:nvSpPr>
-        <p:spPr>
-          <a:xfrm>
-            <a:off x="0" y="0"/>
-            <a:ext cx="2971800" cy="458788"/>
-          </a:xfrm>
-          <a:prstGeom prst="rect">
-            <a:avLst/>
-          </a:prstGeom>
-        </p:spPr>
-        <p:txBody>
-          <a:bodyPr vert="horz" lIns="91440" tIns="45720" rIns="91440" bIns="45720" rtlCol="0"/>
-          <a:lstStyle>
-            <a:lvl1pPr algn="l">
-              <a:defRPr sz="1200"/>
-            </a:lvl1pPr>
-          </a:lstStyle>
-          <a:p>
-            <a:endParaRPr lang="en-US"/>
-          </a:p>
-        </p:txBody>
-      </p:sp>
-      <p:sp>
-        <p:nvSpPr>
-          <p:cNvPr id="3" name="Date Placeholder 2"/>
-          <p:cNvSpPr>
-            <a:spLocks noGrp="1"/>
-          </p:cNvSpPr>
-          <p:nvPr>
-            <p:ph type="dt" idx="1"/>
-          </p:nvPr>
-        </p:nvSpPr>
-        <p:spPr>
-          <a:xfrm>
-            <a:off x="3884613" y="0"/>
-            <a:ext cx="2971800" cy="458788"/>
-          </a:xfrm>
-          <a:prstGeom prst="rect">
-            <a:avLst/>
-          </a:prstGeom>
-        </p:spPr>
-        <p:txBody>
-          <a:bodyPr vert="horz" lIns="91440" tIns="45720" rIns="91440" bIns="45720" rtlCol="0"/>
-          <a:lstStyle>
-            <a:lvl1pPr algn="r">
-              <a:defRPr sz="1200"/>
-            </a:lvl1pPr>
-          </a:lstStyle>
-          <a:p>
-            <a:fld id="{5282F153-3F37-0F45-9E97-73ACFA13230C}" type="datetimeFigureOut">
-              <a:rPr lang="en-US"/>
-              <a:t>7/23/19</a:t>
-            </a:fld>
-            <a:endParaRPr lang="en-US"/>
-          </a:p>
-        </p:txBody>
-      </p:sp>
-      <p:sp>
-        <p:nvSpPr>
-          <p:cNvPr id="4" name="Slide Image Placeholder 3"/>
-          <p:cNvSpPr>
-            <a:spLocks noGrp="1" noRot="1" noChangeAspect="1"/>
-          </p:cNvSpPr>
-          <p:nvPr>
-            <p:ph type="sldImg" idx="2"/>
-          </p:nvPr>
-        </p:nvSpPr>
-        <p:spPr>
-          <a:xfrm>
-            <a:off x="685800" y="1143000"/>
-            <a:ext cx="5486400" cy="3086100"/>
-          </a:xfrm>
-          <a:prstGeom prst="rect">
-            <a:avLst/>
-          </a:prstGeom>
-          <a:noFill/>
-          <a:ln w="12700">
-            <a:solidFill>
-              <a:prstClr val="black"/>
-            </a:solidFill>
-          </a:ln>
-        </p:spPr>
-        <p:txBody>
-          <a:bodyPr vert="horz" lIns="91440" tIns="45720" rIns="91440" bIns="45720" rtlCol="0" anchor="ctr"/>
-          <a:lstStyle/>
-          <a:p>
-            <a:endParaRPr lang="en-US"/>
-          </a:p>
-        </p:txBody>
-      </p:sp>
-      <p:sp>
-        <p:nvSpPr>
-          <p:cNvPr id="5" name="Notes Placeholder 4"/>
-          <p:cNvSpPr>
-            <a:spLocks noGrp="1"/>
-          </p:cNvSpPr>
-          <p:nvPr>
-            <p:ph type="body" sz="quarter" idx="3"/>
-          </p:nvPr>
-        </p:nvSpPr>
-        <p:spPr>
-          <a:xfrm>
-            <a:off x="685800" y="4400550"/>
-            <a:ext cx="5486400" cy="3600450"/>
-          </a:xfrm>
-          <a:prstGeom prst="rect">
-            <a:avLst/>
-          </a:prstGeom>
-        </p:spPr>
-        <p:txBody>
-          <a:bodyPr vert="horz" lIns="91440" tIns="45720" rIns="91440" bIns="45720" rtlCol="0"/>
-          <a:lstStyle/>
-          <a:p>
-            <a:pPr lvl="0"/>
-            <a:r>
-              <a:rPr lang="en-US"/>
-              <a:t>Click to edit Master text styles</a:t>
-            </a:r>
-          </a:p>
-          <a:p>
-            <a:pPr lvl="1"/>
-            <a:r>
-              <a:rPr lang="en-US"/>
-              <a:t>Second level</a:t>
-            </a:r>
-          </a:p>
-          <a:p>
-            <a:pPr lvl="2"/>
-            <a:r>
-              <a:rPr lang="en-US"/>
-              <a:t>Third level</a:t>
-            </a:r>
-          </a:p>
-          <a:p>
-            <a:pPr lvl="3"/>
-            <a:r>
-              <a:rPr lang="en-US"/>
-              <a:t>Fourth level</a:t>
-            </a:r>
-          </a:p>
-          <a:p>
-            <a:pPr lvl="4"/>
-            <a:r>
-              <a:rPr lang="en-US"/>
-              <a:t>Fifth level</a:t>
-            </a:r>
-          </a:p>
-        </p:txBody>
-      </p:sp>
-      <p:sp>
-        <p:nvSpPr>
-          <p:cNvPr id="6" name="Footer Placeholder 5"/>
-          <p:cNvSpPr>
-            <a:spLocks noGrp="1"/>
-          </p:cNvSpPr>
-          <p:nvPr>
-            <p:ph type="ftr" sz="quarter" idx="4"/>
-          </p:nvPr>
-        </p:nvSpPr>
-        <p:spPr>
-          <a:xfrm>
-            <a:off x="0" y="8685213"/>
-            <a:ext cx="2971800" cy="458787"/>
-          </a:xfrm>
-          <a:prstGeom prst="rect">
-            <a:avLst/>
-          </a:prstGeom>
-        </p:spPr>
-        <p:txBody>
-          <a:bodyPr vert="horz" lIns="91440" tIns="45720" rIns="91440" bIns="45720" rtlCol="0" anchor="b"/>
-          <a:lstStyle>
-            <a:lvl1pPr algn="l">
-              <a:defRPr sz="1200"/>
-            </a:lvl1pPr>
-          </a:lstStyle>
-          <a:p>
-            <a:endParaRPr lang="en-US"/>
-          </a:p>
-        </p:txBody>
-      </p:sp>
-      <p:sp>
-        <p:nvSpPr>
-          <p:cNvPr id="7" name="Slide Number Placeholder 6"/>
-          <p:cNvSpPr>
-            <a:spLocks noGrp="1"/>
-          </p:cNvSpPr>
-          <p:nvPr>
-            <p:ph type="sldNum" sz="quarter" idx="5"/>
-          </p:nvPr>
-        </p:nvSpPr>
-        <p:spPr>
-          <a:xfrm>
-            <a:off x="3884613" y="8685213"/>
-            <a:ext cx="2971800" cy="458787"/>
-          </a:xfrm>
-          <a:prstGeom prst="rect">
-            <a:avLst/>
-          </a:prstGeom>
-        </p:spPr>
-        <p:txBody>
-          <a:bodyPr vert="horz" lIns="91440" tIns="45720" rIns="91440" bIns="45720" rtlCol="0" anchor="b"/>
-          <a:lstStyle>
-            <a:lvl1pPr algn="r">
-              <a:defRPr sz="1200"/>
-            </a:lvl1pPr>
-          </a:lstStyle>
-          <a:p>
-            <a:fld id="{CE5E9CC1-C706-0F49-92D6-E571CC5EEA8F}" type="slidenum">
-              <a:rPr lang="en-US"/>
-              <a:t>‹#›</a:t>
-            </a:fld>
-            <a:endParaRPr lang="en-US"/>
-          </a:p>
-        </p:txBody>
-      </p:sp>
     </p:spTree>
     <p:extLst>
       <p:ext uri="{BB962C8B-B14F-4D97-AF65-F5344CB8AC3E}">
-        <p14:creationId xmlns:p14="http://schemas.microsoft.com/office/powerpoint/2010/main" val="1024086991"/>
+        <p14:creationId xmlns:p14="http://schemas.microsoft.com/office/powerpoint/2010/main" val="462290413"/>
       </p:ext>
     </p:extLst>
   </p:cSld>
@@ -523,7 +304,6 @@
               <a:rPr lang="en-US" dirty="0"/>
               <a:t>BLUF: a log-log OLS model on EPA MY2024 compliance data predicts fuel economy with R-squared 0.846 from just four design variables. Today: where the data comes from, how the equation is derived, what it says, and what it unlocks.</a:t>
             </a:r>
-            <a:endParaRPr lang="en-US" dirty="0"/>
           </a:p>
         </p:txBody>
       </p:sp>
@@ -611,7 +391,6 @@
               <a:rPr lang="en-US" dirty="0"/>
               <a:t>Elasticities in words. Power is the steepest lever; hybridization is worth 23% at constant everything else — that ranks the design menu: hybridize before lightweighting. The fig22 tie-back: engineering never stalled, allocation did, and these coefficients are the price sheet for that allocation.</a:t>
             </a:r>
-            <a:endParaRPr lang="en-US" dirty="0"/>
           </a:p>
         </p:txBody>
       </p:sp>
@@ -699,7 +478,6 @@
               <a:rPr lang="en-US" dirty="0"/>
               <a:t>Same story in six specifications across two datasets and two DV definitions. The era comparison is itself informative: the model weakens after 2020 because everything became a two-liter turbo — homogenization, not physics failure. The BEV companion model shows electric efficiency is nearly unit-elastic in weight.</a:t>
             </a:r>
-            <a:endParaRPr lang="en-US" dirty="0"/>
           </a:p>
         </p:txBody>
       </p:sp>
@@ -787,7 +565,6 @@
               <a:rPr lang="en-US" dirty="0"/>
               <a:t>Close the loop to consumers: predicted MPG converts directly to dollars per year. Payback arithmetic: $6,477 premium over $1,456 annual savings is about 4.5 years, energy only. The bar chart: efficiency also buys stability — the BEV's worst observed year beats gasoline's best.</a:t>
             </a:r>
-            <a:endParaRPr lang="en-US" dirty="0"/>
           </a:p>
         </p:txBody>
       </p:sp>
@@ -875,7 +652,6 @@
               <a:rPr lang="en-US" dirty="0"/>
               <a:t>Four honest limitations. The lab-vs-road chart earns its place: predictions are of the consistent lab measure; translating to driver experience needs the 31% haircut. Association not causation for any single redesign.</a:t>
             </a:r>
-            <a:endParaRPr lang="en-US" dirty="0"/>
           </a:p>
         </p:txBody>
       </p:sp>
@@ -963,7 +739,6 @@
               <a:rPr lang="en-US" dirty="0"/>
               <a:t>Recap the three numbers, then the forward thesis: prediction turns design menus and sales mixes into dollar forecasts. Leave 2-3 minutes for questions.</a:t>
             </a:r>
-            <a:endParaRPr lang="en-US" dirty="0"/>
           </a:p>
         </p:txBody>
       </p:sp>
@@ -1051,7 +826,6 @@
               <a:rPr lang="en-US" dirty="0"/>
               <a:t>Use if asked how the eras on slide 3 were chosen: exhaustive changepoint search, BIC model order, Chow tests at the chosen breaks.</a:t>
             </a:r>
-            <a:endParaRPr lang="en-US" dirty="0"/>
           </a:p>
         </p:txBody>
       </p:sp>
@@ -1139,7 +913,6 @@
               <a:rPr lang="en-US" dirty="0"/>
               <a:t>Use for any causal question about gas prices or interest rates driving buying patterns: we tested both, both fail the differenced audit. Event study rescued exactly one episode, 1979.</a:t>
             </a:r>
-            <a:endParaRPr lang="en-US" dirty="0"/>
           </a:p>
         </p:txBody>
       </p:sp>
@@ -1227,7 +1000,6 @@
               <a:rPr lang="en-US" dirty="0"/>
               <a:t>Use for consumer-behavior questions: demand tilts toward efficiency relative to the catalog, and volume concentrates hard.</a:t>
             </a:r>
-            <a:endParaRPr lang="en-US" dirty="0"/>
           </a:p>
         </p:txBody>
       </p:sp>
@@ -1315,7 +1087,6 @@
               <a:rPr lang="en-US" dirty="0"/>
               <a:t>Use for price-history questions. Emphasize MSRP vs ATP distinction: asking price vs price paid.</a:t>
             </a:r>
-            <a:endParaRPr lang="en-US" dirty="0"/>
           </a:p>
         </p:txBody>
       </p:sp>
@@ -1403,7 +1174,6 @@
               <a:rPr lang="en-US" dirty="0"/>
               <a:t>Use for fuel-cost trend questions. Energy only; excludes purchase, depreciation, DC-fast premiums; PHEV and diesel excluded with reasons.</a:t>
             </a:r>
-            <a:endParaRPr lang="en-US" dirty="0"/>
           </a:p>
         </p:txBody>
       </p:sp>
@@ -1491,7 +1261,6 @@
               <a:rPr lang="en-US" dirty="0"/>
               <a:t>Frame with money, not units: a gas car costs about $2,500 a year to fuel, an EV about $1,000. Purchase price averages near $50k. MPG is the design lever behind the fuel line. Research question on screen.</a:t>
             </a:r>
-            <a:endParaRPr lang="en-US" dirty="0"/>
           </a:p>
         </p:txBody>
       </p:sp>
@@ -1579,7 +1348,6 @@
               <a:rPr lang="en-US" dirty="0"/>
               <a:t>The forward-looking backup: normalization built from our own regression coefficients. Lead with the vanished trough, then the projection, then the caveats in order.</a:t>
             </a:r>
-            <a:endParaRPr lang="en-US" dirty="0"/>
           </a:p>
         </p:txBody>
       </p:sp>
@@ -1667,7 +1435,6 @@
               <a:rPr lang="en-US" dirty="0"/>
               <a:t>Thirty seconds of history: rise, 17-year trough, modern climb. The trough is where efficiency went into horsepower and pounds; the regression quantifies that exchange rate. Changepoint detection found these eras algorithmically at 1983, 2003, 2013.</a:t>
             </a:r>
-            <a:endParaRPr lang="en-US" dirty="0"/>
           </a:p>
         </p:txBody>
       </p:sp>
@@ -1755,7 +1522,6 @@
               <a:rPr lang="en-US" dirty="0"/>
               <a:t>Get the terminology right out loud: MPG is the dependent variable; the four design measures are the independent variables. Signs predicted before fitting. EVs are excluded because MPGe measures a different quantity; they get their own model later.</a:t>
             </a:r>
-            <a:endParaRPr lang="en-US" dirty="0"/>
           </a:p>
         </p:txBody>
       </p:sp>
@@ -1843,7 +1609,6 @@
               <a:rPr lang="en-US" dirty="0"/>
               <a:t>Not a survey and not scraped: these are compliance filings. One row per model type. Deduplicated production volumes; the two files join perfectly at carline level. Chain of custody is checksummed.</a:t>
             </a:r>
-            <a:endParaRPr lang="en-US" dirty="0"/>
           </a:p>
         </p:txBody>
       </p:sp>
@@ -1931,7 +1696,6 @@
               <a:rPr lang="en-US" dirty="0"/>
               <a:t>Raw scatter first, model second. Footprint vs unadjusted MPG, dot area = production. The pattern is obvious; the point of regression is to disentangle correlated causes and put confidence bounds on each.</a:t>
             </a:r>
-            <a:endParaRPr lang="en-US" dirty="0"/>
           </a:p>
         </p:txBody>
       </p:sp>
@@ -2019,7 +1783,6 @@
               <a:rPr lang="en-US" dirty="0"/>
               <a:t>The equation, verbatim. Why logs: physics is multiplicative. Why elasticities: comparable, unit-free effect sizes. Why HC1: a Fiat and an F-350 do not share error variance. This is the slide to slow down on.</a:t>
             </a:r>
-            <a:endParaRPr lang="en-US" dirty="0"/>
           </a:p>
         </p:txBody>
       </p:sp>
@@ -2107,7 +1870,6 @@
               <a:rPr lang="en-US" dirty="0"/>
               <a:t>All four predictors reject zero; three at p under 0.001. R-squared 0.846, adjusted essentially identical — no overfitting with 205 observations per parameter. VIF maxes at 3.4: collinearity present (size travels with weight) but far from destabilizing.</a:t>
             </a:r>
-            <a:endParaRPr lang="en-US" dirty="0"/>
           </a:p>
         </p:txBody>
       </p:sp>
@@ -2195,7 +1957,6 @@
               <a:rPr lang="en-US" dirty="0"/>
               <a:t>Predicted against actual, one dot per model type, 45-degree line is perfection. Typical miss is a few MPG. Ask the room: guess a random 2024 vehicle's MPG knowing only weight, horsepower, footprint, and hybrid status — this is how close you get.</a:t>
             </a:r>
-            <a:endParaRPr lang="en-US" dirty="0"/>
           </a:p>
         </p:txBody>
       </p:sp>
@@ -2268,6 +2029,11 @@
 <file path=ppt/slideMasters/slideMaster1.xml><?xml version="1.0" encoding="utf-8"?>
 <p:sldMaster xmlns:a="http://schemas.openxmlformats.org/drawingml/2006/main" xmlns:r="http://schemas.openxmlformats.org/officeDocument/2006/relationships" xmlns:p="http://schemas.openxmlformats.org/presentationml/2006/main">
   <p:cSld>
+    <p:bg>
+      <p:bgRef idx="1001">
+        <a:schemeClr val="bg1"/>
+      </p:bgRef>
+    </p:bg>
     <p:spTree>
       <p:nvGrpSpPr>
         <p:cNvPr id="1" name=""/>
@@ -2550,6 +2316,7 @@
         <a:solidFill>
           <a:srgbClr val="14181E"/>
         </a:solidFill>
+        <a:effectLst/>
       </p:bgPr>
     </p:bg>
     <p:spTree>
@@ -2587,7 +2354,7 @@
           <a:bodyPr wrap="square" lIns="0" tIns="0" rIns="0" bIns="0" rtlCol="0" anchor="ctr"/>
           <a:lstStyle/>
           <a:p>
-            <a:pPr indent="0" marL="0">
+            <a:pPr marL="0" indent="0">
               <a:buNone/>
             </a:pPr>
             <a:r>
@@ -2626,7 +2393,7 @@
           <a:bodyPr wrap="square" lIns="0" tIns="0" rIns="0" bIns="0" rtlCol="0" anchor="ctr"/>
           <a:lstStyle/>
           <a:p>
-            <a:pPr indent="0" marL="0">
+            <a:pPr marL="0" indent="0">
               <a:buNone/>
             </a:pPr>
             <a:r>
@@ -2665,7 +2432,7 @@
           <a:bodyPr wrap="square" lIns="0" tIns="0" rIns="0" bIns="0" rtlCol="0" anchor="ctr"/>
           <a:lstStyle/>
           <a:p>
-            <a:pPr indent="0" marL="0">
+            <a:pPr marL="0" indent="0">
               <a:buNone/>
             </a:pPr>
             <a:r>
@@ -2704,7 +2471,7 @@
           <a:bodyPr wrap="square" lIns="0" tIns="0" rIns="0" bIns="0" rtlCol="0" anchor="ctr"/>
           <a:lstStyle/>
           <a:p>
-            <a:pPr indent="0" marL="0">
+            <a:pPr marL="0" indent="0">
               <a:buNone/>
             </a:pPr>
             <a:r>
@@ -2721,7 +2488,7 @@
             <a:endParaRPr lang="en-US" sz="1400" dirty="0"/>
           </a:p>
           <a:p>
-            <a:pPr indent="0" marL="0">
+            <a:pPr marL="0" indent="0">
               <a:buNone/>
             </a:pPr>
             <a:r>
@@ -2785,7 +2552,7 @@
           <a:bodyPr wrap="square" lIns="0" tIns="0" rIns="0" bIns="0" rtlCol="0" anchor="ctr"/>
           <a:lstStyle/>
           <a:p>
-            <a:pPr indent="0" marL="0">
+            <a:pPr marL="0" indent="0">
               <a:buNone/>
             </a:pPr>
             <a:r>
@@ -2824,7 +2591,7 @@
           <a:bodyPr wrap="square" lIns="0" tIns="0" rIns="0" bIns="0" rtlCol="0" anchor="ctr"/>
           <a:lstStyle/>
           <a:p>
-            <a:pPr indent="0" marL="0">
+            <a:pPr marL="0" indent="0">
               <a:buNone/>
             </a:pPr>
             <a:r>
@@ -2863,7 +2630,7 @@
           <a:bodyPr wrap="square" lIns="0" tIns="0" rIns="0" bIns="0" rtlCol="0" anchor="ctr"/>
           <a:lstStyle/>
           <a:p>
-            <a:pPr indent="0" marL="0">
+            <a:pPr marL="0" indent="0">
               <a:buNone/>
             </a:pPr>
             <a:r>
@@ -2902,7 +2669,7 @@
           <a:bodyPr wrap="square" lIns="0" tIns="0" rIns="0" bIns="0" rtlCol="0" anchor="ctr"/>
           <a:lstStyle/>
           <a:p>
-            <a:pPr indent="0" marL="0">
+            <a:pPr marL="0" indent="0">
               <a:buNone/>
             </a:pPr>
             <a:r>
@@ -2941,7 +2708,7 @@
           <a:bodyPr wrap="square" lIns="0" tIns="0" rIns="0" bIns="0" rtlCol="0" anchor="ctr"/>
           <a:lstStyle/>
           <a:p>
-            <a:pPr indent="0" marL="0">
+            <a:pPr marL="0" indent="0">
               <a:buNone/>
             </a:pPr>
             <a:r>
@@ -2980,7 +2747,7 @@
           <a:bodyPr wrap="square" lIns="0" tIns="0" rIns="0" bIns="0" rtlCol="0" anchor="ctr"/>
           <a:lstStyle/>
           <a:p>
-            <a:pPr indent="0" marL="0">
+            <a:pPr marL="0" indent="0">
               <a:buNone/>
             </a:pPr>
             <a:r>
@@ -3019,7 +2786,7 @@
           <a:bodyPr wrap="square" lIns="0" tIns="0" rIns="0" bIns="0" rtlCol="0" anchor="ctr"/>
           <a:lstStyle/>
           <a:p>
-            <a:pPr indent="0" marL="0">
+            <a:pPr marL="0" indent="0">
               <a:buNone/>
             </a:pPr>
             <a:r>
@@ -3039,14 +2806,14 @@
       </p:sp>
       <p:pic>
         <p:nvPicPr>
-          <p:cNvPr id="9" name="Image 0" descr="C:\Users\Samson\Desktop\Homework\OS3180\Final Project\charts\fig22_allocation_proof.png">    </p:cNvPr>
+          <p:cNvPr id="9" name="Image 0" descr="C:\Users\Samson\Desktop\Homework\OS3180\Final Project\charts\fig22_allocation_proof.png"/>
           <p:cNvPicPr>
             <a:picLocks noChangeAspect="1"/>
           </p:cNvPicPr>
           <p:nvPr/>
         </p:nvPicPr>
         <p:blipFill>
-          <a:blip r:embed="rId1"/>
+          <a:blip r:embed="rId3"/>
           <a:stretch>
             <a:fillRect/>
           </a:stretch>
@@ -3069,8 +2836,8 @@
         </p:nvSpPr>
         <p:spPr>
           <a:xfrm>
-            <a:off x="5669280" y="3429000"/>
-            <a:ext cx="6035040" cy="2651760"/>
+            <a:off x="6350654" y="3429000"/>
+            <a:ext cx="5353665" cy="2651760"/>
           </a:xfrm>
           <a:prstGeom prst="rect">
             <a:avLst/>
@@ -3082,7 +2849,7 @@
           <a:bodyPr wrap="square" lIns="0" tIns="0" rIns="0" bIns="0" rtlCol="0" anchor="ctr"/>
           <a:lstStyle/>
           <a:p>
-            <a:pPr indent="0" marL="0">
+            <a:pPr marL="0" indent="0">
               <a:buNone/>
             </a:pPr>
             <a:r>
@@ -3096,9 +2863,6 @@
               </a:rPr>
               <a:t>This is the exchange rate behind the 50-year story. </a:t>
             </a:r>
-            <a:pPr indent="0" marL="0">
-              <a:buNone/>
-            </a:pPr>
             <a:r>
               <a:rPr lang="en-US" sz="1500" dirty="0">
                 <a:solidFill>
@@ -3135,7 +2899,7 @@
           <a:bodyPr wrap="square" lIns="0" tIns="0" rIns="0" bIns="0" rtlCol="0" anchor="ctr"/>
           <a:lstStyle/>
           <a:p>
-            <a:pPr indent="0" marL="0">
+            <a:pPr marL="0" indent="0">
               <a:buNone/>
             </a:pPr>
             <a:r>
@@ -3199,7 +2963,7 @@
           <a:bodyPr wrap="square" lIns="0" tIns="0" rIns="0" bIns="0" rtlCol="0" anchor="ctr"/>
           <a:lstStyle/>
           <a:p>
-            <a:pPr indent="0" marL="0">
+            <a:pPr marL="0" indent="0">
               <a:buNone/>
             </a:pPr>
             <a:r>
@@ -3233,17 +2997,41 @@
         </p:nvGraphicFramePr>
         <p:xfrm>
           <a:off x="502920" y="1371600"/>
-          <a:ext cx="8412480" cy="914400"/>
+          <a:ext cx="8412480" cy="2944368"/>
         </p:xfrm>
         <a:graphic>
           <a:graphicData uri="http://schemas.openxmlformats.org/drawingml/2006/table">
             <a:tbl>
               <a:tblPr/>
               <a:tblGrid>
-                <a:gridCol w="3291840"/>
-                <a:gridCol w="2651760"/>
-                <a:gridCol w="1005840"/>
-                <a:gridCol w="1463040"/>
+                <a:gridCol w="3291840">
+                  <a:extLst>
+                    <a:ext uri="{9D8B030D-6E8A-4147-A177-3AD203B41FA5}">
+                      <a16:colId xmlns:a16="http://schemas.microsoft.com/office/drawing/2014/main" val="20000"/>
+                    </a:ext>
+                  </a:extLst>
+                </a:gridCol>
+                <a:gridCol w="2651760">
+                  <a:extLst>
+                    <a:ext uri="{9D8B030D-6E8A-4147-A177-3AD203B41FA5}">
+                      <a16:colId xmlns:a16="http://schemas.microsoft.com/office/drawing/2014/main" val="20001"/>
+                    </a:ext>
+                  </a:extLst>
+                </a:gridCol>
+                <a:gridCol w="1005840">
+                  <a:extLst>
+                    <a:ext uri="{9D8B030D-6E8A-4147-A177-3AD203B41FA5}">
+                      <a16:colId xmlns:a16="http://schemas.microsoft.com/office/drawing/2014/main" val="20002"/>
+                    </a:ext>
+                  </a:extLst>
+                </a:gridCol>
+                <a:gridCol w="1463040">
+                  <a:extLst>
+                    <a:ext uri="{9D8B030D-6E8A-4147-A177-3AD203B41FA5}">
+                      <a16:colId xmlns:a16="http://schemas.microsoft.com/office/drawing/2014/main" val="20003"/>
+                    </a:ext>
+                  </a:extLst>
+                </a:gridCol>
               </a:tblGrid>
               <a:tr h="420624">
                 <a:tc>
@@ -3251,7 +3039,7 @@
                     <a:bodyPr/>
                     <a:lstStyle/>
                     <a:p>
-                      <a:pPr indent="0" marL="0">
+                      <a:pPr marL="0" indent="0">
                         <a:buNone/>
                       </a:pPr>
                       <a:r>
@@ -3272,7 +3060,7 @@
                       </a:endParaRPr>
                     </a:p>
                   </a:txBody>
-                  <a:tcPr marL="91440" marR="91440" marT="45720" marB="45720" anchor="ctr">
+                  <a:tcPr anchor="ctr">
                     <a:lnL w="6350" cap="flat" cmpd="sng" algn="ctr">
                       <a:solidFill>
                         <a:srgbClr val="D8D6CF"/>
@@ -3319,7 +3107,7 @@
                     <a:bodyPr/>
                     <a:lstStyle/>
                     <a:p>
-                      <a:pPr indent="0" marL="0">
+                      <a:pPr marL="0" indent="0">
                         <a:buNone/>
                       </a:pPr>
                       <a:r>
@@ -3340,7 +3128,7 @@
                       </a:endParaRPr>
                     </a:p>
                   </a:txBody>
-                  <a:tcPr marL="91440" marR="91440" marT="45720" marB="45720" anchor="ctr">
+                  <a:tcPr anchor="ctr">
                     <a:lnL w="6350" cap="flat" cmpd="sng" algn="ctr">
                       <a:solidFill>
                         <a:srgbClr val="D8D6CF"/>
@@ -3387,7 +3175,7 @@
                     <a:bodyPr/>
                     <a:lstStyle/>
                     <a:p>
-                      <a:pPr indent="0" marL="0">
+                      <a:pPr marL="0" indent="0">
                         <a:buNone/>
                       </a:pPr>
                       <a:r>
@@ -3408,7 +3196,7 @@
                       </a:endParaRPr>
                     </a:p>
                   </a:txBody>
-                  <a:tcPr marL="91440" marR="91440" marT="45720" marB="45720" anchor="ctr">
+                  <a:tcPr anchor="ctr">
                     <a:lnL w="6350" cap="flat" cmpd="sng" algn="ctr">
                       <a:solidFill>
                         <a:srgbClr val="D8D6CF"/>
@@ -3455,7 +3243,7 @@
                     <a:bodyPr/>
                     <a:lstStyle/>
                     <a:p>
-                      <a:pPr indent="0" marL="0">
+                      <a:pPr marL="0" indent="0">
                         <a:buNone/>
                       </a:pPr>
                       <a:r>
@@ -3476,7 +3264,7 @@
                       </a:endParaRPr>
                     </a:p>
                   </a:txBody>
-                  <a:tcPr marL="91440" marR="91440" marT="45720" marB="45720" anchor="ctr">
+                  <a:tcPr anchor="ctr">
                     <a:lnL w="6350" cap="flat" cmpd="sng" algn="ctr">
                       <a:solidFill>
                         <a:srgbClr val="D8D6CF"/>
@@ -3518,6 +3306,11 @@
                     </a:solidFill>
                   </a:tcPr>
                 </a:tc>
+                <a:extLst>
+                  <a:ext uri="{0D108BD9-81ED-4DB2-BD59-A6C34878D82A}">
+                    <a16:rowId xmlns:a16="http://schemas.microsoft.com/office/drawing/2014/main" val="10000"/>
+                  </a:ext>
+                </a:extLst>
               </a:tr>
               <a:tr h="420624">
                 <a:tc>
@@ -3525,7 +3318,7 @@
                     <a:bodyPr/>
                     <a:lstStyle/>
                     <a:p>
-                      <a:pPr indent="0" marL="0">
+                      <a:pPr marL="0" indent="0">
                         <a:buNone/>
                       </a:pPr>
                       <a:r>
@@ -3546,7 +3339,7 @@
                       </a:endParaRPr>
                     </a:p>
                   </a:txBody>
-                  <a:tcPr marL="91440" marR="91440" marT="45720" marB="45720" anchor="ctr">
+                  <a:tcPr anchor="ctr">
                     <a:lnL w="6350" cap="flat" cmpd="sng" algn="ctr">
                       <a:solidFill>
                         <a:srgbClr val="D8D6CF"/>
@@ -3593,7 +3386,7 @@
                     <a:bodyPr/>
                     <a:lstStyle/>
                     <a:p>
-                      <a:pPr indent="0" marL="0">
+                      <a:pPr marL="0" indent="0">
                         <a:buNone/>
                       </a:pPr>
                       <a:r>
@@ -3614,7 +3407,7 @@
                       </a:endParaRPr>
                     </a:p>
                   </a:txBody>
-                  <a:tcPr marL="91440" marR="91440" marT="45720" marB="45720" anchor="ctr">
+                  <a:tcPr anchor="ctr">
                     <a:lnL w="6350" cap="flat" cmpd="sng" algn="ctr">
                       <a:solidFill>
                         <a:srgbClr val="D8D6CF"/>
@@ -3661,7 +3454,7 @@
                     <a:bodyPr/>
                     <a:lstStyle/>
                     <a:p>
-                      <a:pPr indent="0" marL="0">
+                      <a:pPr marL="0" indent="0">
                         <a:buNone/>
                       </a:pPr>
                       <a:r>
@@ -3682,7 +3475,7 @@
                       </a:endParaRPr>
                     </a:p>
                   </a:txBody>
-                  <a:tcPr marL="91440" marR="91440" marT="45720" marB="45720" anchor="ctr">
+                  <a:tcPr anchor="ctr">
                     <a:lnL w="6350" cap="flat" cmpd="sng" algn="ctr">
                       <a:solidFill>
                         <a:srgbClr val="D8D6CF"/>
@@ -3729,7 +3522,7 @@
                     <a:bodyPr/>
                     <a:lstStyle/>
                     <a:p>
-                      <a:pPr indent="0" marL="0">
+                      <a:pPr marL="0" indent="0">
                         <a:buNone/>
                       </a:pPr>
                       <a:r>
@@ -3750,7 +3543,7 @@
                       </a:endParaRPr>
                     </a:p>
                   </a:txBody>
-                  <a:tcPr marL="91440" marR="91440" marT="45720" marB="45720" anchor="ctr">
+                  <a:tcPr anchor="ctr">
                     <a:lnL w="6350" cap="flat" cmpd="sng" algn="ctr">
                       <a:solidFill>
                         <a:srgbClr val="D8D6CF"/>
@@ -3792,6 +3585,11 @@
                     </a:solidFill>
                   </a:tcPr>
                 </a:tc>
+                <a:extLst>
+                  <a:ext uri="{0D108BD9-81ED-4DB2-BD59-A6C34878D82A}">
+                    <a16:rowId xmlns:a16="http://schemas.microsoft.com/office/drawing/2014/main" val="10001"/>
+                  </a:ext>
+                </a:extLst>
               </a:tr>
               <a:tr h="420624">
                 <a:tc>
@@ -3799,7 +3597,7 @@
                     <a:bodyPr/>
                     <a:lstStyle/>
                     <a:p>
-                      <a:pPr indent="0" marL="0">
+                      <a:pPr marL="0" indent="0">
                         <a:buNone/>
                       </a:pPr>
                       <a:r>
@@ -3820,7 +3618,7 @@
                       </a:endParaRPr>
                     </a:p>
                   </a:txBody>
-                  <a:tcPr marL="91440" marR="91440" marT="45720" marB="45720" anchor="ctr">
+                  <a:tcPr anchor="ctr">
                     <a:lnL w="6350" cap="flat" cmpd="sng" algn="ctr">
                       <a:solidFill>
                         <a:srgbClr val="D8D6CF"/>
@@ -3867,7 +3665,7 @@
                     <a:bodyPr/>
                     <a:lstStyle/>
                     <a:p>
-                      <a:pPr indent="0" marL="0">
+                      <a:pPr marL="0" indent="0">
                         <a:buNone/>
                       </a:pPr>
                       <a:r>
@@ -3888,7 +3686,7 @@
                       </a:endParaRPr>
                     </a:p>
                   </a:txBody>
-                  <a:tcPr marL="91440" marR="91440" marT="45720" marB="45720" anchor="ctr">
+                  <a:tcPr anchor="ctr">
                     <a:lnL w="6350" cap="flat" cmpd="sng" algn="ctr">
                       <a:solidFill>
                         <a:srgbClr val="D8D6CF"/>
@@ -3935,7 +3733,7 @@
                     <a:bodyPr/>
                     <a:lstStyle/>
                     <a:p>
-                      <a:pPr indent="0" marL="0">
+                      <a:pPr marL="0" indent="0">
                         <a:buNone/>
                       </a:pPr>
                       <a:r>
@@ -3956,7 +3754,7 @@
                       </a:endParaRPr>
                     </a:p>
                   </a:txBody>
-                  <a:tcPr marL="91440" marR="91440" marT="45720" marB="45720" anchor="ctr">
+                  <a:tcPr anchor="ctr">
                     <a:lnL w="6350" cap="flat" cmpd="sng" algn="ctr">
                       <a:solidFill>
                         <a:srgbClr val="D8D6CF"/>
@@ -4003,7 +3801,7 @@
                     <a:bodyPr/>
                     <a:lstStyle/>
                     <a:p>
-                      <a:pPr indent="0" marL="0">
+                      <a:pPr marL="0" indent="0">
                         <a:buNone/>
                       </a:pPr>
                       <a:r>
@@ -4024,7 +3822,7 @@
                       </a:endParaRPr>
                     </a:p>
                   </a:txBody>
-                  <a:tcPr marL="91440" marR="91440" marT="45720" marB="45720" anchor="ctr">
+                  <a:tcPr anchor="ctr">
                     <a:lnL w="6350" cap="flat" cmpd="sng" algn="ctr">
                       <a:solidFill>
                         <a:srgbClr val="D8D6CF"/>
@@ -4066,6 +3864,11 @@
                     </a:solidFill>
                   </a:tcPr>
                 </a:tc>
+                <a:extLst>
+                  <a:ext uri="{0D108BD9-81ED-4DB2-BD59-A6C34878D82A}">
+                    <a16:rowId xmlns:a16="http://schemas.microsoft.com/office/drawing/2014/main" val="10002"/>
+                  </a:ext>
+                </a:extLst>
               </a:tr>
               <a:tr h="420624">
                 <a:tc>
@@ -4073,7 +3876,7 @@
                     <a:bodyPr/>
                     <a:lstStyle/>
                     <a:p>
-                      <a:pPr indent="0" marL="0">
+                      <a:pPr marL="0" indent="0">
                         <a:buNone/>
                       </a:pPr>
                       <a:r>
@@ -4094,7 +3897,7 @@
                       </a:endParaRPr>
                     </a:p>
                   </a:txBody>
-                  <a:tcPr marL="91440" marR="91440" marT="45720" marB="45720" anchor="ctr">
+                  <a:tcPr anchor="ctr">
                     <a:lnL w="6350" cap="flat" cmpd="sng" algn="ctr">
                       <a:solidFill>
                         <a:srgbClr val="D8D6CF"/>
@@ -4141,7 +3944,7 @@
                     <a:bodyPr/>
                     <a:lstStyle/>
                     <a:p>
-                      <a:pPr indent="0" marL="0">
+                      <a:pPr marL="0" indent="0">
                         <a:buNone/>
                       </a:pPr>
                       <a:r>
@@ -4162,7 +3965,7 @@
                       </a:endParaRPr>
                     </a:p>
                   </a:txBody>
-                  <a:tcPr marL="91440" marR="91440" marT="45720" marB="45720" anchor="ctr">
+                  <a:tcPr anchor="ctr">
                     <a:lnL w="6350" cap="flat" cmpd="sng" algn="ctr">
                       <a:solidFill>
                         <a:srgbClr val="D8D6CF"/>
@@ -4209,7 +4012,7 @@
                     <a:bodyPr/>
                     <a:lstStyle/>
                     <a:p>
-                      <a:pPr indent="0" marL="0">
+                      <a:pPr marL="0" indent="0">
                         <a:buNone/>
                       </a:pPr>
                       <a:r>
@@ -4230,7 +4033,7 @@
                       </a:endParaRPr>
                     </a:p>
                   </a:txBody>
-                  <a:tcPr marL="91440" marR="91440" marT="45720" marB="45720" anchor="ctr">
+                  <a:tcPr anchor="ctr">
                     <a:lnL w="6350" cap="flat" cmpd="sng" algn="ctr">
                       <a:solidFill>
                         <a:srgbClr val="D8D6CF"/>
@@ -4277,7 +4080,7 @@
                     <a:bodyPr/>
                     <a:lstStyle/>
                     <a:p>
-                      <a:pPr indent="0" marL="0">
+                      <a:pPr marL="0" indent="0">
                         <a:buNone/>
                       </a:pPr>
                       <a:r>
@@ -4298,7 +4101,7 @@
                       </a:endParaRPr>
                     </a:p>
                   </a:txBody>
-                  <a:tcPr marL="91440" marR="91440" marT="45720" marB="45720" anchor="ctr">
+                  <a:tcPr anchor="ctr">
                     <a:lnL w="6350" cap="flat" cmpd="sng" algn="ctr">
                       <a:solidFill>
                         <a:srgbClr val="D8D6CF"/>
@@ -4340,6 +4143,11 @@
                     </a:solidFill>
                   </a:tcPr>
                 </a:tc>
+                <a:extLst>
+                  <a:ext uri="{0D108BD9-81ED-4DB2-BD59-A6C34878D82A}">
+                    <a16:rowId xmlns:a16="http://schemas.microsoft.com/office/drawing/2014/main" val="10003"/>
+                  </a:ext>
+                </a:extLst>
               </a:tr>
               <a:tr h="420624">
                 <a:tc>
@@ -4347,7 +4155,7 @@
                     <a:bodyPr/>
                     <a:lstStyle/>
                     <a:p>
-                      <a:pPr indent="0" marL="0">
+                      <a:pPr marL="0" indent="0">
                         <a:buNone/>
                       </a:pPr>
                       <a:r>
@@ -4368,7 +4176,7 @@
                       </a:endParaRPr>
                     </a:p>
                   </a:txBody>
-                  <a:tcPr marL="91440" marR="91440" marT="45720" marB="45720" anchor="ctr">
+                  <a:tcPr anchor="ctr">
                     <a:lnL w="6350" cap="flat" cmpd="sng" algn="ctr">
                       <a:solidFill>
                         <a:srgbClr val="D8D6CF"/>
@@ -4415,7 +4223,7 @@
                     <a:bodyPr/>
                     <a:lstStyle/>
                     <a:p>
-                      <a:pPr indent="0" marL="0">
+                      <a:pPr marL="0" indent="0">
                         <a:buNone/>
                       </a:pPr>
                       <a:r>
@@ -4436,7 +4244,7 @@
                       </a:endParaRPr>
                     </a:p>
                   </a:txBody>
-                  <a:tcPr marL="91440" marR="91440" marT="45720" marB="45720" anchor="ctr">
+                  <a:tcPr anchor="ctr">
                     <a:lnL w="6350" cap="flat" cmpd="sng" algn="ctr">
                       <a:solidFill>
                         <a:srgbClr val="D8D6CF"/>
@@ -4483,7 +4291,7 @@
                     <a:bodyPr/>
                     <a:lstStyle/>
                     <a:p>
-                      <a:pPr indent="0" marL="0">
+                      <a:pPr marL="0" indent="0">
                         <a:buNone/>
                       </a:pPr>
                       <a:r>
@@ -4504,7 +4312,7 @@
                       </a:endParaRPr>
                     </a:p>
                   </a:txBody>
-                  <a:tcPr marL="91440" marR="91440" marT="45720" marB="45720" anchor="ctr">
+                  <a:tcPr anchor="ctr">
                     <a:lnL w="6350" cap="flat" cmpd="sng" algn="ctr">
                       <a:solidFill>
                         <a:srgbClr val="D8D6CF"/>
@@ -4551,7 +4359,7 @@
                     <a:bodyPr/>
                     <a:lstStyle/>
                     <a:p>
-                      <a:pPr indent="0" marL="0">
+                      <a:pPr marL="0" indent="0">
                         <a:buNone/>
                       </a:pPr>
                       <a:r>
@@ -4572,7 +4380,7 @@
                       </a:endParaRPr>
                     </a:p>
                   </a:txBody>
-                  <a:tcPr marL="91440" marR="91440" marT="45720" marB="45720" anchor="ctr">
+                  <a:tcPr anchor="ctr">
                     <a:lnL w="6350" cap="flat" cmpd="sng" algn="ctr">
                       <a:solidFill>
                         <a:srgbClr val="D8D6CF"/>
@@ -4614,6 +4422,11 @@
                     </a:solidFill>
                   </a:tcPr>
                 </a:tc>
+                <a:extLst>
+                  <a:ext uri="{0D108BD9-81ED-4DB2-BD59-A6C34878D82A}">
+                    <a16:rowId xmlns:a16="http://schemas.microsoft.com/office/drawing/2014/main" val="10004"/>
+                  </a:ext>
+                </a:extLst>
               </a:tr>
               <a:tr h="420624">
                 <a:tc>
@@ -4621,7 +4434,7 @@
                     <a:bodyPr/>
                     <a:lstStyle/>
                     <a:p>
-                      <a:pPr indent="0" marL="0">
+                      <a:pPr marL="0" indent="0">
                         <a:buNone/>
                       </a:pPr>
                       <a:r>
@@ -4642,7 +4455,7 @@
                       </a:endParaRPr>
                     </a:p>
                   </a:txBody>
-                  <a:tcPr marL="91440" marR="91440" marT="45720" marB="45720" anchor="ctr">
+                  <a:tcPr anchor="ctr">
                     <a:lnL w="6350" cap="flat" cmpd="sng" algn="ctr">
                       <a:solidFill>
                         <a:srgbClr val="D8D6CF"/>
@@ -4689,7 +4502,7 @@
                     <a:bodyPr/>
                     <a:lstStyle/>
                     <a:p>
-                      <a:pPr indent="0" marL="0">
+                      <a:pPr marL="0" indent="0">
                         <a:buNone/>
                       </a:pPr>
                       <a:r>
@@ -4710,7 +4523,7 @@
                       </a:endParaRPr>
                     </a:p>
                   </a:txBody>
-                  <a:tcPr marL="91440" marR="91440" marT="45720" marB="45720" anchor="ctr">
+                  <a:tcPr anchor="ctr">
                     <a:lnL w="6350" cap="flat" cmpd="sng" algn="ctr">
                       <a:solidFill>
                         <a:srgbClr val="D8D6CF"/>
@@ -4757,7 +4570,7 @@
                     <a:bodyPr/>
                     <a:lstStyle/>
                     <a:p>
-                      <a:pPr indent="0" marL="0">
+                      <a:pPr marL="0" indent="0">
                         <a:buNone/>
                       </a:pPr>
                       <a:r>
@@ -4778,7 +4591,7 @@
                       </a:endParaRPr>
                     </a:p>
                   </a:txBody>
-                  <a:tcPr marL="91440" marR="91440" marT="45720" marB="45720" anchor="ctr">
+                  <a:tcPr anchor="ctr">
                     <a:lnL w="6350" cap="flat" cmpd="sng" algn="ctr">
                       <a:solidFill>
                         <a:srgbClr val="D8D6CF"/>
@@ -4825,7 +4638,7 @@
                     <a:bodyPr/>
                     <a:lstStyle/>
                     <a:p>
-                      <a:pPr indent="0" marL="0">
+                      <a:pPr marL="0" indent="0">
                         <a:buNone/>
                       </a:pPr>
                       <a:r>
@@ -4846,7 +4659,7 @@
                       </a:endParaRPr>
                     </a:p>
                   </a:txBody>
-                  <a:tcPr marL="91440" marR="91440" marT="45720" marB="45720" anchor="ctr">
+                  <a:tcPr anchor="ctr">
                     <a:lnL w="6350" cap="flat" cmpd="sng" algn="ctr">
                       <a:solidFill>
                         <a:srgbClr val="D8D6CF"/>
@@ -4888,6 +4701,11 @@
                     </a:solidFill>
                   </a:tcPr>
                 </a:tc>
+                <a:extLst>
+                  <a:ext uri="{0D108BD9-81ED-4DB2-BD59-A6C34878D82A}">
+                    <a16:rowId xmlns:a16="http://schemas.microsoft.com/office/drawing/2014/main" val="10005"/>
+                  </a:ext>
+                </a:extLst>
               </a:tr>
               <a:tr h="420624">
                 <a:tc>
@@ -4895,7 +4713,7 @@
                     <a:bodyPr/>
                     <a:lstStyle/>
                     <a:p>
-                      <a:pPr indent="0" marL="0">
+                      <a:pPr marL="0" indent="0">
                         <a:buNone/>
                       </a:pPr>
                       <a:r>
@@ -4916,7 +4734,7 @@
                       </a:endParaRPr>
                     </a:p>
                   </a:txBody>
-                  <a:tcPr marL="91440" marR="91440" marT="45720" marB="45720" anchor="ctr">
+                  <a:tcPr anchor="ctr">
                     <a:lnL w="6350" cap="flat" cmpd="sng" algn="ctr">
                       <a:solidFill>
                         <a:srgbClr val="D8D6CF"/>
@@ -4963,7 +4781,7 @@
                     <a:bodyPr/>
                     <a:lstStyle/>
                     <a:p>
-                      <a:pPr indent="0" marL="0">
+                      <a:pPr marL="0" indent="0">
                         <a:buNone/>
                       </a:pPr>
                       <a:r>
@@ -4984,7 +4802,7 @@
                       </a:endParaRPr>
                     </a:p>
                   </a:txBody>
-                  <a:tcPr marL="91440" marR="91440" marT="45720" marB="45720" anchor="ctr">
+                  <a:tcPr anchor="ctr">
                     <a:lnL w="6350" cap="flat" cmpd="sng" algn="ctr">
                       <a:solidFill>
                         <a:srgbClr val="D8D6CF"/>
@@ -5031,7 +4849,7 @@
                     <a:bodyPr/>
                     <a:lstStyle/>
                     <a:p>
-                      <a:pPr indent="0" marL="0">
+                      <a:pPr marL="0" indent="0">
                         <a:buNone/>
                       </a:pPr>
                       <a:r>
@@ -5052,7 +4870,7 @@
                       </a:endParaRPr>
                     </a:p>
                   </a:txBody>
-                  <a:tcPr marL="91440" marR="91440" marT="45720" marB="45720" anchor="ctr">
+                  <a:tcPr anchor="ctr">
                     <a:lnL w="6350" cap="flat" cmpd="sng" algn="ctr">
                       <a:solidFill>
                         <a:srgbClr val="D8D6CF"/>
@@ -5099,7 +4917,7 @@
                     <a:bodyPr/>
                     <a:lstStyle/>
                     <a:p>
-                      <a:pPr indent="0" marL="0">
+                      <a:pPr marL="0" indent="0">
                         <a:buNone/>
                       </a:pPr>
                       <a:r>
@@ -5120,7 +4938,7 @@
                       </a:endParaRPr>
                     </a:p>
                   </a:txBody>
-                  <a:tcPr marL="91440" marR="91440" marT="45720" marB="45720" anchor="ctr">
+                  <a:tcPr anchor="ctr">
                     <a:lnL w="6350" cap="flat" cmpd="sng" algn="ctr">
                       <a:solidFill>
                         <a:srgbClr val="D8D6CF"/>
@@ -5162,6 +4980,11 @@
                     </a:solidFill>
                   </a:tcPr>
                 </a:tc>
+                <a:extLst>
+                  <a:ext uri="{0D108BD9-81ED-4DB2-BD59-A6C34878D82A}">
+                    <a16:rowId xmlns:a16="http://schemas.microsoft.com/office/drawing/2014/main" val="10006"/>
+                  </a:ext>
+                </a:extLst>
               </a:tr>
             </a:tbl>
           </a:graphicData>
@@ -5188,7 +5011,7 @@
           <a:bodyPr wrap="square" lIns="0" tIns="0" rIns="0" bIns="0" rtlCol="0" anchor="ctr"/>
           <a:lstStyle/>
           <a:p>
-            <a:pPr indent="0" marL="0">
+            <a:pPr marL="0" indent="0">
               <a:buNone/>
             </a:pPr>
             <a:r>
@@ -5203,9 +5026,6 @@
               <a:t>Two findings inside the table:
 </a:t>
             </a:r>
-            <a:pPr indent="0" marL="0">
-              <a:buNone/>
-            </a:pPr>
             <a:r>
               <a:rPr lang="en-US" sz="1300" dirty="0">
                 <a:solidFill>
@@ -5220,13 +5040,13 @@
             <a:endParaRPr lang="en-US" sz="1300" dirty="0"/>
           </a:p>
           <a:p>
-            <a:pPr indent="0" marL="0">
+            <a:pPr marL="0" indent="0">
               <a:buNone/>
             </a:pPr>
             <a:endParaRPr lang="en-US" sz="1300" dirty="0"/>
           </a:p>
           <a:p>
-            <a:pPr indent="0" marL="0">
+            <a:pPr marL="0" indent="0">
               <a:buNone/>
             </a:pPr>
             <a:r>
@@ -5265,7 +5085,7 @@
           <a:bodyPr wrap="square" lIns="0" tIns="0" rIns="0" bIns="0" rtlCol="0" anchor="ctr"/>
           <a:lstStyle/>
           <a:p>
-            <a:pPr indent="0" marL="0">
+            <a:pPr marL="0" indent="0">
               <a:buNone/>
             </a:pPr>
             <a:r>
@@ -5329,7 +5149,7 @@
           <a:bodyPr wrap="square" lIns="0" tIns="0" rIns="0" bIns="0" rtlCol="0" anchor="ctr"/>
           <a:lstStyle/>
           <a:p>
-            <a:pPr indent="0" marL="0">
+            <a:pPr marL="0" indent="0">
               <a:buNone/>
             </a:pPr>
             <a:r>
@@ -5349,14 +5169,14 @@
       </p:sp>
       <p:pic>
         <p:nvPicPr>
-          <p:cNvPr id="3" name="Image 0" descr="C:\Users\Samson\Desktop\Homework\OS3180\Final Project\charts\fig36_price_sensitivity.png">    </p:cNvPr>
+          <p:cNvPr id="3" name="Image 0" descr="C:\Users\Samson\Desktop\Homework\OS3180\Final Project\charts\fig36_price_sensitivity.png"/>
           <p:cNvPicPr>
             <a:picLocks noChangeAspect="1"/>
           </p:cNvPicPr>
           <p:nvPr/>
         </p:nvPicPr>
         <p:blipFill>
-          <a:blip r:embed="rId1"/>
+          <a:blip r:embed="rId3"/>
           <a:stretch>
             <a:fillRect/>
           </a:stretch>
@@ -5392,7 +5212,7 @@
           <a:bodyPr wrap="square" lIns="0" tIns="0" rIns="0" bIns="0" rtlCol="0" anchor="ctr"/>
           <a:lstStyle/>
           <a:p>
-            <a:pPr indent="0" marL="0">
+            <a:pPr marL="0" indent="0">
               <a:buNone/>
             </a:pPr>
             <a:r>
@@ -5431,7 +5251,7 @@
           <a:bodyPr wrap="square" lIns="0" tIns="0" rIns="0" bIns="0" rtlCol="0" anchor="ctr"/>
           <a:lstStyle/>
           <a:p>
-            <a:pPr indent="0" marL="0">
+            <a:pPr marL="0" indent="0">
               <a:buNone/>
             </a:pPr>
             <a:r>
@@ -5470,7 +5290,7 @@
           <a:bodyPr wrap="square" lIns="0" tIns="0" rIns="0" bIns="0" rtlCol="0" anchor="ctr"/>
           <a:lstStyle/>
           <a:p>
-            <a:pPr indent="0" marL="0">
+            <a:pPr marL="0" indent="0">
               <a:buNone/>
             </a:pPr>
             <a:r>
@@ -5484,9 +5304,6 @@
               </a:rPr>
               <a:t>And the volatility story: </a:t>
             </a:r>
-            <a:pPr indent="0" marL="0">
-              <a:buNone/>
-            </a:pPr>
             <a:r>
               <a:rPr lang="en-US" sz="1500" dirty="0">
                 <a:solidFill>
@@ -5523,7 +5340,7 @@
           <a:bodyPr wrap="square" lIns="0" tIns="0" rIns="0" bIns="0" rtlCol="0" anchor="ctr"/>
           <a:lstStyle/>
           <a:p>
-            <a:pPr indent="0" marL="0">
+            <a:pPr marL="0" indent="0">
               <a:buNone/>
             </a:pPr>
             <a:r>
@@ -5587,7 +5404,7 @@
           <a:bodyPr wrap="square" lIns="0" tIns="0" rIns="0" bIns="0" rtlCol="0" anchor="ctr"/>
           <a:lstStyle/>
           <a:p>
-            <a:pPr indent="0" marL="0">
+            <a:pPr marL="0" indent="0">
               <a:buNone/>
             </a:pPr>
             <a:r>
@@ -5626,7 +5443,7 @@
           <a:bodyPr wrap="square" lIns="0" tIns="0" rIns="0" bIns="0" rtlCol="0" anchor="ctr"/>
           <a:lstStyle/>
           <a:p>
-            <a:pPr indent="0" marL="0">
+            <a:pPr marL="0" indent="0">
               <a:buNone/>
             </a:pPr>
             <a:r>
@@ -5640,9 +5457,6 @@
               </a:rPr>
               <a:t>Cross-sectional, one model year.  </a:t>
             </a:r>
-            <a:pPr indent="0" marL="0">
-              <a:buNone/>
-            </a:pPr>
             <a:r>
               <a:rPr lang="en-US" sz="1450" dirty="0">
                 <a:solidFill>
@@ -5679,7 +5493,7 @@
           <a:bodyPr wrap="square" lIns="0" tIns="0" rIns="0" bIns="0" rtlCol="0" anchor="ctr"/>
           <a:lstStyle/>
           <a:p>
-            <a:pPr indent="0" marL="0">
+            <a:pPr marL="0" indent="0">
               <a:buNone/>
             </a:pPr>
             <a:r>
@@ -5693,9 +5507,6 @@
               </a:rPr>
               <a:t>Lab MPG, not window sticker.  </a:t>
             </a:r>
-            <a:pPr indent="0" marL="0">
-              <a:buNone/>
-            </a:pPr>
             <a:r>
               <a:rPr lang="en-US" sz="1450" dirty="0">
                 <a:solidFill>
@@ -5732,7 +5543,7 @@
           <a:bodyPr wrap="square" lIns="0" tIns="0" rIns="0" bIns="0" rtlCol="0" anchor="ctr"/>
           <a:lstStyle/>
           <a:p>
-            <a:pPr indent="0" marL="0">
+            <a:pPr marL="0" indent="0">
               <a:buNone/>
             </a:pPr>
             <a:r>
@@ -5746,9 +5557,6 @@
               </a:rPr>
               <a:t>Mild collinearity.  </a:t>
             </a:r>
-            <a:pPr indent="0" marL="0">
-              <a:buNone/>
-            </a:pPr>
             <a:r>
               <a:rPr lang="en-US" sz="1450" dirty="0">
                 <a:solidFill>
@@ -5785,7 +5593,7 @@
           <a:bodyPr wrap="square" lIns="0" tIns="0" rIns="0" bIns="0" rtlCol="0" anchor="ctr"/>
           <a:lstStyle/>
           <a:p>
-            <a:pPr indent="0" marL="0">
+            <a:pPr marL="0" indent="0">
               <a:buNone/>
             </a:pPr>
             <a:r>
@@ -5799,9 +5607,6 @@
               </a:rPr>
               <a:t>EVs modeled separately.  </a:t>
             </a:r>
-            <a:pPr indent="0" marL="0">
-              <a:buNone/>
-            </a:pPr>
             <a:r>
               <a:rPr lang="en-US" sz="1450" dirty="0">
                 <a:solidFill>
@@ -5819,14 +5624,14 @@
       </p:sp>
       <p:pic>
         <p:nvPicPr>
-          <p:cNvPr id="7" name="Image 0" descr="C:\Users\Samson\Desktop\Homework\OS3180\Final Project\charts\fig7_lab_vs_road.png">    </p:cNvPr>
+          <p:cNvPr id="7" name="Image 0" descr="C:\Users\Samson\Desktop\Homework\OS3180\Final Project\charts\fig7_lab_vs_road.png"/>
           <p:cNvPicPr>
             <a:picLocks noChangeAspect="1"/>
           </p:cNvPicPr>
           <p:nvPr/>
         </p:nvPicPr>
         <p:blipFill>
-          <a:blip r:embed="rId1"/>
+          <a:blip r:embed="rId3"/>
           <a:stretch>
             <a:fillRect/>
           </a:stretch>
@@ -5862,7 +5667,7 @@
           <a:bodyPr wrap="square" lIns="0" tIns="0" rIns="0" bIns="0" rtlCol="0" anchor="ctr"/>
           <a:lstStyle/>
           <a:p>
-            <a:pPr indent="0" marL="0">
+            <a:pPr marL="0" indent="0">
               <a:buNone/>
             </a:pPr>
             <a:r>
@@ -5901,7 +5706,7 @@
           <a:bodyPr wrap="square" lIns="0" tIns="0" rIns="0" bIns="0" rtlCol="0" anchor="ctr"/>
           <a:lstStyle/>
           <a:p>
-            <a:pPr indent="0" marL="0">
+            <a:pPr marL="0" indent="0">
               <a:buNone/>
             </a:pPr>
             <a:r>
@@ -5935,6 +5740,7 @@
         <a:solidFill>
           <a:srgbClr val="14181E"/>
         </a:solidFill>
+        <a:effectLst/>
       </p:bgPr>
     </p:bg>
     <p:spTree>
@@ -5972,7 +5778,7 @@
           <a:bodyPr wrap="square" lIns="0" tIns="0" rIns="0" bIns="0" rtlCol="0" anchor="ctr"/>
           <a:lstStyle/>
           <a:p>
-            <a:pPr indent="0" marL="0">
+            <a:pPr marL="0" indent="0">
               <a:buNone/>
             </a:pPr>
             <a:r>
@@ -6011,7 +5817,7 @@
           <a:bodyPr wrap="square" lIns="0" tIns="0" rIns="0" bIns="0" rtlCol="0" anchor="ctr"/>
           <a:lstStyle/>
           <a:p>
-            <a:pPr indent="0" marL="0">
+            <a:pPr marL="0" indent="0">
               <a:buNone/>
             </a:pPr>
             <a:r>
@@ -6050,7 +5856,7 @@
           <a:bodyPr wrap="square" lIns="0" tIns="0" rIns="0" bIns="0" rtlCol="0" anchor="ctr"/>
           <a:lstStyle/>
           <a:p>
-            <a:pPr indent="0" marL="0">
+            <a:pPr marL="0" indent="0">
               <a:buNone/>
             </a:pPr>
             <a:r>
@@ -6089,7 +5895,7 @@
           <a:bodyPr wrap="square" lIns="0" tIns="0" rIns="0" bIns="0" rtlCol="0" anchor="ctr"/>
           <a:lstStyle/>
           <a:p>
-            <a:pPr indent="0" marL="0">
+            <a:pPr marL="0" indent="0">
               <a:buNone/>
             </a:pPr>
             <a:r>
@@ -6128,7 +5934,7 @@
           <a:bodyPr wrap="square" lIns="0" tIns="0" rIns="0" bIns="0" rtlCol="0" anchor="ctr"/>
           <a:lstStyle/>
           <a:p>
-            <a:pPr indent="0" marL="0">
+            <a:pPr marL="0" indent="0">
               <a:buNone/>
             </a:pPr>
             <a:r>
@@ -6167,7 +5973,7 @@
           <a:bodyPr wrap="square" lIns="0" tIns="0" rIns="0" bIns="0" rtlCol="0" anchor="ctr"/>
           <a:lstStyle/>
           <a:p>
-            <a:pPr indent="0" marL="0">
+            <a:pPr marL="0" indent="0">
               <a:buNone/>
             </a:pPr>
             <a:r>
@@ -6206,7 +6012,7 @@
           <a:bodyPr wrap="square" lIns="0" tIns="0" rIns="0" bIns="0" rtlCol="0" anchor="ctr"/>
           <a:lstStyle/>
           <a:p>
-            <a:pPr indent="0" marL="0">
+            <a:pPr marL="0" indent="0">
               <a:buNone/>
             </a:pPr>
             <a:r>
@@ -6245,7 +6051,7 @@
           <a:bodyPr wrap="square" lIns="0" tIns="0" rIns="0" bIns="0" rtlCol="0" anchor="ctr"/>
           <a:lstStyle/>
           <a:p>
-            <a:pPr indent="0" marL="0">
+            <a:pPr marL="0" indent="0">
               <a:buNone/>
             </a:pPr>
             <a:r>
@@ -6260,9 +6066,6 @@
               <a:t>The chain this equation unlocks:
 </a:t>
             </a:r>
-            <a:pPr indent="0" marL="0">
-              <a:buNone/>
-            </a:pPr>
             <a:r>
               <a:rPr lang="en-US" sz="1600" dirty="0">
                 <a:solidFill>
@@ -6277,13 +6080,13 @@
             <a:endParaRPr lang="en-US" sz="1600" dirty="0"/>
           </a:p>
           <a:p>
-            <a:pPr indent="0" marL="0">
+            <a:pPr marL="0" indent="0">
               <a:buNone/>
             </a:pPr>
             <a:endParaRPr lang="en-US" sz="1600" dirty="0"/>
           </a:p>
           <a:p>
-            <a:pPr indent="0" marL="0">
+            <a:pPr marL="0" indent="0">
               <a:buNone/>
             </a:pPr>
             <a:r>
@@ -6322,7 +6125,7 @@
           <a:bodyPr wrap="square" lIns="0" tIns="0" rIns="0" bIns="0" rtlCol="0" anchor="ctr"/>
           <a:lstStyle/>
           <a:p>
-            <a:pPr indent="0" marL="0">
+            <a:pPr marL="0" indent="0">
               <a:buNone/>
             </a:pPr>
             <a:r>
@@ -6386,7 +6189,7 @@
           <a:bodyPr wrap="square" lIns="0" tIns="0" rIns="0" bIns="0" rtlCol="0" anchor="ctr"/>
           <a:lstStyle/>
           <a:p>
-            <a:pPr indent="0" marL="0">
+            <a:pPr marL="0" indent="0">
               <a:buNone/>
             </a:pPr>
             <a:r>
@@ -6400,9 +6203,6 @@
               </a:rPr>
               <a:t>BACKUP   </a:t>
             </a:r>
-            <a:pPr indent="0" marL="0">
-              <a:buNone/>
-            </a:pPr>
             <a:r>
               <a:rPr lang="en-US" sz="2600" b="1" dirty="0">
                 <a:solidFill>
@@ -6420,14 +6220,14 @@
       </p:sp>
       <p:pic>
         <p:nvPicPr>
-          <p:cNvPr id="3" name="Image 0" descr="C:\Users\Samson\Desktop\Homework\OS3180\Final Project\charts\fig16_changepoints.png">    </p:cNvPr>
+          <p:cNvPr id="3" name="Image 0" descr="C:\Users\Samson\Desktop\Homework\OS3180\Final Project\charts\fig16_changepoints.png"/>
           <p:cNvPicPr>
             <a:picLocks noChangeAspect="1"/>
           </p:cNvPicPr>
           <p:nvPr/>
         </p:nvPicPr>
         <p:blipFill>
-          <a:blip r:embed="rId1"/>
+          <a:blip r:embed="rId3"/>
           <a:stretch>
             <a:fillRect/>
           </a:stretch>
@@ -6463,7 +6263,7 @@
           <a:bodyPr wrap="square" lIns="0" tIns="0" rIns="0" bIns="0" rtlCol="0" anchor="ctr"/>
           <a:lstStyle/>
           <a:p>
-            <a:pPr indent="0" marL="0">
+            <a:pPr marL="0" indent="0">
               <a:buNone/>
             </a:pPr>
             <a:r>
@@ -6502,7 +6302,7 @@
           <a:bodyPr wrap="square" lIns="0" tIns="0" rIns="0" bIns="0" rtlCol="0" anchor="ctr"/>
           <a:lstStyle/>
           <a:p>
-            <a:pPr indent="0" marL="0">
+            <a:pPr marL="0" indent="0">
               <a:buNone/>
             </a:pPr>
             <a:r>
@@ -6566,7 +6366,7 @@
           <a:bodyPr wrap="square" lIns="0" tIns="0" rIns="0" bIns="0" rtlCol="0" anchor="ctr"/>
           <a:lstStyle/>
           <a:p>
-            <a:pPr indent="0" marL="0">
+            <a:pPr marL="0" indent="0">
               <a:buNone/>
             </a:pPr>
             <a:r>
@@ -6580,9 +6380,6 @@
               </a:rPr>
               <a:t>BACKUP   </a:t>
             </a:r>
-            <a:pPr indent="0" marL="0">
-              <a:buNone/>
-            </a:pPr>
             <a:r>
               <a:rPr lang="en-US" sz="2600" b="1" dirty="0">
                 <a:solidFill>
@@ -6600,14 +6397,14 @@
       </p:sp>
       <p:pic>
         <p:nvPicPr>
-          <p:cNvPr id="3" name="Image 0" descr="C:\Users\Samson\Desktop\Homework\OS3180\Final Project\charts\fig19_correlation_that_wasnt.png">    </p:cNvPr>
+          <p:cNvPr id="3" name="Image 0" descr="C:\Users\Samson\Desktop\Homework\OS3180\Final Project\charts\fig19_correlation_that_wasnt.png"/>
           <p:cNvPicPr>
             <a:picLocks noChangeAspect="1"/>
           </p:cNvPicPr>
           <p:nvPr/>
         </p:nvPicPr>
         <p:blipFill>
-          <a:blip r:embed="rId1"/>
+          <a:blip r:embed="rId3"/>
           <a:stretch>
             <a:fillRect/>
           </a:stretch>
@@ -6643,7 +6440,7 @@
           <a:bodyPr wrap="square" lIns="0" tIns="0" rIns="0" bIns="0" rtlCol="0" anchor="ctr"/>
           <a:lstStyle/>
           <a:p>
-            <a:pPr indent="0" marL="0">
+            <a:pPr marL="0" indent="0">
               <a:buNone/>
             </a:pPr>
             <a:r>
@@ -6682,7 +6479,7 @@
           <a:bodyPr wrap="square" lIns="0" tIns="0" rIns="0" bIns="0" rtlCol="0" anchor="ctr"/>
           <a:lstStyle/>
           <a:p>
-            <a:pPr indent="0" marL="0">
+            <a:pPr marL="0" indent="0">
               <a:buNone/>
             </a:pPr>
             <a:r>
@@ -6746,7 +6543,7 @@
           <a:bodyPr wrap="square" lIns="0" tIns="0" rIns="0" bIns="0" rtlCol="0" anchor="ctr"/>
           <a:lstStyle/>
           <a:p>
-            <a:pPr indent="0" marL="0">
+            <a:pPr marL="0" indent="0">
               <a:buNone/>
             </a:pPr>
             <a:r>
@@ -6760,9 +6557,6 @@
               </a:rPr>
               <a:t>BACKUP   </a:t>
             </a:r>
-            <a:pPr indent="0" marL="0">
-              <a:buNone/>
-            </a:pPr>
             <a:r>
               <a:rPr lang="en-US" sz="2600" b="1" dirty="0">
                 <a:solidFill>
@@ -6780,14 +6574,14 @@
       </p:sp>
       <p:pic>
         <p:nvPicPr>
-          <p:cNvPr id="3" name="Image 0" descr="C:\Users\Samson\Desktop\Homework\OS3180\Final Project\charts\fig17_distribution_shift.png">    </p:cNvPr>
+          <p:cNvPr id="3" name="Image 0" descr="C:\Users\Samson\Desktop\Homework\OS3180\Final Project\charts\fig17_distribution_shift.png"/>
           <p:cNvPicPr>
             <a:picLocks noChangeAspect="1"/>
           </p:cNvPicPr>
           <p:nvPr/>
         </p:nvPicPr>
         <p:blipFill>
-          <a:blip r:embed="rId1"/>
+          <a:blip r:embed="rId3"/>
           <a:stretch>
             <a:fillRect/>
           </a:stretch>
@@ -6823,7 +6617,7 @@
           <a:bodyPr wrap="square" lIns="0" tIns="0" rIns="0" bIns="0" rtlCol="0" anchor="ctr"/>
           <a:lstStyle/>
           <a:p>
-            <a:pPr indent="0" marL="0">
+            <a:pPr marL="0" indent="0">
               <a:buNone/>
             </a:pPr>
             <a:r>
@@ -6862,7 +6656,7 @@
           <a:bodyPr wrap="square" lIns="0" tIns="0" rIns="0" bIns="0" rtlCol="0" anchor="ctr"/>
           <a:lstStyle/>
           <a:p>
-            <a:pPr indent="0" marL="0">
+            <a:pPr marL="0" indent="0">
               <a:buNone/>
             </a:pPr>
             <a:r>
@@ -6926,7 +6720,7 @@
           <a:bodyPr wrap="square" lIns="0" tIns="0" rIns="0" bIns="0" rtlCol="0" anchor="ctr"/>
           <a:lstStyle/>
           <a:p>
-            <a:pPr indent="0" marL="0">
+            <a:pPr marL="0" indent="0">
               <a:buNone/>
             </a:pPr>
             <a:r>
@@ -6940,9 +6734,6 @@
               </a:rPr>
               <a:t>BACKUP   </a:t>
             </a:r>
-            <a:pPr indent="0" marL="0">
-              <a:buNone/>
-            </a:pPr>
             <a:r>
               <a:rPr lang="en-US" sz="2600" b="1" dirty="0">
                 <a:solidFill>
@@ -6960,14 +6751,14 @@
       </p:sp>
       <p:pic>
         <p:nvPicPr>
-          <p:cNvPr id="3" name="Image 0" descr="C:\Users\Samson\Desktop\Homework\OS3180\Final Project\charts\fig41_msrp_by_powertrain.png">    </p:cNvPr>
+          <p:cNvPr id="3" name="Image 0" descr="C:\Users\Samson\Desktop\Homework\OS3180\Final Project\charts\fig41_msrp_by_powertrain.png"/>
           <p:cNvPicPr>
             <a:picLocks noChangeAspect="1"/>
           </p:cNvPicPr>
           <p:nvPr/>
         </p:nvPicPr>
         <p:blipFill>
-          <a:blip r:embed="rId1"/>
+          <a:blip r:embed="rId3"/>
           <a:stretch>
             <a:fillRect/>
           </a:stretch>
@@ -7003,7 +6794,7 @@
           <a:bodyPr wrap="square" lIns="0" tIns="0" rIns="0" bIns="0" rtlCol="0" anchor="ctr"/>
           <a:lstStyle/>
           <a:p>
-            <a:pPr indent="0" marL="0">
+            <a:pPr marL="0" indent="0">
               <a:buNone/>
             </a:pPr>
             <a:r>
@@ -7042,7 +6833,7 @@
           <a:bodyPr wrap="square" lIns="0" tIns="0" rIns="0" bIns="0" rtlCol="0" anchor="ctr"/>
           <a:lstStyle/>
           <a:p>
-            <a:pPr indent="0" marL="0">
+            <a:pPr marL="0" indent="0">
               <a:buNone/>
             </a:pPr>
             <a:r>
@@ -7106,7 +6897,7 @@
           <a:bodyPr wrap="square" lIns="0" tIns="0" rIns="0" bIns="0" rtlCol="0" anchor="ctr"/>
           <a:lstStyle/>
           <a:p>
-            <a:pPr indent="0" marL="0">
+            <a:pPr marL="0" indent="0">
               <a:buNone/>
             </a:pPr>
             <a:r>
@@ -7120,9 +6911,6 @@
               </a:rPr>
               <a:t>BACKUP   </a:t>
             </a:r>
-            <a:pPr indent="0" marL="0">
-              <a:buNone/>
-            </a:pPr>
             <a:r>
               <a:rPr lang="en-US" sz="2600" b="1" dirty="0">
                 <a:solidFill>
@@ -7140,14 +6928,14 @@
       </p:sp>
       <p:pic>
         <p:nvPicPr>
-          <p:cNvPr id="3" name="Image 0" descr="C:\Users\Samson\Desktop\Homework\OS3180\Final Project\charts\fig33_cost_trends.png">    </p:cNvPr>
+          <p:cNvPr id="3" name="Image 0" descr="C:\Users\Samson\Desktop\Homework\OS3180\Final Project\charts\fig33_cost_trends.png"/>
           <p:cNvPicPr>
             <a:picLocks noChangeAspect="1"/>
           </p:cNvPicPr>
           <p:nvPr/>
         </p:nvPicPr>
         <p:blipFill>
-          <a:blip r:embed="rId1"/>
+          <a:blip r:embed="rId3"/>
           <a:stretch>
             <a:fillRect/>
           </a:stretch>
@@ -7183,7 +6971,7 @@
           <a:bodyPr wrap="square" lIns="0" tIns="0" rIns="0" bIns="0" rtlCol="0" anchor="ctr"/>
           <a:lstStyle/>
           <a:p>
-            <a:pPr indent="0" marL="0">
+            <a:pPr marL="0" indent="0">
               <a:buNone/>
             </a:pPr>
             <a:r>
@@ -7222,7 +7010,7 @@
           <a:bodyPr wrap="square" lIns="0" tIns="0" rIns="0" bIns="0" rtlCol="0" anchor="ctr"/>
           <a:lstStyle/>
           <a:p>
-            <a:pPr indent="0" marL="0">
+            <a:pPr marL="0" indent="0">
               <a:buNone/>
             </a:pPr>
             <a:r>
@@ -7286,7 +7074,7 @@
           <a:bodyPr wrap="square" lIns="0" tIns="0" rIns="0" bIns="0" rtlCol="0" anchor="ctr"/>
           <a:lstStyle/>
           <a:p>
-            <a:pPr indent="0" marL="0">
+            <a:pPr marL="0" indent="0">
               <a:buNone/>
             </a:pPr>
             <a:r>
@@ -7325,7 +7113,7 @@
           <a:bodyPr wrap="square" lIns="0" tIns="0" rIns="0" bIns="0" rtlCol="0" anchor="ctr"/>
           <a:lstStyle/>
           <a:p>
-            <a:pPr indent="0" marL="0">
+            <a:pPr marL="0" indent="0">
               <a:buNone/>
             </a:pPr>
             <a:r>
@@ -7364,7 +7152,7 @@
           <a:bodyPr wrap="square" lIns="0" tIns="0" rIns="0" bIns="0" rtlCol="0" anchor="ctr"/>
           <a:lstStyle/>
           <a:p>
-            <a:pPr indent="0" marL="0">
+            <a:pPr marL="0" indent="0">
               <a:buNone/>
             </a:pPr>
             <a:r>
@@ -7403,7 +7191,7 @@
           <a:bodyPr wrap="square" lIns="0" tIns="0" rIns="0" bIns="0" rtlCol="0" anchor="ctr"/>
           <a:lstStyle/>
           <a:p>
-            <a:pPr indent="0" marL="0">
+            <a:pPr marL="0" indent="0">
               <a:buNone/>
             </a:pPr>
             <a:r>
@@ -7442,7 +7230,7 @@
           <a:bodyPr wrap="square" lIns="0" tIns="0" rIns="0" bIns="0" rtlCol="0" anchor="ctr"/>
           <a:lstStyle/>
           <a:p>
-            <a:pPr indent="0" marL="0">
+            <a:pPr marL="0" indent="0">
               <a:buNone/>
             </a:pPr>
             <a:r>
@@ -7481,7 +7269,7 @@
           <a:bodyPr wrap="square" lIns="0" tIns="0" rIns="0" bIns="0" rtlCol="0" anchor="ctr"/>
           <a:lstStyle/>
           <a:p>
-            <a:pPr indent="0" marL="0">
+            <a:pPr marL="0" indent="0">
               <a:buNone/>
             </a:pPr>
             <a:r>
@@ -7520,7 +7308,7 @@
           <a:bodyPr wrap="square" lIns="0" tIns="0" rIns="0" bIns="0" rtlCol="0" anchor="ctr"/>
           <a:lstStyle/>
           <a:p>
-            <a:pPr indent="0" marL="0">
+            <a:pPr marL="0" indent="0">
               <a:buNone/>
             </a:pPr>
             <a:r>
@@ -7559,7 +7347,7 @@
           <a:bodyPr wrap="square" lIns="0" tIns="0" rIns="0" bIns="0" rtlCol="0" anchor="ctr"/>
           <a:lstStyle/>
           <a:p>
-            <a:pPr indent="0" marL="0">
+            <a:pPr marL="0" indent="0">
               <a:buNone/>
             </a:pPr>
             <a:r>
@@ -7598,6 +7386,13 @@
           </a:solidFill>
           <a:ln/>
         </p:spPr>
+        <p:txBody>
+          <a:bodyPr/>
+          <a:lstStyle/>
+          <a:p>
+            <a:endParaRPr lang="en-US"/>
+          </a:p>
+        </p:txBody>
       </p:sp>
       <p:sp>
         <p:nvSpPr>
@@ -7620,7 +7415,7 @@
           <a:bodyPr wrap="square" lIns="0" tIns="0" rIns="0" bIns="0" rtlCol="0" anchor="ctr"/>
           <a:lstStyle/>
           <a:p>
-            <a:pPr indent="0" marL="0">
+            <a:pPr marL="0" indent="0">
               <a:buNone/>
             </a:pPr>
             <a:r>
@@ -7634,9 +7429,6 @@
               </a:rPr>
               <a:t>Research question:  </a:t>
             </a:r>
-            <a:pPr indent="0" marL="0">
-              <a:buNone/>
-            </a:pPr>
             <a:r>
               <a:rPr lang="en-US" sz="1800" dirty="0">
                 <a:solidFill>
@@ -7673,7 +7465,7 @@
           <a:bodyPr wrap="square" lIns="0" tIns="0" rIns="0" bIns="0" rtlCol="0" anchor="ctr"/>
           <a:lstStyle/>
           <a:p>
-            <a:pPr indent="0" marL="0">
+            <a:pPr marL="0" indent="0">
               <a:buNone/>
             </a:pPr>
             <a:r>
@@ -7737,7 +7529,7 @@
           <a:bodyPr wrap="square" lIns="0" tIns="0" rIns="0" bIns="0" rtlCol="0" anchor="ctr"/>
           <a:lstStyle/>
           <a:p>
-            <a:pPr indent="0" marL="0">
+            <a:pPr marL="0" indent="0">
               <a:buNone/>
             </a:pPr>
             <a:r>
@@ -7751,9 +7543,6 @@
               </a:rPr>
               <a:t>BACKUP   </a:t>
             </a:r>
-            <a:pPr indent="0" marL="0">
-              <a:buNone/>
-            </a:pPr>
             <a:r>
               <a:rPr lang="en-US" sz="2600" b="1" dirty="0">
                 <a:solidFill>
@@ -7771,14 +7560,14 @@
       </p:sp>
       <p:pic>
         <p:nvPicPr>
-          <p:cNvPr id="3" name="Image 0" descr="C:\Users\Samson\Desktop\Homework\OS3180\Final Project\charts\fig42_productivity_projection.png">    </p:cNvPr>
+          <p:cNvPr id="3" name="Image 0" descr="C:\Users\Samson\Desktop\Homework\OS3180\Final Project\charts\fig42_productivity_projection.png"/>
           <p:cNvPicPr>
             <a:picLocks noChangeAspect="1"/>
           </p:cNvPicPr>
           <p:nvPr/>
         </p:nvPicPr>
         <p:blipFill>
-          <a:blip r:embed="rId1"/>
+          <a:blip r:embed="rId3"/>
           <a:stretch>
             <a:fillRect/>
           </a:stretch>
@@ -7814,7 +7603,7 @@
           <a:bodyPr wrap="square" lIns="0" tIns="0" rIns="0" bIns="0" rtlCol="0" anchor="ctr"/>
           <a:lstStyle/>
           <a:p>
-            <a:pPr indent="0" marL="0">
+            <a:pPr marL="0" indent="0">
               <a:buNone/>
             </a:pPr>
             <a:r>
@@ -7853,7 +7642,7 @@
           <a:bodyPr wrap="square" lIns="0" tIns="0" rIns="0" bIns="0" rtlCol="0" anchor="ctr"/>
           <a:lstStyle/>
           <a:p>
-            <a:pPr indent="0" marL="0">
+            <a:pPr marL="0" indent="0">
               <a:buNone/>
             </a:pPr>
             <a:r>
@@ -7917,7 +7706,7 @@
           <a:bodyPr wrap="square" lIns="0" tIns="0" rIns="0" bIns="0" rtlCol="0" anchor="ctr"/>
           <a:lstStyle/>
           <a:p>
-            <a:pPr indent="0" marL="0">
+            <a:pPr marL="0" indent="0">
               <a:buNone/>
             </a:pPr>
             <a:r>
@@ -7937,14 +7726,14 @@
       </p:sp>
       <p:pic>
         <p:nvPicPr>
-          <p:cNvPr id="3" name="Image 0" descr="C:\Users\Samson\Desktop\Homework\OS3180\Final Project\charts\fig1_three_acts.png">    </p:cNvPr>
+          <p:cNvPr id="3" name="Image 0" descr="C:\Users\Samson\Desktop\Homework\OS3180\Final Project\charts\fig1_three_acts.png"/>
           <p:cNvPicPr>
             <a:picLocks noChangeAspect="1"/>
           </p:cNvPicPr>
           <p:nvPr/>
         </p:nvPicPr>
         <p:blipFill>
-          <a:blip r:embed="rId1"/>
+          <a:blip r:embed="rId3"/>
           <a:stretch>
             <a:fillRect/>
           </a:stretch>
@@ -7980,7 +7769,7 @@
           <a:bodyPr wrap="square" lIns="0" tIns="0" rIns="0" bIns="0" rtlCol="0" anchor="ctr"/>
           <a:lstStyle/>
           <a:p>
-            <a:pPr indent="0" marL="0">
+            <a:pPr marL="0" indent="0">
               <a:buNone/>
             </a:pPr>
             <a:r>
@@ -7994,9 +7783,6 @@
               </a:rPr>
               <a:t>1975–1987: </a:t>
             </a:r>
-            <a:pPr indent="0" marL="0">
-              <a:buNone/>
-            </a:pPr>
             <a:r>
               <a:rPr lang="en-US" sz="1400" dirty="0">
                 <a:solidFill>
@@ -8009,9 +7795,6 @@
               <a:t>13.1 to 22.0 MPG under new CAFE standards
 </a:t>
             </a:r>
-            <a:pPr indent="0" marL="0">
-              <a:buNone/>
-            </a:pPr>
             <a:r>
               <a:rPr lang="en-US" sz="1400" b="1" dirty="0">
                 <a:solidFill>
@@ -8023,9 +7806,6 @@
               </a:rPr>
               <a:t>1987–2004: </a:t>
             </a:r>
-            <a:pPr indent="0" marL="0">
-              <a:buNone/>
-            </a:pPr>
             <a:r>
               <a:rPr lang="en-US" sz="1400" dirty="0">
                 <a:solidFill>
@@ -8038,9 +7818,6 @@
               <a:t>MPG falls to 19.3 while horsepower nearly doubles and weight regains 900 lbs
 </a:t>
             </a:r>
-            <a:pPr indent="0" marL="0">
-              <a:buNone/>
-            </a:pPr>
             <a:r>
               <a:rPr lang="en-US" sz="1400" b="1" dirty="0">
                 <a:solidFill>
@@ -8052,9 +7829,6 @@
               </a:rPr>
               <a:t>2004–2024: </a:t>
             </a:r>
-            <a:pPr indent="0" marL="0">
-              <a:buNone/>
-            </a:pPr>
             <a:r>
               <a:rPr lang="en-US" sz="1400" dirty="0">
                 <a:solidFill>
@@ -8067,9 +7841,6 @@
               <a:t>27.2 MPG: technology finally moves economy, power, and size together
 </a:t>
             </a:r>
-            <a:pPr indent="0" marL="0">
-              <a:buNone/>
-            </a:pPr>
             <a:r>
               <a:rPr lang="en-US" sz="1400" i="1" dirty="0">
                 <a:solidFill>
@@ -8106,7 +7877,7 @@
           <a:bodyPr wrap="square" lIns="0" tIns="0" rIns="0" bIns="0" rtlCol="0" anchor="ctr"/>
           <a:lstStyle/>
           <a:p>
-            <a:pPr indent="0" marL="0">
+            <a:pPr marL="0" indent="0">
               <a:buNone/>
             </a:pPr>
             <a:r>
@@ -8170,7 +7941,7 @@
           <a:bodyPr wrap="square" lIns="0" tIns="0" rIns="0" bIns="0" rtlCol="0" anchor="ctr"/>
           <a:lstStyle/>
           <a:p>
-            <a:pPr indent="0" marL="0">
+            <a:pPr marL="0" indent="0">
               <a:buNone/>
             </a:pPr>
             <a:r>
@@ -8209,6 +7980,13 @@
           </a:solidFill>
           <a:ln/>
         </p:spPr>
+        <p:txBody>
+          <a:bodyPr/>
+          <a:lstStyle/>
+          <a:p>
+            <a:endParaRPr lang="en-US"/>
+          </a:p>
+        </p:txBody>
       </p:sp>
       <p:sp>
         <p:nvSpPr>
@@ -8231,7 +8009,7 @@
           <a:bodyPr wrap="square" lIns="0" tIns="0" rIns="0" bIns="0" rtlCol="0" anchor="ctr"/>
           <a:lstStyle/>
           <a:p>
-            <a:pPr indent="0" marL="0">
+            <a:pPr marL="0" indent="0">
               <a:buNone/>
             </a:pPr>
             <a:r>
@@ -8245,9 +8023,6 @@
               </a:rPr>
               <a:t>DEPENDENT (y):  </a:t>
             </a:r>
-            <a:pPr indent="0" marL="0">
-              <a:buNone/>
-            </a:pPr>
             <a:r>
               <a:rPr lang="en-US" sz="1500" dirty="0">
                 <a:solidFill>
@@ -8284,6 +8059,13 @@
           </a:solidFill>
           <a:ln/>
         </p:spPr>
+        <p:txBody>
+          <a:bodyPr/>
+          <a:lstStyle/>
+          <a:p>
+            <a:endParaRPr lang="en-US"/>
+          </a:p>
+        </p:txBody>
       </p:sp>
       <p:sp>
         <p:nvSpPr>
@@ -8306,7 +8088,7 @@
           <a:bodyPr wrap="square" lIns="0" tIns="0" rIns="0" bIns="0" rtlCol="0" anchor="ctr"/>
           <a:lstStyle/>
           <a:p>
-            <a:pPr indent="0" marL="0">
+            <a:pPr marL="0" indent="0">
               <a:lnSpc>
                 <a:spcPts val="2600"/>
               </a:lnSpc>
@@ -8324,12 +8106,6 @@
               <a:t>INDEPENDENT (x):
 </a:t>
             </a:r>
-            <a:pPr indent="0" marL="0">
-              <a:lnSpc>
-                <a:spcPts val="2600"/>
-              </a:lnSpc>
-              <a:buNone/>
-            </a:pPr>
             <a:r>
               <a:rPr lang="en-US" sz="1600" dirty="0">
                 <a:solidFill>
@@ -8344,7 +8120,7 @@
             <a:endParaRPr lang="en-US" sz="1600" dirty="0"/>
           </a:p>
           <a:p>
-            <a:pPr indent="0" marL="0">
+            <a:pPr marL="0" indent="0">
               <a:lnSpc>
                 <a:spcPts val="2600"/>
               </a:lnSpc>
@@ -8364,7 +8140,7 @@
             <a:endParaRPr lang="en-US" sz="1600" dirty="0"/>
           </a:p>
           <a:p>
-            <a:pPr indent="0" marL="0">
+            <a:pPr marL="0" indent="0">
               <a:lnSpc>
                 <a:spcPts val="2600"/>
               </a:lnSpc>
@@ -8384,7 +8160,7 @@
             <a:endParaRPr lang="en-US" sz="1600" dirty="0"/>
           </a:p>
           <a:p>
-            <a:pPr indent="0" marL="0">
+            <a:pPr marL="0" indent="0">
               <a:lnSpc>
                 <a:spcPts val="2600"/>
               </a:lnSpc>
@@ -8407,7 +8183,7 @@
       </p:sp>
       <p:graphicFrame>
         <p:nvGraphicFramePr>
-          <p:cNvPr id="5" name="Table 0"/>
+          <p:cNvPr id="7" name="Table 0"/>
           <p:cNvGraphicFramePr>
             <a:graphicFrameLocks noGrp="1"/>
           </p:cNvGraphicFramePr>
@@ -8421,16 +8197,34 @@
         </p:nvGraphicFramePr>
         <p:xfrm>
           <a:off x="6126480" y="1234440"/>
-          <a:ext cx="5577840" cy="914400"/>
+          <a:ext cx="5577840" cy="2133600"/>
         </p:xfrm>
         <a:graphic>
           <a:graphicData uri="http://schemas.openxmlformats.org/drawingml/2006/table">
             <a:tbl>
               <a:tblPr/>
               <a:tblGrid>
-                <a:gridCol w="1554480"/>
-                <a:gridCol w="1188720"/>
-                <a:gridCol w="2834640"/>
+                <a:gridCol w="1554480">
+                  <a:extLst>
+                    <a:ext uri="{9D8B030D-6E8A-4147-A177-3AD203B41FA5}">
+                      <a16:colId xmlns:a16="http://schemas.microsoft.com/office/drawing/2014/main" val="20000"/>
+                    </a:ext>
+                  </a:extLst>
+                </a:gridCol>
+                <a:gridCol w="1188720">
+                  <a:extLst>
+                    <a:ext uri="{9D8B030D-6E8A-4147-A177-3AD203B41FA5}">
+                      <a16:colId xmlns:a16="http://schemas.microsoft.com/office/drawing/2014/main" val="20001"/>
+                    </a:ext>
+                  </a:extLst>
+                </a:gridCol>
+                <a:gridCol w="2834640">
+                  <a:extLst>
+                    <a:ext uri="{9D8B030D-6E8A-4147-A177-3AD203B41FA5}">
+                      <a16:colId xmlns:a16="http://schemas.microsoft.com/office/drawing/2014/main" val="20002"/>
+                    </a:ext>
+                  </a:extLst>
+                </a:gridCol>
               </a:tblGrid>
               <a:tr h="411480">
                 <a:tc>
@@ -8438,7 +8232,7 @@
                     <a:bodyPr/>
                     <a:lstStyle/>
                     <a:p>
-                      <a:pPr indent="0" marL="0">
+                      <a:pPr marL="0" indent="0">
                         <a:buNone/>
                       </a:pPr>
                       <a:r>
@@ -8459,7 +8253,7 @@
                       </a:endParaRPr>
                     </a:p>
                   </a:txBody>
-                  <a:tcPr marL="91440" marR="91440" marT="45720" marB="45720" anchor="ctr">
+                  <a:tcPr anchor="ctr">
                     <a:lnL w="6350" cap="flat" cmpd="sng" algn="ctr">
                       <a:solidFill>
                         <a:srgbClr val="D8D6CF"/>
@@ -8506,7 +8300,7 @@
                     <a:bodyPr/>
                     <a:lstStyle/>
                     <a:p>
-                      <a:pPr indent="0" marL="0">
+                      <a:pPr marL="0" indent="0">
                         <a:buNone/>
                       </a:pPr>
                       <a:r>
@@ -8527,7 +8321,7 @@
                       </a:endParaRPr>
                     </a:p>
                   </a:txBody>
-                  <a:tcPr marL="91440" marR="91440" marT="45720" marB="45720" anchor="ctr">
+                  <a:tcPr anchor="ctr">
                     <a:lnL w="6350" cap="flat" cmpd="sng" algn="ctr">
                       <a:solidFill>
                         <a:srgbClr val="D8D6CF"/>
@@ -8574,7 +8368,7 @@
                     <a:bodyPr/>
                     <a:lstStyle/>
                     <a:p>
-                      <a:pPr indent="0" marL="0">
+                      <a:pPr marL="0" indent="0">
                         <a:buNone/>
                       </a:pPr>
                       <a:r>
@@ -8595,7 +8389,7 @@
                       </a:endParaRPr>
                     </a:p>
                   </a:txBody>
-                  <a:tcPr marL="91440" marR="91440" marT="45720" marB="45720" anchor="ctr">
+                  <a:tcPr anchor="ctr">
                     <a:lnL w="6350" cap="flat" cmpd="sng" algn="ctr">
                       <a:solidFill>
                         <a:srgbClr val="D8D6CF"/>
@@ -8637,6 +8431,11 @@
                     </a:solidFill>
                   </a:tcPr>
                 </a:tc>
+                <a:extLst>
+                  <a:ext uri="{0D108BD9-81ED-4DB2-BD59-A6C34878D82A}">
+                    <a16:rowId xmlns:a16="http://schemas.microsoft.com/office/drawing/2014/main" val="10000"/>
+                  </a:ext>
+                </a:extLst>
               </a:tr>
               <a:tr h="411480">
                 <a:tc>
@@ -8644,7 +8443,7 @@
                     <a:bodyPr/>
                     <a:lstStyle/>
                     <a:p>
-                      <a:pPr indent="0" marL="0">
+                      <a:pPr marL="0" indent="0">
                         <a:buNone/>
                       </a:pPr>
                       <a:r>
@@ -8665,7 +8464,7 @@
                       </a:endParaRPr>
                     </a:p>
                   </a:txBody>
-                  <a:tcPr marL="91440" marR="91440" marT="45720" marB="45720" anchor="ctr">
+                  <a:tcPr anchor="ctr">
                     <a:lnL w="6350" cap="flat" cmpd="sng" algn="ctr">
                       <a:solidFill>
                         <a:srgbClr val="D8D6CF"/>
@@ -8712,7 +8511,7 @@
                     <a:bodyPr/>
                     <a:lstStyle/>
                     <a:p>
-                      <a:pPr indent="0" marL="0">
+                      <a:pPr marL="0" indent="0">
                         <a:buNone/>
                       </a:pPr>
                       <a:r>
@@ -8733,7 +8532,7 @@
                       </a:endParaRPr>
                     </a:p>
                   </a:txBody>
-                  <a:tcPr marL="91440" marR="91440" marT="45720" marB="45720" anchor="ctr">
+                  <a:tcPr anchor="ctr">
                     <a:lnL w="6350" cap="flat" cmpd="sng" algn="ctr">
                       <a:solidFill>
                         <a:srgbClr val="D8D6CF"/>
@@ -8780,7 +8579,7 @@
                     <a:bodyPr/>
                     <a:lstStyle/>
                     <a:p>
-                      <a:pPr indent="0" marL="0">
+                      <a:pPr marL="0" indent="0">
                         <a:buNone/>
                       </a:pPr>
                       <a:r>
@@ -8801,7 +8600,7 @@
                       </a:endParaRPr>
                     </a:p>
                   </a:txBody>
-                  <a:tcPr marL="91440" marR="91440" marT="45720" marB="45720" anchor="ctr">
+                  <a:tcPr anchor="ctr">
                     <a:lnL w="6350" cap="flat" cmpd="sng" algn="ctr">
                       <a:solidFill>
                         <a:srgbClr val="D8D6CF"/>
@@ -8843,6 +8642,11 @@
                     </a:solidFill>
                   </a:tcPr>
                 </a:tc>
+                <a:extLst>
+                  <a:ext uri="{0D108BD9-81ED-4DB2-BD59-A6C34878D82A}">
+                    <a16:rowId xmlns:a16="http://schemas.microsoft.com/office/drawing/2014/main" val="10001"/>
+                  </a:ext>
+                </a:extLst>
               </a:tr>
               <a:tr h="411480">
                 <a:tc>
@@ -8850,7 +8654,7 @@
                     <a:bodyPr/>
                     <a:lstStyle/>
                     <a:p>
-                      <a:pPr indent="0" marL="0">
+                      <a:pPr marL="0" indent="0">
                         <a:buNone/>
                       </a:pPr>
                       <a:r>
@@ -8871,7 +8675,7 @@
                       </a:endParaRPr>
                     </a:p>
                   </a:txBody>
-                  <a:tcPr marL="91440" marR="91440" marT="45720" marB="45720" anchor="ctr">
+                  <a:tcPr anchor="ctr">
                     <a:lnL w="6350" cap="flat" cmpd="sng" algn="ctr">
                       <a:solidFill>
                         <a:srgbClr val="D8D6CF"/>
@@ -8918,7 +8722,7 @@
                     <a:bodyPr/>
                     <a:lstStyle/>
                     <a:p>
-                      <a:pPr indent="0" marL="0">
+                      <a:pPr marL="0" indent="0">
                         <a:buNone/>
                       </a:pPr>
                       <a:r>
@@ -8939,7 +8743,7 @@
                       </a:endParaRPr>
                     </a:p>
                   </a:txBody>
-                  <a:tcPr marL="91440" marR="91440" marT="45720" marB="45720" anchor="ctr">
+                  <a:tcPr anchor="ctr">
                     <a:lnL w="6350" cap="flat" cmpd="sng" algn="ctr">
                       <a:solidFill>
                         <a:srgbClr val="D8D6CF"/>
@@ -8986,7 +8790,7 @@
                     <a:bodyPr/>
                     <a:lstStyle/>
                     <a:p>
-                      <a:pPr indent="0" marL="0">
+                      <a:pPr marL="0" indent="0">
                         <a:buNone/>
                       </a:pPr>
                       <a:r>
@@ -9007,7 +8811,7 @@
                       </a:endParaRPr>
                     </a:p>
                   </a:txBody>
-                  <a:tcPr marL="91440" marR="91440" marT="45720" marB="45720" anchor="ctr">
+                  <a:tcPr anchor="ctr">
                     <a:lnL w="6350" cap="flat" cmpd="sng" algn="ctr">
                       <a:solidFill>
                         <a:srgbClr val="D8D6CF"/>
@@ -9049,6 +8853,11 @@
                     </a:solidFill>
                   </a:tcPr>
                 </a:tc>
+                <a:extLst>
+                  <a:ext uri="{0D108BD9-81ED-4DB2-BD59-A6C34878D82A}">
+                    <a16:rowId xmlns:a16="http://schemas.microsoft.com/office/drawing/2014/main" val="10002"/>
+                  </a:ext>
+                </a:extLst>
               </a:tr>
               <a:tr h="411480">
                 <a:tc>
@@ -9056,7 +8865,7 @@
                     <a:bodyPr/>
                     <a:lstStyle/>
                     <a:p>
-                      <a:pPr indent="0" marL="0">
+                      <a:pPr marL="0" indent="0">
                         <a:buNone/>
                       </a:pPr>
                       <a:r>
@@ -9077,7 +8886,7 @@
                       </a:endParaRPr>
                     </a:p>
                   </a:txBody>
-                  <a:tcPr marL="91440" marR="91440" marT="45720" marB="45720" anchor="ctr">
+                  <a:tcPr anchor="ctr">
                     <a:lnL w="6350" cap="flat" cmpd="sng" algn="ctr">
                       <a:solidFill>
                         <a:srgbClr val="D8D6CF"/>
@@ -9124,7 +8933,7 @@
                     <a:bodyPr/>
                     <a:lstStyle/>
                     <a:p>
-                      <a:pPr indent="0" marL="0">
+                      <a:pPr marL="0" indent="0">
                         <a:buNone/>
                       </a:pPr>
                       <a:r>
@@ -9145,7 +8954,7 @@
                       </a:endParaRPr>
                     </a:p>
                   </a:txBody>
-                  <a:tcPr marL="91440" marR="91440" marT="45720" marB="45720" anchor="ctr">
+                  <a:tcPr anchor="ctr">
                     <a:lnL w="6350" cap="flat" cmpd="sng" algn="ctr">
                       <a:solidFill>
                         <a:srgbClr val="D8D6CF"/>
@@ -9192,7 +9001,7 @@
                     <a:bodyPr/>
                     <a:lstStyle/>
                     <a:p>
-                      <a:pPr indent="0" marL="0">
+                      <a:pPr marL="0" indent="0">
                         <a:buNone/>
                       </a:pPr>
                       <a:r>
@@ -9213,7 +9022,7 @@
                       </a:endParaRPr>
                     </a:p>
                   </a:txBody>
-                  <a:tcPr marL="91440" marR="91440" marT="45720" marB="45720" anchor="ctr">
+                  <a:tcPr anchor="ctr">
                     <a:lnL w="6350" cap="flat" cmpd="sng" algn="ctr">
                       <a:solidFill>
                         <a:srgbClr val="D8D6CF"/>
@@ -9255,6 +9064,11 @@
                     </a:solidFill>
                   </a:tcPr>
                 </a:tc>
+                <a:extLst>
+                  <a:ext uri="{0D108BD9-81ED-4DB2-BD59-A6C34878D82A}">
+                    <a16:rowId xmlns:a16="http://schemas.microsoft.com/office/drawing/2014/main" val="10003"/>
+                  </a:ext>
+                </a:extLst>
               </a:tr>
               <a:tr h="411480">
                 <a:tc>
@@ -9262,7 +9076,7 @@
                     <a:bodyPr/>
                     <a:lstStyle/>
                     <a:p>
-                      <a:pPr indent="0" marL="0">
+                      <a:pPr marL="0" indent="0">
                         <a:buNone/>
                       </a:pPr>
                       <a:r>
@@ -9283,7 +9097,7 @@
                       </a:endParaRPr>
                     </a:p>
                   </a:txBody>
-                  <a:tcPr marL="91440" marR="91440" marT="45720" marB="45720" anchor="ctr">
+                  <a:tcPr anchor="ctr">
                     <a:lnL w="6350" cap="flat" cmpd="sng" algn="ctr">
                       <a:solidFill>
                         <a:srgbClr val="D8D6CF"/>
@@ -9330,7 +9144,7 @@
                     <a:bodyPr/>
                     <a:lstStyle/>
                     <a:p>
-                      <a:pPr indent="0" marL="0">
+                      <a:pPr marL="0" indent="0">
                         <a:buNone/>
                       </a:pPr>
                       <a:r>
@@ -9351,7 +9165,7 @@
                       </a:endParaRPr>
                     </a:p>
                   </a:txBody>
-                  <a:tcPr marL="91440" marR="91440" marT="45720" marB="45720" anchor="ctr">
+                  <a:tcPr anchor="ctr">
                     <a:lnL w="6350" cap="flat" cmpd="sng" algn="ctr">
                       <a:solidFill>
                         <a:srgbClr val="D8D6CF"/>
@@ -9398,7 +9212,7 @@
                     <a:bodyPr/>
                     <a:lstStyle/>
                     <a:p>
-                      <a:pPr indent="0" marL="0">
+                      <a:pPr marL="0" indent="0">
                         <a:buNone/>
                       </a:pPr>
                       <a:r>
@@ -9419,7 +9233,7 @@
                       </a:endParaRPr>
                     </a:p>
                   </a:txBody>
-                  <a:tcPr marL="91440" marR="91440" marT="45720" marB="45720" anchor="ctr">
+                  <a:tcPr anchor="ctr">
                     <a:lnL w="6350" cap="flat" cmpd="sng" algn="ctr">
                       <a:solidFill>
                         <a:srgbClr val="D8D6CF"/>
@@ -9461,6 +9275,11 @@
                     </a:solidFill>
                   </a:tcPr>
                 </a:tc>
+                <a:extLst>
+                  <a:ext uri="{0D108BD9-81ED-4DB2-BD59-A6C34878D82A}">
+                    <a16:rowId xmlns:a16="http://schemas.microsoft.com/office/drawing/2014/main" val="10004"/>
+                  </a:ext>
+                </a:extLst>
               </a:tr>
             </a:tbl>
           </a:graphicData>
@@ -9487,7 +9306,7 @@
           <a:bodyPr wrap="square" lIns="0" tIns="0" rIns="0" bIns="0" rtlCol="0" anchor="ctr"/>
           <a:lstStyle/>
           <a:p>
-            <a:pPr indent="0" marL="0">
+            <a:pPr marL="0" indent="0">
               <a:buNone/>
             </a:pPr>
             <a:r>
@@ -9526,7 +9345,7 @@
           <a:bodyPr wrap="square" lIns="0" tIns="0" rIns="0" bIns="0" rtlCol="0" anchor="ctr"/>
           <a:lstStyle/>
           <a:p>
-            <a:pPr indent="0" marL="0">
+            <a:pPr marL="0" indent="0">
               <a:buNone/>
             </a:pPr>
             <a:r>
@@ -9590,7 +9409,7 @@
           <a:bodyPr wrap="square" lIns="0" tIns="0" rIns="0" bIns="0" rtlCol="0" anchor="ctr"/>
           <a:lstStyle/>
           <a:p>
-            <a:pPr indent="0" marL="0">
+            <a:pPr marL="0" indent="0">
               <a:buNone/>
             </a:pPr>
             <a:r>
@@ -9624,18 +9443,48 @@
         </p:nvGraphicFramePr>
         <p:xfrm>
           <a:off x="502920" y="1371600"/>
-          <a:ext cx="6675120" cy="914400"/>
+          <a:ext cx="6675120" cy="1536192"/>
         </p:xfrm>
         <a:graphic>
           <a:graphicData uri="http://schemas.openxmlformats.org/drawingml/2006/table">
             <a:tbl>
               <a:tblPr/>
               <a:tblGrid>
-                <a:gridCol w="1188720"/>
-                <a:gridCol w="1371600"/>
-                <a:gridCol w="1371600"/>
-                <a:gridCol w="1371600"/>
-                <a:gridCol w="1371600"/>
+                <a:gridCol w="1188720">
+                  <a:extLst>
+                    <a:ext uri="{9D8B030D-6E8A-4147-A177-3AD203B41FA5}">
+                      <a16:colId xmlns:a16="http://schemas.microsoft.com/office/drawing/2014/main" val="20000"/>
+                    </a:ext>
+                  </a:extLst>
+                </a:gridCol>
+                <a:gridCol w="1371600">
+                  <a:extLst>
+                    <a:ext uri="{9D8B030D-6E8A-4147-A177-3AD203B41FA5}">
+                      <a16:colId xmlns:a16="http://schemas.microsoft.com/office/drawing/2014/main" val="20001"/>
+                    </a:ext>
+                  </a:extLst>
+                </a:gridCol>
+                <a:gridCol w="1371600">
+                  <a:extLst>
+                    <a:ext uri="{9D8B030D-6E8A-4147-A177-3AD203B41FA5}">
+                      <a16:colId xmlns:a16="http://schemas.microsoft.com/office/drawing/2014/main" val="20002"/>
+                    </a:ext>
+                  </a:extLst>
+                </a:gridCol>
+                <a:gridCol w="1371600">
+                  <a:extLst>
+                    <a:ext uri="{9D8B030D-6E8A-4147-A177-3AD203B41FA5}">
+                      <a16:colId xmlns:a16="http://schemas.microsoft.com/office/drawing/2014/main" val="20003"/>
+                    </a:ext>
+                  </a:extLst>
+                </a:gridCol>
+                <a:gridCol w="1371600">
+                  <a:extLst>
+                    <a:ext uri="{9D8B030D-6E8A-4147-A177-3AD203B41FA5}">
+                      <a16:colId xmlns:a16="http://schemas.microsoft.com/office/drawing/2014/main" val="20004"/>
+                    </a:ext>
+                  </a:extLst>
+                </a:gridCol>
               </a:tblGrid>
               <a:tr h="384048">
                 <a:tc>
@@ -9643,7 +9492,7 @@
                     <a:bodyPr/>
                     <a:lstStyle/>
                     <a:p>
-                      <a:pPr indent="0" marL="0">
+                      <a:pPr marL="0" indent="0">
                         <a:buNone/>
                       </a:pPr>
                       <a:endParaRPr lang="en-US" sz="1300" dirty="0">
@@ -9653,7 +9502,7 @@
                       </a:endParaRPr>
                     </a:p>
                   </a:txBody>
-                  <a:tcPr marL="91440" marR="91440" marT="45720" marB="45720" anchor="ctr">
+                  <a:tcPr anchor="ctr">
                     <a:lnL w="6350" cap="flat" cmpd="sng" algn="ctr">
                       <a:solidFill>
                         <a:srgbClr val="D8D6CF"/>
@@ -9700,7 +9549,7 @@
                     <a:bodyPr/>
                     <a:lstStyle/>
                     <a:p>
-                      <a:pPr indent="0" marL="0">
+                      <a:pPr marL="0" indent="0">
                         <a:buNone/>
                       </a:pPr>
                       <a:r>
@@ -9721,7 +9570,7 @@
                       </a:endParaRPr>
                     </a:p>
                   </a:txBody>
-                  <a:tcPr marL="91440" marR="91440" marT="45720" marB="45720" anchor="ctr">
+                  <a:tcPr anchor="ctr">
                     <a:lnL w="6350" cap="flat" cmpd="sng" algn="ctr">
                       <a:solidFill>
                         <a:srgbClr val="D8D6CF"/>
@@ -9768,7 +9617,7 @@
                     <a:bodyPr/>
                     <a:lstStyle/>
                     <a:p>
-                      <a:pPr indent="0" marL="0">
+                      <a:pPr marL="0" indent="0">
                         <a:buNone/>
                       </a:pPr>
                       <a:r>
@@ -9789,7 +9638,7 @@
                       </a:endParaRPr>
                     </a:p>
                   </a:txBody>
-                  <a:tcPr marL="91440" marR="91440" marT="45720" marB="45720" anchor="ctr">
+                  <a:tcPr anchor="ctr">
                     <a:lnL w="6350" cap="flat" cmpd="sng" algn="ctr">
                       <a:solidFill>
                         <a:srgbClr val="D8D6CF"/>
@@ -9836,7 +9685,7 @@
                     <a:bodyPr/>
                     <a:lstStyle/>
                     <a:p>
-                      <a:pPr indent="0" marL="0">
+                      <a:pPr marL="0" indent="0">
                         <a:buNone/>
                       </a:pPr>
                       <a:r>
@@ -9857,7 +9706,7 @@
                       </a:endParaRPr>
                     </a:p>
                   </a:txBody>
-                  <a:tcPr marL="91440" marR="91440" marT="45720" marB="45720" anchor="ctr">
+                  <a:tcPr anchor="ctr">
                     <a:lnL w="6350" cap="flat" cmpd="sng" algn="ctr">
                       <a:solidFill>
                         <a:srgbClr val="D8D6CF"/>
@@ -9904,7 +9753,7 @@
                     <a:bodyPr/>
                     <a:lstStyle/>
                     <a:p>
-                      <a:pPr indent="0" marL="0">
+                      <a:pPr marL="0" indent="0">
                         <a:buNone/>
                       </a:pPr>
                       <a:r>
@@ -9925,7 +9774,7 @@
                       </a:endParaRPr>
                     </a:p>
                   </a:txBody>
-                  <a:tcPr marL="91440" marR="91440" marT="45720" marB="45720" anchor="ctr">
+                  <a:tcPr anchor="ctr">
                     <a:lnL w="6350" cap="flat" cmpd="sng" algn="ctr">
                       <a:solidFill>
                         <a:srgbClr val="D8D6CF"/>
@@ -9967,6 +9816,11 @@
                     </a:solidFill>
                   </a:tcPr>
                 </a:tc>
+                <a:extLst>
+                  <a:ext uri="{0D108BD9-81ED-4DB2-BD59-A6C34878D82A}">
+                    <a16:rowId xmlns:a16="http://schemas.microsoft.com/office/drawing/2014/main" val="10000"/>
+                  </a:ext>
+                </a:extLst>
               </a:tr>
               <a:tr h="384048">
                 <a:tc>
@@ -9974,7 +9828,7 @@
                     <a:bodyPr/>
                     <a:lstStyle/>
                     <a:p>
-                      <a:pPr indent="0" marL="0">
+                      <a:pPr marL="0" indent="0">
                         <a:buNone/>
                       </a:pPr>
                       <a:r>
@@ -9995,7 +9849,7 @@
                       </a:endParaRPr>
                     </a:p>
                   </a:txBody>
-                  <a:tcPr marL="91440" marR="91440" marT="45720" marB="45720" anchor="ctr">
+                  <a:tcPr anchor="ctr">
                     <a:lnL w="6350" cap="flat" cmpd="sng" algn="ctr">
                       <a:solidFill>
                         <a:srgbClr val="D8D6CF"/>
@@ -10042,7 +9896,7 @@
                     <a:bodyPr/>
                     <a:lstStyle/>
                     <a:p>
-                      <a:pPr indent="0" marL="0">
+                      <a:pPr marL="0" indent="0">
                         <a:buNone/>
                       </a:pPr>
                       <a:r>
@@ -10063,7 +9917,7 @@
                       </a:endParaRPr>
                     </a:p>
                   </a:txBody>
-                  <a:tcPr marL="91440" marR="91440" marT="45720" marB="45720" anchor="ctr">
+                  <a:tcPr anchor="ctr">
                     <a:lnL w="6350" cap="flat" cmpd="sng" algn="ctr">
                       <a:solidFill>
                         <a:srgbClr val="D8D6CF"/>
@@ -10110,7 +9964,7 @@
                     <a:bodyPr/>
                     <a:lstStyle/>
                     <a:p>
-                      <a:pPr indent="0" marL="0">
+                      <a:pPr marL="0" indent="0">
                         <a:buNone/>
                       </a:pPr>
                       <a:r>
@@ -10131,7 +9985,7 @@
                       </a:endParaRPr>
                     </a:p>
                   </a:txBody>
-                  <a:tcPr marL="91440" marR="91440" marT="45720" marB="45720" anchor="ctr">
+                  <a:tcPr anchor="ctr">
                     <a:lnL w="6350" cap="flat" cmpd="sng" algn="ctr">
                       <a:solidFill>
                         <a:srgbClr val="D8D6CF"/>
@@ -10178,7 +10032,7 @@
                     <a:bodyPr/>
                     <a:lstStyle/>
                     <a:p>
-                      <a:pPr indent="0" marL="0">
+                      <a:pPr marL="0" indent="0">
                         <a:buNone/>
                       </a:pPr>
                       <a:r>
@@ -10199,7 +10053,7 @@
                       </a:endParaRPr>
                     </a:p>
                   </a:txBody>
-                  <a:tcPr marL="91440" marR="91440" marT="45720" marB="45720" anchor="ctr">
+                  <a:tcPr anchor="ctr">
                     <a:lnL w="6350" cap="flat" cmpd="sng" algn="ctr">
                       <a:solidFill>
                         <a:srgbClr val="D8D6CF"/>
@@ -10246,7 +10100,7 @@
                     <a:bodyPr/>
                     <a:lstStyle/>
                     <a:p>
-                      <a:pPr indent="0" marL="0">
+                      <a:pPr marL="0" indent="0">
                         <a:buNone/>
                       </a:pPr>
                       <a:r>
@@ -10267,7 +10121,7 @@
                       </a:endParaRPr>
                     </a:p>
                   </a:txBody>
-                  <a:tcPr marL="91440" marR="91440" marT="45720" marB="45720" anchor="ctr">
+                  <a:tcPr anchor="ctr">
                     <a:lnL w="6350" cap="flat" cmpd="sng" algn="ctr">
                       <a:solidFill>
                         <a:srgbClr val="D8D6CF"/>
@@ -10309,6 +10163,11 @@
                     </a:solidFill>
                   </a:tcPr>
                 </a:tc>
+                <a:extLst>
+                  <a:ext uri="{0D108BD9-81ED-4DB2-BD59-A6C34878D82A}">
+                    <a16:rowId xmlns:a16="http://schemas.microsoft.com/office/drawing/2014/main" val="10001"/>
+                  </a:ext>
+                </a:extLst>
               </a:tr>
               <a:tr h="384048">
                 <a:tc>
@@ -10316,7 +10175,7 @@
                     <a:bodyPr/>
                     <a:lstStyle/>
                     <a:p>
-                      <a:pPr indent="0" marL="0">
+                      <a:pPr marL="0" indent="0">
                         <a:buNone/>
                       </a:pPr>
                       <a:r>
@@ -10337,7 +10196,7 @@
                       </a:endParaRPr>
                     </a:p>
                   </a:txBody>
-                  <a:tcPr marL="91440" marR="91440" marT="45720" marB="45720" anchor="ctr">
+                  <a:tcPr anchor="ctr">
                     <a:lnL w="6350" cap="flat" cmpd="sng" algn="ctr">
                       <a:solidFill>
                         <a:srgbClr val="D8D6CF"/>
@@ -10384,7 +10243,7 @@
                     <a:bodyPr/>
                     <a:lstStyle/>
                     <a:p>
-                      <a:pPr indent="0" marL="0">
+                      <a:pPr marL="0" indent="0">
                         <a:buNone/>
                       </a:pPr>
                       <a:r>
@@ -10405,7 +10264,7 @@
                       </a:endParaRPr>
                     </a:p>
                   </a:txBody>
-                  <a:tcPr marL="91440" marR="91440" marT="45720" marB="45720" anchor="ctr">
+                  <a:tcPr anchor="ctr">
                     <a:lnL w="6350" cap="flat" cmpd="sng" algn="ctr">
                       <a:solidFill>
                         <a:srgbClr val="D8D6CF"/>
@@ -10452,7 +10311,7 @@
                     <a:bodyPr/>
                     <a:lstStyle/>
                     <a:p>
-                      <a:pPr indent="0" marL="0">
+                      <a:pPr marL="0" indent="0">
                         <a:buNone/>
                       </a:pPr>
                       <a:r>
@@ -10473,7 +10332,7 @@
                       </a:endParaRPr>
                     </a:p>
                   </a:txBody>
-                  <a:tcPr marL="91440" marR="91440" marT="45720" marB="45720" anchor="ctr">
+                  <a:tcPr anchor="ctr">
                     <a:lnL w="6350" cap="flat" cmpd="sng" algn="ctr">
                       <a:solidFill>
                         <a:srgbClr val="D8D6CF"/>
@@ -10520,7 +10379,7 @@
                     <a:bodyPr/>
                     <a:lstStyle/>
                     <a:p>
-                      <a:pPr indent="0" marL="0">
+                      <a:pPr marL="0" indent="0">
                         <a:buNone/>
                       </a:pPr>
                       <a:r>
@@ -10541,7 +10400,7 @@
                       </a:endParaRPr>
                     </a:p>
                   </a:txBody>
-                  <a:tcPr marL="91440" marR="91440" marT="45720" marB="45720" anchor="ctr">
+                  <a:tcPr anchor="ctr">
                     <a:lnL w="6350" cap="flat" cmpd="sng" algn="ctr">
                       <a:solidFill>
                         <a:srgbClr val="D8D6CF"/>
@@ -10588,7 +10447,7 @@
                     <a:bodyPr/>
                     <a:lstStyle/>
                     <a:p>
-                      <a:pPr indent="0" marL="0">
+                      <a:pPr marL="0" indent="0">
                         <a:buNone/>
                       </a:pPr>
                       <a:r>
@@ -10609,7 +10468,7 @@
                       </a:endParaRPr>
                     </a:p>
                   </a:txBody>
-                  <a:tcPr marL="91440" marR="91440" marT="45720" marB="45720" anchor="ctr">
+                  <a:tcPr anchor="ctr">
                     <a:lnL w="6350" cap="flat" cmpd="sng" algn="ctr">
                       <a:solidFill>
                         <a:srgbClr val="D8D6CF"/>
@@ -10651,6 +10510,11 @@
                     </a:solidFill>
                   </a:tcPr>
                 </a:tc>
+                <a:extLst>
+                  <a:ext uri="{0D108BD9-81ED-4DB2-BD59-A6C34878D82A}">
+                    <a16:rowId xmlns:a16="http://schemas.microsoft.com/office/drawing/2014/main" val="10002"/>
+                  </a:ext>
+                </a:extLst>
               </a:tr>
               <a:tr h="384048">
                 <a:tc>
@@ -10658,7 +10522,7 @@
                     <a:bodyPr/>
                     <a:lstStyle/>
                     <a:p>
-                      <a:pPr indent="0" marL="0">
+                      <a:pPr marL="0" indent="0">
                         <a:buNone/>
                       </a:pPr>
                       <a:r>
@@ -10679,7 +10543,7 @@
                       </a:endParaRPr>
                     </a:p>
                   </a:txBody>
-                  <a:tcPr marL="91440" marR="91440" marT="45720" marB="45720" anchor="ctr">
+                  <a:tcPr anchor="ctr">
                     <a:lnL w="6350" cap="flat" cmpd="sng" algn="ctr">
                       <a:solidFill>
                         <a:srgbClr val="D8D6CF"/>
@@ -10726,7 +10590,7 @@
                     <a:bodyPr/>
                     <a:lstStyle/>
                     <a:p>
-                      <a:pPr indent="0" marL="0">
+                      <a:pPr marL="0" indent="0">
                         <a:buNone/>
                       </a:pPr>
                       <a:r>
@@ -10747,7 +10611,7 @@
                       </a:endParaRPr>
                     </a:p>
                   </a:txBody>
-                  <a:tcPr marL="91440" marR="91440" marT="45720" marB="45720" anchor="ctr">
+                  <a:tcPr anchor="ctr">
                     <a:lnL w="6350" cap="flat" cmpd="sng" algn="ctr">
                       <a:solidFill>
                         <a:srgbClr val="D8D6CF"/>
@@ -10794,7 +10658,7 @@
                     <a:bodyPr/>
                     <a:lstStyle/>
                     <a:p>
-                      <a:pPr indent="0" marL="0">
+                      <a:pPr marL="0" indent="0">
                         <a:buNone/>
                       </a:pPr>
                       <a:r>
@@ -10815,7 +10679,7 @@
                       </a:endParaRPr>
                     </a:p>
                   </a:txBody>
-                  <a:tcPr marL="91440" marR="91440" marT="45720" marB="45720" anchor="ctr">
+                  <a:tcPr anchor="ctr">
                     <a:lnL w="6350" cap="flat" cmpd="sng" algn="ctr">
                       <a:solidFill>
                         <a:srgbClr val="D8D6CF"/>
@@ -10862,7 +10726,7 @@
                     <a:bodyPr/>
                     <a:lstStyle/>
                     <a:p>
-                      <a:pPr indent="0" marL="0">
+                      <a:pPr marL="0" indent="0">
                         <a:buNone/>
                       </a:pPr>
                       <a:r>
@@ -10883,7 +10747,7 @@
                       </a:endParaRPr>
                     </a:p>
                   </a:txBody>
-                  <a:tcPr marL="91440" marR="91440" marT="45720" marB="45720" anchor="ctr">
+                  <a:tcPr anchor="ctr">
                     <a:lnL w="6350" cap="flat" cmpd="sng" algn="ctr">
                       <a:solidFill>
                         <a:srgbClr val="D8D6CF"/>
@@ -10930,7 +10794,7 @@
                     <a:bodyPr/>
                     <a:lstStyle/>
                     <a:p>
-                      <a:pPr indent="0" marL="0">
+                      <a:pPr marL="0" indent="0">
                         <a:buNone/>
                       </a:pPr>
                       <a:r>
@@ -10951,7 +10815,7 @@
                       </a:endParaRPr>
                     </a:p>
                   </a:txBody>
-                  <a:tcPr marL="91440" marR="91440" marT="45720" marB="45720" anchor="ctr">
+                  <a:tcPr anchor="ctr">
                     <a:lnL w="6350" cap="flat" cmpd="sng" algn="ctr">
                       <a:solidFill>
                         <a:srgbClr val="D8D6CF"/>
@@ -10993,6 +10857,11 @@
                     </a:solidFill>
                   </a:tcPr>
                 </a:tc>
+                <a:extLst>
+                  <a:ext uri="{0D108BD9-81ED-4DB2-BD59-A6C34878D82A}">
+                    <a16:rowId xmlns:a16="http://schemas.microsoft.com/office/drawing/2014/main" val="10003"/>
+                  </a:ext>
+                </a:extLst>
               </a:tr>
             </a:tbl>
           </a:graphicData>
@@ -11019,7 +10888,7 @@
           <a:bodyPr wrap="square" lIns="0" tIns="0" rIns="0" bIns="0" rtlCol="0" anchor="ctr"/>
           <a:lstStyle/>
           <a:p>
-            <a:pPr indent="0" marL="0">
+            <a:pPr marL="0" indent="0">
               <a:buNone/>
             </a:pPr>
             <a:r>
@@ -11033,9 +10902,6 @@
               </a:rPr>
               <a:t>n = 1,025 </a:t>
             </a:r>
-            <a:pPr indent="0" marL="0">
-              <a:buNone/>
-            </a:pPr>
             <a:r>
               <a:rPr lang="en-US" sz="1400" dirty="0">
                 <a:solidFill>
@@ -11048,9 +10914,6 @@
               <a:t>combustion model types — every configuration manufacturers legally filed for model year 2024
 </a:t>
             </a:r>
-            <a:pPr indent="0" marL="0">
-              <a:buNone/>
-            </a:pPr>
             <a:r>
               <a:rPr lang="en-US" sz="2200" b="1" dirty="0">
                 <a:solidFill>
@@ -11062,9 +10925,6 @@
               </a:rPr>
               <a:t>205:1 </a:t>
             </a:r>
-            <a:pPr indent="0" marL="0">
-              <a:buNone/>
-            </a:pPr>
             <a:r>
               <a:rPr lang="en-US" sz="1400" dirty="0">
                 <a:solidFill>
@@ -11077,9 +10937,6 @@
               <a:t>observations per estimated parameter (course rule of thumb: 10:1)
 </a:t>
             </a:r>
-            <a:pPr indent="0" marL="0">
-              <a:buNone/>
-            </a:pPr>
             <a:r>
               <a:rPr lang="en-US" sz="2200" b="1" dirty="0">
                 <a:solidFill>
@@ -11091,9 +10948,6 @@
               </a:rPr>
               <a:t>100% </a:t>
             </a:r>
-            <a:pPr indent="0" marL="0">
-              <a:buNone/>
-            </a:pPr>
             <a:r>
               <a:rPr lang="en-US" sz="1400" dirty="0">
                 <a:solidFill>
@@ -11130,7 +10984,7 @@
           <a:bodyPr wrap="square" lIns="0" tIns="0" rIns="0" bIns="0" rtlCol="0" anchor="ctr"/>
           <a:lstStyle/>
           <a:p>
-            <a:pPr indent="0" marL="0">
+            <a:pPr marL="0" indent="0">
               <a:buNone/>
             </a:pPr>
             <a:r>
@@ -11150,7 +11004,7 @@
       </p:sp>
       <p:sp>
         <p:nvSpPr>
-          <p:cNvPr id="6" name="Text 3"/>
+          <p:cNvPr id="3" name="Text 3"/>
           <p:cNvSpPr txBox="1"/>
           <p:nvPr/>
         </p:nvSpPr>
@@ -11169,7 +11023,7 @@
           <a:bodyPr wrap="square" lIns="0" tIns="0" rIns="0" bIns="0" rtlCol="0" anchor="ctr"/>
           <a:lstStyle/>
           <a:p>
-            <a:pPr indent="0" marL="0">
+            <a:pPr marL="0" indent="0">
               <a:buNone/>
             </a:pPr>
             <a:r>
@@ -11233,7 +11087,7 @@
           <a:bodyPr wrap="square" lIns="0" tIns="0" rIns="0" bIns="0" rtlCol="0" anchor="ctr"/>
           <a:lstStyle/>
           <a:p>
-            <a:pPr indent="0" marL="0">
+            <a:pPr marL="0" indent="0">
               <a:buNone/>
             </a:pPr>
             <a:r>
@@ -11253,14 +11107,14 @@
       </p:sp>
       <p:pic>
         <p:nvPicPr>
-          <p:cNvPr id="3" name="Image 0" descr="C:\Users\Samson\Desktop\Homework\OS3180\Final Project\charts\fig9_footprint_vs_mpg_2024.png">    </p:cNvPr>
+          <p:cNvPr id="3" name="Image 0" descr="C:\Users\Samson\Desktop\Homework\OS3180\Final Project\charts\fig9_footprint_vs_mpg_2024.png"/>
           <p:cNvPicPr>
             <a:picLocks noChangeAspect="1"/>
           </p:cNvPicPr>
           <p:nvPr/>
         </p:nvPicPr>
         <p:blipFill>
-          <a:blip r:embed="rId1"/>
+          <a:blip r:embed="rId3"/>
           <a:stretch>
             <a:fillRect/>
           </a:stretch>
@@ -11296,7 +11150,7 @@
           <a:bodyPr wrap="square" lIns="0" tIns="0" rIns="0" bIns="0" rtlCol="0" anchor="ctr"/>
           <a:lstStyle/>
           <a:p>
-            <a:pPr indent="0" marL="0">
+            <a:pPr marL="0" indent="0">
               <a:buNone/>
             </a:pPr>
             <a:r>
@@ -11360,7 +11214,7 @@
           <a:bodyPr wrap="square" lIns="0" tIns="0" rIns="0" bIns="0" rtlCol="0" anchor="ctr"/>
           <a:lstStyle/>
           <a:p>
-            <a:pPr indent="0" marL="0">
+            <a:pPr marL="0" indent="0">
               <a:buNone/>
             </a:pPr>
             <a:r>
@@ -11399,6 +11253,13 @@
           </a:solidFill>
           <a:ln/>
         </p:spPr>
+        <p:txBody>
+          <a:bodyPr/>
+          <a:lstStyle/>
+          <a:p>
+            <a:endParaRPr lang="en-US"/>
+          </a:p>
+        </p:txBody>
       </p:sp>
       <p:sp>
         <p:nvSpPr>
@@ -11421,7 +11282,7 @@
           <a:bodyPr wrap="square" lIns="0" tIns="0" rIns="0" bIns="0" rtlCol="0" anchor="ctr"/>
           <a:lstStyle/>
           <a:p>
-            <a:pPr indent="0" marL="0">
+            <a:pPr marL="0" indent="0">
               <a:buNone/>
             </a:pPr>
             <a:r>
@@ -11458,6 +11319,13 @@
           </a:solidFill>
           <a:ln/>
         </p:spPr>
+        <p:txBody>
+          <a:bodyPr/>
+          <a:lstStyle/>
+          <a:p>
+            <a:endParaRPr lang="en-US"/>
+          </a:p>
+        </p:txBody>
       </p:sp>
       <p:sp>
         <p:nvSpPr>
@@ -11480,7 +11348,7 @@
           <a:bodyPr wrap="square" lIns="0" tIns="0" rIns="0" bIns="0" rtlCol="0" anchor="ctr"/>
           <a:lstStyle/>
           <a:p>
-            <a:pPr algn="ctr" indent="0" marL="0">
+            <a:pPr marL="0" indent="0" algn="ctr">
               <a:buNone/>
             </a:pPr>
             <a:r>
@@ -11519,7 +11387,7 @@
           <a:bodyPr wrap="square" lIns="0" tIns="0" rIns="0" bIns="0" rtlCol="0" anchor="ctr"/>
           <a:lstStyle/>
           <a:p>
-            <a:pPr indent="0" marL="0">
+            <a:pPr marL="0" indent="0">
               <a:buNone/>
             </a:pPr>
             <a:r>
@@ -11534,9 +11402,6 @@
               <a:t>Multiplicative physics
 </a:t>
             </a:r>
-            <a:pPr indent="0" marL="0">
-              <a:buNone/>
-            </a:pPr>
             <a:r>
               <a:rPr lang="en-US" sz="1400" dirty="0">
                 <a:solidFill>
@@ -11571,6 +11436,13 @@
           </a:solidFill>
           <a:ln/>
         </p:spPr>
+        <p:txBody>
+          <a:bodyPr/>
+          <a:lstStyle/>
+          <a:p>
+            <a:endParaRPr lang="en-US"/>
+          </a:p>
+        </p:txBody>
       </p:sp>
       <p:sp>
         <p:nvSpPr>
@@ -11593,7 +11465,7 @@
           <a:bodyPr wrap="square" lIns="0" tIns="0" rIns="0" bIns="0" rtlCol="0" anchor="ctr"/>
           <a:lstStyle/>
           <a:p>
-            <a:pPr algn="ctr" indent="0" marL="0">
+            <a:pPr marL="0" indent="0" algn="ctr">
               <a:buNone/>
             </a:pPr>
             <a:r>
@@ -11632,7 +11504,7 @@
           <a:bodyPr wrap="square" lIns="0" tIns="0" rIns="0" bIns="0" rtlCol="0" anchor="ctr"/>
           <a:lstStyle/>
           <a:p>
-            <a:pPr indent="0" marL="0">
+            <a:pPr marL="0" indent="0">
               <a:buNone/>
             </a:pPr>
             <a:r>
@@ -11647,9 +11519,6 @@
               <a:t>Elasticity coefficients
 </a:t>
             </a:r>
-            <a:pPr indent="0" marL="0">
-              <a:buNone/>
-            </a:pPr>
             <a:r>
               <a:rPr lang="en-US" sz="1400" dirty="0">
                 <a:solidFill>
@@ -11684,6 +11553,13 @@
           </a:solidFill>
           <a:ln/>
         </p:spPr>
+        <p:txBody>
+          <a:bodyPr/>
+          <a:lstStyle/>
+          <a:p>
+            <a:endParaRPr lang="en-US"/>
+          </a:p>
+        </p:txBody>
       </p:sp>
       <p:sp>
         <p:nvSpPr>
@@ -11706,7 +11582,7 @@
           <a:bodyPr wrap="square" lIns="0" tIns="0" rIns="0" bIns="0" rtlCol="0" anchor="ctr"/>
           <a:lstStyle/>
           <a:p>
-            <a:pPr algn="ctr" indent="0" marL="0">
+            <a:pPr marL="0" indent="0" algn="ctr">
               <a:buNone/>
             </a:pPr>
             <a:r>
@@ -11745,7 +11621,7 @@
           <a:bodyPr wrap="square" lIns="0" tIns="0" rIns="0" bIns="0" rtlCol="0" anchor="ctr"/>
           <a:lstStyle/>
           <a:p>
-            <a:pPr indent="0" marL="0">
+            <a:pPr marL="0" indent="0">
               <a:buNone/>
             </a:pPr>
             <a:r>
@@ -11760,9 +11636,6 @@
               <a:t>Honest uncertainty
 </a:t>
             </a:r>
-            <a:pPr indent="0" marL="0">
-              <a:buNone/>
-            </a:pPr>
             <a:r>
               <a:rPr lang="en-US" sz="1400" dirty="0">
                 <a:solidFill>
@@ -11799,7 +11672,7 @@
           <a:bodyPr wrap="square" lIns="0" tIns="0" rIns="0" bIns="0" rtlCol="0" anchor="ctr"/>
           <a:lstStyle/>
           <a:p>
-            <a:pPr indent="0" marL="0">
+            <a:pPr marL="0" indent="0">
               <a:buNone/>
             </a:pPr>
             <a:r>
@@ -11863,7 +11736,7 @@
           <a:bodyPr wrap="square" lIns="0" tIns="0" rIns="0" bIns="0" rtlCol="0" anchor="ctr"/>
           <a:lstStyle/>
           <a:p>
-            <a:pPr indent="0" marL="0">
+            <a:pPr marL="0" indent="0">
               <a:buNone/>
             </a:pPr>
             <a:r>
@@ -11897,19 +11770,55 @@
         </p:nvGraphicFramePr>
         <p:xfrm>
           <a:off x="502920" y="1371600"/>
-          <a:ext cx="6949440" cy="914400"/>
+          <a:ext cx="6949440" cy="2414016"/>
         </p:xfrm>
         <a:graphic>
           <a:graphicData uri="http://schemas.openxmlformats.org/drawingml/2006/table">
             <a:tbl>
               <a:tblPr/>
               <a:tblGrid>
-                <a:gridCol w="1737360"/>
-                <a:gridCol w="1234440"/>
-                <a:gridCol w="960120"/>
-                <a:gridCol w="868680"/>
-                <a:gridCol w="1051560"/>
-                <a:gridCol w="1097280"/>
+                <a:gridCol w="1737360">
+                  <a:extLst>
+                    <a:ext uri="{9D8B030D-6E8A-4147-A177-3AD203B41FA5}">
+                      <a16:colId xmlns:a16="http://schemas.microsoft.com/office/drawing/2014/main" val="20000"/>
+                    </a:ext>
+                  </a:extLst>
+                </a:gridCol>
+                <a:gridCol w="1234440">
+                  <a:extLst>
+                    <a:ext uri="{9D8B030D-6E8A-4147-A177-3AD203B41FA5}">
+                      <a16:colId xmlns:a16="http://schemas.microsoft.com/office/drawing/2014/main" val="20001"/>
+                    </a:ext>
+                  </a:extLst>
+                </a:gridCol>
+                <a:gridCol w="960120">
+                  <a:extLst>
+                    <a:ext uri="{9D8B030D-6E8A-4147-A177-3AD203B41FA5}">
+                      <a16:colId xmlns:a16="http://schemas.microsoft.com/office/drawing/2014/main" val="20002"/>
+                    </a:ext>
+                  </a:extLst>
+                </a:gridCol>
+                <a:gridCol w="868680">
+                  <a:extLst>
+                    <a:ext uri="{9D8B030D-6E8A-4147-A177-3AD203B41FA5}">
+                      <a16:colId xmlns:a16="http://schemas.microsoft.com/office/drawing/2014/main" val="20003"/>
+                    </a:ext>
+                  </a:extLst>
+                </a:gridCol>
+                <a:gridCol w="1051560">
+                  <a:extLst>
+                    <a:ext uri="{9D8B030D-6E8A-4147-A177-3AD203B41FA5}">
+                      <a16:colId xmlns:a16="http://schemas.microsoft.com/office/drawing/2014/main" val="20004"/>
+                    </a:ext>
+                  </a:extLst>
+                </a:gridCol>
+                <a:gridCol w="1097280">
+                  <a:extLst>
+                    <a:ext uri="{9D8B030D-6E8A-4147-A177-3AD203B41FA5}">
+                      <a16:colId xmlns:a16="http://schemas.microsoft.com/office/drawing/2014/main" val="20005"/>
+                    </a:ext>
+                  </a:extLst>
+                </a:gridCol>
               </a:tblGrid>
               <a:tr h="402336">
                 <a:tc>
@@ -11917,7 +11826,7 @@
                     <a:bodyPr/>
                     <a:lstStyle/>
                     <a:p>
-                      <a:pPr indent="0" marL="0">
+                      <a:pPr marL="0" indent="0">
                         <a:buNone/>
                       </a:pPr>
                       <a:r>
@@ -11938,7 +11847,7 @@
                       </a:endParaRPr>
                     </a:p>
                   </a:txBody>
-                  <a:tcPr marL="91440" marR="91440" marT="45720" marB="45720" anchor="ctr">
+                  <a:tcPr anchor="ctr">
                     <a:lnL w="6350" cap="flat" cmpd="sng" algn="ctr">
                       <a:solidFill>
                         <a:srgbClr val="D8D6CF"/>
@@ -11985,7 +11894,7 @@
                     <a:bodyPr/>
                     <a:lstStyle/>
                     <a:p>
-                      <a:pPr indent="0" marL="0">
+                      <a:pPr marL="0" indent="0">
                         <a:buNone/>
                       </a:pPr>
                       <a:r>
@@ -12006,7 +11915,7 @@
                       </a:endParaRPr>
                     </a:p>
                   </a:txBody>
-                  <a:tcPr marL="91440" marR="91440" marT="45720" marB="45720" anchor="ctr">
+                  <a:tcPr anchor="ctr">
                     <a:lnL w="6350" cap="flat" cmpd="sng" algn="ctr">
                       <a:solidFill>
                         <a:srgbClr val="D8D6CF"/>
@@ -12053,7 +11962,7 @@
                     <a:bodyPr/>
                     <a:lstStyle/>
                     <a:p>
-                      <a:pPr indent="0" marL="0">
+                      <a:pPr marL="0" indent="0">
                         <a:buNone/>
                       </a:pPr>
                       <a:r>
@@ -12074,7 +11983,7 @@
                       </a:endParaRPr>
                     </a:p>
                   </a:txBody>
-                  <a:tcPr marL="91440" marR="91440" marT="45720" marB="45720" anchor="ctr">
+                  <a:tcPr anchor="ctr">
                     <a:lnL w="6350" cap="flat" cmpd="sng" algn="ctr">
                       <a:solidFill>
                         <a:srgbClr val="D8D6CF"/>
@@ -12121,7 +12030,7 @@
                     <a:bodyPr/>
                     <a:lstStyle/>
                     <a:p>
-                      <a:pPr indent="0" marL="0">
+                      <a:pPr marL="0" indent="0">
                         <a:buNone/>
                       </a:pPr>
                       <a:r>
@@ -12142,7 +12051,7 @@
                       </a:endParaRPr>
                     </a:p>
                   </a:txBody>
-                  <a:tcPr marL="91440" marR="91440" marT="45720" marB="45720" anchor="ctr">
+                  <a:tcPr anchor="ctr">
                     <a:lnL w="6350" cap="flat" cmpd="sng" algn="ctr">
                       <a:solidFill>
                         <a:srgbClr val="D8D6CF"/>
@@ -12189,7 +12098,7 @@
                     <a:bodyPr/>
                     <a:lstStyle/>
                     <a:p>
-                      <a:pPr indent="0" marL="0">
+                      <a:pPr marL="0" indent="0">
                         <a:buNone/>
                       </a:pPr>
                       <a:r>
@@ -12210,7 +12119,7 @@
                       </a:endParaRPr>
                     </a:p>
                   </a:txBody>
-                  <a:tcPr marL="91440" marR="91440" marT="45720" marB="45720" anchor="ctr">
+                  <a:tcPr anchor="ctr">
                     <a:lnL w="6350" cap="flat" cmpd="sng" algn="ctr">
                       <a:solidFill>
                         <a:srgbClr val="D8D6CF"/>
@@ -12257,7 +12166,7 @@
                     <a:bodyPr/>
                     <a:lstStyle/>
                     <a:p>
-                      <a:pPr indent="0" marL="0">
+                      <a:pPr marL="0" indent="0">
                         <a:buNone/>
                       </a:pPr>
                       <a:r>
@@ -12278,7 +12187,7 @@
                       </a:endParaRPr>
                     </a:p>
                   </a:txBody>
-                  <a:tcPr marL="91440" marR="91440" marT="45720" marB="45720" anchor="ctr">
+                  <a:tcPr anchor="ctr">
                     <a:lnL w="6350" cap="flat" cmpd="sng" algn="ctr">
                       <a:solidFill>
                         <a:srgbClr val="D8D6CF"/>
@@ -12320,6 +12229,11 @@
                     </a:solidFill>
                   </a:tcPr>
                 </a:tc>
+                <a:extLst>
+                  <a:ext uri="{0D108BD9-81ED-4DB2-BD59-A6C34878D82A}">
+                    <a16:rowId xmlns:a16="http://schemas.microsoft.com/office/drawing/2014/main" val="10000"/>
+                  </a:ext>
+                </a:extLst>
               </a:tr>
               <a:tr h="402336">
                 <a:tc>
@@ -12327,7 +12241,7 @@
                     <a:bodyPr/>
                     <a:lstStyle/>
                     <a:p>
-                      <a:pPr indent="0" marL="0">
+                      <a:pPr marL="0" indent="0">
                         <a:buNone/>
                       </a:pPr>
                       <a:r>
@@ -12348,7 +12262,7 @@
                       </a:endParaRPr>
                     </a:p>
                   </a:txBody>
-                  <a:tcPr marL="91440" marR="91440" marT="45720" marB="45720" anchor="ctr">
+                  <a:tcPr anchor="ctr">
                     <a:lnL w="6350" cap="flat" cmpd="sng" algn="ctr">
                       <a:solidFill>
                         <a:srgbClr val="D8D6CF"/>
@@ -12395,7 +12309,7 @@
                     <a:bodyPr/>
                     <a:lstStyle/>
                     <a:p>
-                      <a:pPr indent="0" marL="0">
+                      <a:pPr marL="0" indent="0">
                         <a:buNone/>
                       </a:pPr>
                       <a:r>
@@ -12416,7 +12330,7 @@
                       </a:endParaRPr>
                     </a:p>
                   </a:txBody>
-                  <a:tcPr marL="91440" marR="91440" marT="45720" marB="45720" anchor="ctr">
+                  <a:tcPr anchor="ctr">
                     <a:lnL w="6350" cap="flat" cmpd="sng" algn="ctr">
                       <a:solidFill>
                         <a:srgbClr val="D8D6CF"/>
@@ -12463,7 +12377,7 @@
                     <a:bodyPr/>
                     <a:lstStyle/>
                     <a:p>
-                      <a:pPr indent="0" marL="0">
+                      <a:pPr marL="0" indent="0">
                         <a:buNone/>
                       </a:pPr>
                       <a:r>
@@ -12484,7 +12398,7 @@
                       </a:endParaRPr>
                     </a:p>
                   </a:txBody>
-                  <a:tcPr marL="91440" marR="91440" marT="45720" marB="45720" anchor="ctr">
+                  <a:tcPr anchor="ctr">
                     <a:lnL w="6350" cap="flat" cmpd="sng" algn="ctr">
                       <a:solidFill>
                         <a:srgbClr val="D8D6CF"/>
@@ -12531,7 +12445,7 @@
                     <a:bodyPr/>
                     <a:lstStyle/>
                     <a:p>
-                      <a:pPr indent="0" marL="0">
+                      <a:pPr marL="0" indent="0">
                         <a:buNone/>
                       </a:pPr>
                       <a:r>
@@ -12552,7 +12466,7 @@
                       </a:endParaRPr>
                     </a:p>
                   </a:txBody>
-                  <a:tcPr marL="91440" marR="91440" marT="45720" marB="45720" anchor="ctr">
+                  <a:tcPr anchor="ctr">
                     <a:lnL w="6350" cap="flat" cmpd="sng" algn="ctr">
                       <a:solidFill>
                         <a:srgbClr val="D8D6CF"/>
@@ -12599,7 +12513,7 @@
                     <a:bodyPr/>
                     <a:lstStyle/>
                     <a:p>
-                      <a:pPr indent="0" marL="0">
+                      <a:pPr marL="0" indent="0">
                         <a:buNone/>
                       </a:pPr>
                       <a:r>
@@ -12620,7 +12534,7 @@
                       </a:endParaRPr>
                     </a:p>
                   </a:txBody>
-                  <a:tcPr marL="91440" marR="91440" marT="45720" marB="45720" anchor="ctr">
+                  <a:tcPr anchor="ctr">
                     <a:lnL w="6350" cap="flat" cmpd="sng" algn="ctr">
                       <a:solidFill>
                         <a:srgbClr val="D8D6CF"/>
@@ -12667,7 +12581,7 @@
                     <a:bodyPr/>
                     <a:lstStyle/>
                     <a:p>
-                      <a:pPr indent="0" marL="0">
+                      <a:pPr marL="0" indent="0">
                         <a:buNone/>
                       </a:pPr>
                       <a:r>
@@ -12688,7 +12602,7 @@
                       </a:endParaRPr>
                     </a:p>
                   </a:txBody>
-                  <a:tcPr marL="91440" marR="91440" marT="45720" marB="45720" anchor="ctr">
+                  <a:tcPr anchor="ctr">
                     <a:lnL w="6350" cap="flat" cmpd="sng" algn="ctr">
                       <a:solidFill>
                         <a:srgbClr val="D8D6CF"/>
@@ -12730,6 +12644,11 @@
                     </a:solidFill>
                   </a:tcPr>
                 </a:tc>
+                <a:extLst>
+                  <a:ext uri="{0D108BD9-81ED-4DB2-BD59-A6C34878D82A}">
+                    <a16:rowId xmlns:a16="http://schemas.microsoft.com/office/drawing/2014/main" val="10001"/>
+                  </a:ext>
+                </a:extLst>
               </a:tr>
               <a:tr h="402336">
                 <a:tc>
@@ -12737,7 +12656,7 @@
                     <a:bodyPr/>
                     <a:lstStyle/>
                     <a:p>
-                      <a:pPr indent="0" marL="0">
+                      <a:pPr marL="0" indent="0">
                         <a:buNone/>
                       </a:pPr>
                       <a:r>
@@ -12758,7 +12677,7 @@
                       </a:endParaRPr>
                     </a:p>
                   </a:txBody>
-                  <a:tcPr marL="91440" marR="91440" marT="45720" marB="45720" anchor="ctr">
+                  <a:tcPr anchor="ctr">
                     <a:lnL w="6350" cap="flat" cmpd="sng" algn="ctr">
                       <a:solidFill>
                         <a:srgbClr val="D8D6CF"/>
@@ -12805,7 +12724,7 @@
                     <a:bodyPr/>
                     <a:lstStyle/>
                     <a:p>
-                      <a:pPr indent="0" marL="0">
+                      <a:pPr marL="0" indent="0">
                         <a:buNone/>
                       </a:pPr>
                       <a:r>
@@ -12826,7 +12745,7 @@
                       </a:endParaRPr>
                     </a:p>
                   </a:txBody>
-                  <a:tcPr marL="91440" marR="91440" marT="45720" marB="45720" anchor="ctr">
+                  <a:tcPr anchor="ctr">
                     <a:lnL w="6350" cap="flat" cmpd="sng" algn="ctr">
                       <a:solidFill>
                         <a:srgbClr val="D8D6CF"/>
@@ -12873,7 +12792,7 @@
                     <a:bodyPr/>
                     <a:lstStyle/>
                     <a:p>
-                      <a:pPr indent="0" marL="0">
+                      <a:pPr marL="0" indent="0">
                         <a:buNone/>
                       </a:pPr>
                       <a:r>
@@ -12894,7 +12813,7 @@
                       </a:endParaRPr>
                     </a:p>
                   </a:txBody>
-                  <a:tcPr marL="91440" marR="91440" marT="45720" marB="45720" anchor="ctr">
+                  <a:tcPr anchor="ctr">
                     <a:lnL w="6350" cap="flat" cmpd="sng" algn="ctr">
                       <a:solidFill>
                         <a:srgbClr val="D8D6CF"/>
@@ -12941,7 +12860,7 @@
                     <a:bodyPr/>
                     <a:lstStyle/>
                     <a:p>
-                      <a:pPr indent="0" marL="0">
+                      <a:pPr marL="0" indent="0">
                         <a:buNone/>
                       </a:pPr>
                       <a:r>
@@ -12962,7 +12881,7 @@
                       </a:endParaRPr>
                     </a:p>
                   </a:txBody>
-                  <a:tcPr marL="91440" marR="91440" marT="45720" marB="45720" anchor="ctr">
+                  <a:tcPr anchor="ctr">
                     <a:lnL w="6350" cap="flat" cmpd="sng" algn="ctr">
                       <a:solidFill>
                         <a:srgbClr val="D8D6CF"/>
@@ -13009,7 +12928,7 @@
                     <a:bodyPr/>
                     <a:lstStyle/>
                     <a:p>
-                      <a:pPr indent="0" marL="0">
+                      <a:pPr marL="0" indent="0">
                         <a:buNone/>
                       </a:pPr>
                       <a:r>
@@ -13030,7 +12949,7 @@
                       </a:endParaRPr>
                     </a:p>
                   </a:txBody>
-                  <a:tcPr marL="91440" marR="91440" marT="45720" marB="45720" anchor="ctr">
+                  <a:tcPr anchor="ctr">
                     <a:lnL w="6350" cap="flat" cmpd="sng" algn="ctr">
                       <a:solidFill>
                         <a:srgbClr val="D8D6CF"/>
@@ -13077,7 +12996,7 @@
                     <a:bodyPr/>
                     <a:lstStyle/>
                     <a:p>
-                      <a:pPr indent="0" marL="0">
+                      <a:pPr marL="0" indent="0">
                         <a:buNone/>
                       </a:pPr>
                       <a:r>
@@ -13098,7 +13017,7 @@
                       </a:endParaRPr>
                     </a:p>
                   </a:txBody>
-                  <a:tcPr marL="91440" marR="91440" marT="45720" marB="45720" anchor="ctr">
+                  <a:tcPr anchor="ctr">
                     <a:lnL w="6350" cap="flat" cmpd="sng" algn="ctr">
                       <a:solidFill>
                         <a:srgbClr val="D8D6CF"/>
@@ -13140,6 +13059,11 @@
                     </a:solidFill>
                   </a:tcPr>
                 </a:tc>
+                <a:extLst>
+                  <a:ext uri="{0D108BD9-81ED-4DB2-BD59-A6C34878D82A}">
+                    <a16:rowId xmlns:a16="http://schemas.microsoft.com/office/drawing/2014/main" val="10002"/>
+                  </a:ext>
+                </a:extLst>
               </a:tr>
               <a:tr h="402336">
                 <a:tc>
@@ -13147,7 +13071,7 @@
                     <a:bodyPr/>
                     <a:lstStyle/>
                     <a:p>
-                      <a:pPr indent="0" marL="0">
+                      <a:pPr marL="0" indent="0">
                         <a:buNone/>
                       </a:pPr>
                       <a:r>
@@ -13168,7 +13092,7 @@
                       </a:endParaRPr>
                     </a:p>
                   </a:txBody>
-                  <a:tcPr marL="91440" marR="91440" marT="45720" marB="45720" anchor="ctr">
+                  <a:tcPr anchor="ctr">
                     <a:lnL w="6350" cap="flat" cmpd="sng" algn="ctr">
                       <a:solidFill>
                         <a:srgbClr val="D8D6CF"/>
@@ -13215,7 +13139,7 @@
                     <a:bodyPr/>
                     <a:lstStyle/>
                     <a:p>
-                      <a:pPr indent="0" marL="0">
+                      <a:pPr marL="0" indent="0">
                         <a:buNone/>
                       </a:pPr>
                       <a:r>
@@ -13236,7 +13160,7 @@
                       </a:endParaRPr>
                     </a:p>
                   </a:txBody>
-                  <a:tcPr marL="91440" marR="91440" marT="45720" marB="45720" anchor="ctr">
+                  <a:tcPr anchor="ctr">
                     <a:lnL w="6350" cap="flat" cmpd="sng" algn="ctr">
                       <a:solidFill>
                         <a:srgbClr val="D8D6CF"/>
@@ -13283,7 +13207,7 @@
                     <a:bodyPr/>
                     <a:lstStyle/>
                     <a:p>
-                      <a:pPr indent="0" marL="0">
+                      <a:pPr marL="0" indent="0">
                         <a:buNone/>
                       </a:pPr>
                       <a:r>
@@ -13304,7 +13228,7 @@
                       </a:endParaRPr>
                     </a:p>
                   </a:txBody>
-                  <a:tcPr marL="91440" marR="91440" marT="45720" marB="45720" anchor="ctr">
+                  <a:tcPr anchor="ctr">
                     <a:lnL w="6350" cap="flat" cmpd="sng" algn="ctr">
                       <a:solidFill>
                         <a:srgbClr val="D8D6CF"/>
@@ -13351,7 +13275,7 @@
                     <a:bodyPr/>
                     <a:lstStyle/>
                     <a:p>
-                      <a:pPr indent="0" marL="0">
+                      <a:pPr marL="0" indent="0">
                         <a:buNone/>
                       </a:pPr>
                       <a:r>
@@ -13372,7 +13296,7 @@
                       </a:endParaRPr>
                     </a:p>
                   </a:txBody>
-                  <a:tcPr marL="91440" marR="91440" marT="45720" marB="45720" anchor="ctr">
+                  <a:tcPr anchor="ctr">
                     <a:lnL w="6350" cap="flat" cmpd="sng" algn="ctr">
                       <a:solidFill>
                         <a:srgbClr val="D8D6CF"/>
@@ -13419,7 +13343,7 @@
                     <a:bodyPr/>
                     <a:lstStyle/>
                     <a:p>
-                      <a:pPr indent="0" marL="0">
+                      <a:pPr marL="0" indent="0">
                         <a:buNone/>
                       </a:pPr>
                       <a:r>
@@ -13440,7 +13364,7 @@
                       </a:endParaRPr>
                     </a:p>
                   </a:txBody>
-                  <a:tcPr marL="91440" marR="91440" marT="45720" marB="45720" anchor="ctr">
+                  <a:tcPr anchor="ctr">
                     <a:lnL w="6350" cap="flat" cmpd="sng" algn="ctr">
                       <a:solidFill>
                         <a:srgbClr val="D8D6CF"/>
@@ -13487,7 +13411,7 @@
                     <a:bodyPr/>
                     <a:lstStyle/>
                     <a:p>
-                      <a:pPr indent="0" marL="0">
+                      <a:pPr marL="0" indent="0">
                         <a:buNone/>
                       </a:pPr>
                       <a:r>
@@ -13508,7 +13432,7 @@
                       </a:endParaRPr>
                     </a:p>
                   </a:txBody>
-                  <a:tcPr marL="91440" marR="91440" marT="45720" marB="45720" anchor="ctr">
+                  <a:tcPr anchor="ctr">
                     <a:lnL w="6350" cap="flat" cmpd="sng" algn="ctr">
                       <a:solidFill>
                         <a:srgbClr val="D8D6CF"/>
@@ -13550,6 +13474,11 @@
                     </a:solidFill>
                   </a:tcPr>
                 </a:tc>
+                <a:extLst>
+                  <a:ext uri="{0D108BD9-81ED-4DB2-BD59-A6C34878D82A}">
+                    <a16:rowId xmlns:a16="http://schemas.microsoft.com/office/drawing/2014/main" val="10003"/>
+                  </a:ext>
+                </a:extLst>
               </a:tr>
               <a:tr h="402336">
                 <a:tc>
@@ -13557,7 +13486,7 @@
                     <a:bodyPr/>
                     <a:lstStyle/>
                     <a:p>
-                      <a:pPr indent="0" marL="0">
+                      <a:pPr marL="0" indent="0">
                         <a:buNone/>
                       </a:pPr>
                       <a:r>
@@ -13578,7 +13507,7 @@
                       </a:endParaRPr>
                     </a:p>
                   </a:txBody>
-                  <a:tcPr marL="91440" marR="91440" marT="45720" marB="45720" anchor="ctr">
+                  <a:tcPr anchor="ctr">
                     <a:lnL w="6350" cap="flat" cmpd="sng" algn="ctr">
                       <a:solidFill>
                         <a:srgbClr val="D8D6CF"/>
@@ -13625,7 +13554,7 @@
                     <a:bodyPr/>
                     <a:lstStyle/>
                     <a:p>
-                      <a:pPr indent="0" marL="0">
+                      <a:pPr marL="0" indent="0">
                         <a:buNone/>
                       </a:pPr>
                       <a:r>
@@ -13646,7 +13575,7 @@
                       </a:endParaRPr>
                     </a:p>
                   </a:txBody>
-                  <a:tcPr marL="91440" marR="91440" marT="45720" marB="45720" anchor="ctr">
+                  <a:tcPr anchor="ctr">
                     <a:lnL w="6350" cap="flat" cmpd="sng" algn="ctr">
                       <a:solidFill>
                         <a:srgbClr val="D8D6CF"/>
@@ -13693,7 +13622,7 @@
                     <a:bodyPr/>
                     <a:lstStyle/>
                     <a:p>
-                      <a:pPr indent="0" marL="0">
+                      <a:pPr marL="0" indent="0">
                         <a:buNone/>
                       </a:pPr>
                       <a:r>
@@ -13714,7 +13643,7 @@
                       </a:endParaRPr>
                     </a:p>
                   </a:txBody>
-                  <a:tcPr marL="91440" marR="91440" marT="45720" marB="45720" anchor="ctr">
+                  <a:tcPr anchor="ctr">
                     <a:lnL w="6350" cap="flat" cmpd="sng" algn="ctr">
                       <a:solidFill>
                         <a:srgbClr val="D8D6CF"/>
@@ -13761,7 +13690,7 @@
                     <a:bodyPr/>
                     <a:lstStyle/>
                     <a:p>
-                      <a:pPr indent="0" marL="0">
+                      <a:pPr marL="0" indent="0">
                         <a:buNone/>
                       </a:pPr>
                       <a:r>
@@ -13782,7 +13711,7 @@
                       </a:endParaRPr>
                     </a:p>
                   </a:txBody>
-                  <a:tcPr marL="91440" marR="91440" marT="45720" marB="45720" anchor="ctr">
+                  <a:tcPr anchor="ctr">
                     <a:lnL w="6350" cap="flat" cmpd="sng" algn="ctr">
                       <a:solidFill>
                         <a:srgbClr val="D8D6CF"/>
@@ -13829,7 +13758,7 @@
                     <a:bodyPr/>
                     <a:lstStyle/>
                     <a:p>
-                      <a:pPr indent="0" marL="0">
+                      <a:pPr marL="0" indent="0">
                         <a:buNone/>
                       </a:pPr>
                       <a:r>
@@ -13850,7 +13779,7 @@
                       </a:endParaRPr>
                     </a:p>
                   </a:txBody>
-                  <a:tcPr marL="91440" marR="91440" marT="45720" marB="45720" anchor="ctr">
+                  <a:tcPr anchor="ctr">
                     <a:lnL w="6350" cap="flat" cmpd="sng" algn="ctr">
                       <a:solidFill>
                         <a:srgbClr val="D8D6CF"/>
@@ -13897,7 +13826,7 @@
                     <a:bodyPr/>
                     <a:lstStyle/>
                     <a:p>
-                      <a:pPr indent="0" marL="0">
+                      <a:pPr marL="0" indent="0">
                         <a:buNone/>
                       </a:pPr>
                       <a:r>
@@ -13918,7 +13847,7 @@
                       </a:endParaRPr>
                     </a:p>
                   </a:txBody>
-                  <a:tcPr marL="91440" marR="91440" marT="45720" marB="45720" anchor="ctr">
+                  <a:tcPr anchor="ctr">
                     <a:lnL w="6350" cap="flat" cmpd="sng" algn="ctr">
                       <a:solidFill>
                         <a:srgbClr val="D8D6CF"/>
@@ -13960,6 +13889,11 @@
                     </a:solidFill>
                   </a:tcPr>
                 </a:tc>
+                <a:extLst>
+                  <a:ext uri="{0D108BD9-81ED-4DB2-BD59-A6C34878D82A}">
+                    <a16:rowId xmlns:a16="http://schemas.microsoft.com/office/drawing/2014/main" val="10004"/>
+                  </a:ext>
+                </a:extLst>
               </a:tr>
               <a:tr h="402336">
                 <a:tc>
@@ -13967,7 +13901,7 @@
                     <a:bodyPr/>
                     <a:lstStyle/>
                     <a:p>
-                      <a:pPr indent="0" marL="0">
+                      <a:pPr marL="0" indent="0">
                         <a:buNone/>
                       </a:pPr>
                       <a:r>
@@ -13988,7 +13922,7 @@
                       </a:endParaRPr>
                     </a:p>
                   </a:txBody>
-                  <a:tcPr marL="91440" marR="91440" marT="45720" marB="45720" anchor="ctr">
+                  <a:tcPr anchor="ctr">
                     <a:lnL w="6350" cap="flat" cmpd="sng" algn="ctr">
                       <a:solidFill>
                         <a:srgbClr val="D8D6CF"/>
@@ -14035,7 +13969,7 @@
                     <a:bodyPr/>
                     <a:lstStyle/>
                     <a:p>
-                      <a:pPr indent="0" marL="0">
+                      <a:pPr marL="0" indent="0">
                         <a:buNone/>
                       </a:pPr>
                       <a:r>
@@ -14056,7 +13990,7 @@
                       </a:endParaRPr>
                     </a:p>
                   </a:txBody>
-                  <a:tcPr marL="91440" marR="91440" marT="45720" marB="45720" anchor="ctr">
+                  <a:tcPr anchor="ctr">
                     <a:lnL w="6350" cap="flat" cmpd="sng" algn="ctr">
                       <a:solidFill>
                         <a:srgbClr val="D8D6CF"/>
@@ -14103,7 +14037,7 @@
                     <a:bodyPr/>
                     <a:lstStyle/>
                     <a:p>
-                      <a:pPr indent="0" marL="0">
+                      <a:pPr marL="0" indent="0">
                         <a:buNone/>
                       </a:pPr>
                       <a:r>
@@ -14124,7 +14058,7 @@
                       </a:endParaRPr>
                     </a:p>
                   </a:txBody>
-                  <a:tcPr marL="91440" marR="91440" marT="45720" marB="45720" anchor="ctr">
+                  <a:tcPr anchor="ctr">
                     <a:lnL w="6350" cap="flat" cmpd="sng" algn="ctr">
                       <a:solidFill>
                         <a:srgbClr val="D8D6CF"/>
@@ -14171,7 +14105,7 @@
                     <a:bodyPr/>
                     <a:lstStyle/>
                     <a:p>
-                      <a:pPr indent="0" marL="0">
+                      <a:pPr marL="0" indent="0">
                         <a:buNone/>
                       </a:pPr>
                       <a:r>
@@ -14192,7 +14126,7 @@
                       </a:endParaRPr>
                     </a:p>
                   </a:txBody>
-                  <a:tcPr marL="91440" marR="91440" marT="45720" marB="45720" anchor="ctr">
+                  <a:tcPr anchor="ctr">
                     <a:lnL w="6350" cap="flat" cmpd="sng" algn="ctr">
                       <a:solidFill>
                         <a:srgbClr val="D8D6CF"/>
@@ -14239,7 +14173,7 @@
                     <a:bodyPr/>
                     <a:lstStyle/>
                     <a:p>
-                      <a:pPr indent="0" marL="0">
+                      <a:pPr marL="0" indent="0">
                         <a:buNone/>
                       </a:pPr>
                       <a:r>
@@ -14260,7 +14194,7 @@
                       </a:endParaRPr>
                     </a:p>
                   </a:txBody>
-                  <a:tcPr marL="91440" marR="91440" marT="45720" marB="45720" anchor="ctr">
+                  <a:tcPr anchor="ctr">
                     <a:lnL w="6350" cap="flat" cmpd="sng" algn="ctr">
                       <a:solidFill>
                         <a:srgbClr val="D8D6CF"/>
@@ -14307,7 +14241,7 @@
                     <a:bodyPr/>
                     <a:lstStyle/>
                     <a:p>
-                      <a:pPr indent="0" marL="0">
+                      <a:pPr marL="0" indent="0">
                         <a:buNone/>
                       </a:pPr>
                       <a:r>
@@ -14328,7 +14262,7 @@
                       </a:endParaRPr>
                     </a:p>
                   </a:txBody>
-                  <a:tcPr marL="91440" marR="91440" marT="45720" marB="45720" anchor="ctr">
+                  <a:tcPr anchor="ctr">
                     <a:lnL w="6350" cap="flat" cmpd="sng" algn="ctr">
                       <a:solidFill>
                         <a:srgbClr val="D8D6CF"/>
@@ -14370,6 +14304,11 @@
                     </a:solidFill>
                   </a:tcPr>
                 </a:tc>
+                <a:extLst>
+                  <a:ext uri="{0D108BD9-81ED-4DB2-BD59-A6C34878D82A}">
+                    <a16:rowId xmlns:a16="http://schemas.microsoft.com/office/drawing/2014/main" val="10005"/>
+                  </a:ext>
+                </a:extLst>
               </a:tr>
             </a:tbl>
           </a:graphicData>
@@ -14396,7 +14335,7 @@
           <a:bodyPr wrap="square" lIns="0" tIns="0" rIns="0" bIns="0" rtlCol="0" anchor="ctr"/>
           <a:lstStyle/>
           <a:p>
-            <a:pPr indent="0" marL="0">
+            <a:pPr marL="0" indent="0">
               <a:buNone/>
             </a:pPr>
             <a:r>
@@ -14435,7 +14374,7 @@
           <a:bodyPr wrap="square" lIns="0" tIns="0" rIns="0" bIns="0" rtlCol="0" anchor="ctr"/>
           <a:lstStyle/>
           <a:p>
-            <a:pPr indent="0" marL="0">
+            <a:pPr marL="0" indent="0">
               <a:buNone/>
             </a:pPr>
             <a:r>
@@ -14474,7 +14413,7 @@
           <a:bodyPr wrap="square" lIns="0" tIns="0" rIns="0" bIns="0" rtlCol="0" anchor="ctr"/>
           <a:lstStyle/>
           <a:p>
-            <a:pPr indent="0" marL="0">
+            <a:pPr marL="0" indent="0">
               <a:buNone/>
             </a:pPr>
             <a:r>
@@ -14513,7 +14452,7 @@
           <a:bodyPr wrap="square" lIns="0" tIns="0" rIns="0" bIns="0" rtlCol="0" anchor="ctr"/>
           <a:lstStyle/>
           <a:p>
-            <a:pPr indent="0" marL="0">
+            <a:pPr marL="0" indent="0">
               <a:buNone/>
             </a:pPr>
             <a:r>
@@ -14552,7 +14491,7 @@
           <a:bodyPr wrap="square" lIns="0" tIns="0" rIns="0" bIns="0" rtlCol="0" anchor="ctr"/>
           <a:lstStyle/>
           <a:p>
-            <a:pPr indent="0" marL="0">
+            <a:pPr marL="0" indent="0">
               <a:buNone/>
             </a:pPr>
             <a:r>
@@ -14616,7 +14555,7 @@
           <a:bodyPr wrap="square" lIns="0" tIns="0" rIns="0" bIns="0" rtlCol="0" anchor="ctr"/>
           <a:lstStyle/>
           <a:p>
-            <a:pPr indent="0" marL="0">
+            <a:pPr marL="0" indent="0">
               <a:buNone/>
             </a:pPr>
             <a:r>
@@ -14636,14 +14575,14 @@
       </p:sp>
       <p:pic>
         <p:nvPicPr>
-          <p:cNvPr id="3" name="Image 0" descr="C:\Users\Samson\Desktop\Homework\OS3180\Final Project\charts\fig31_predicted_vs_actual.png">    </p:cNvPr>
+          <p:cNvPr id="3" name="Image 0" descr="C:\Users\Samson\Desktop\Homework\OS3180\Final Project\charts\fig31_predicted_vs_actual.png"/>
           <p:cNvPicPr>
             <a:picLocks noChangeAspect="1"/>
           </p:cNvPicPr>
           <p:nvPr/>
         </p:nvPicPr>
         <p:blipFill>
-          <a:blip r:embed="rId1"/>
+          <a:blip r:embed="rId3"/>
           <a:stretch>
             <a:fillRect/>
           </a:stretch>
@@ -14959,4 +14898,319 @@
     </a:ext>
   </a:extLst>
 </a:theme>
+</file>
+
+<file path=ppt/theme/theme2.xml><?xml version="1.0" encoding="utf-8"?>
+<a:theme xmlns:a="http://schemas.openxmlformats.org/drawingml/2006/main" name="Office Theme">
+  <a:themeElements>
+    <a:clrScheme name="Office">
+      <a:dk1>
+        <a:sysClr val="windowText" lastClr="000000"/>
+      </a:dk1>
+      <a:lt1>
+        <a:sysClr val="window" lastClr="FFFFFF"/>
+      </a:lt1>
+      <a:dk2>
+        <a:srgbClr val="0E2841"/>
+      </a:dk2>
+      <a:lt2>
+        <a:srgbClr val="E8E8E8"/>
+      </a:lt2>
+      <a:accent1>
+        <a:srgbClr val="156082"/>
+      </a:accent1>
+      <a:accent2>
+        <a:srgbClr val="E97132"/>
+      </a:accent2>
+      <a:accent3>
+        <a:srgbClr val="196B24"/>
+      </a:accent3>
+      <a:accent4>
+        <a:srgbClr val="0F9ED5"/>
+      </a:accent4>
+      <a:accent5>
+        <a:srgbClr val="A02B93"/>
+      </a:accent5>
+      <a:accent6>
+        <a:srgbClr val="4EA72E"/>
+      </a:accent6>
+      <a:hlink>
+        <a:srgbClr val="467886"/>
+      </a:hlink>
+      <a:folHlink>
+        <a:srgbClr val="96607D"/>
+      </a:folHlink>
+    </a:clrScheme>
+    <a:fontScheme name="Office">
+      <a:majorFont>
+        <a:latin typeface="Aptos Display" panose="02110004020202020204"/>
+        <a:ea typeface=""/>
+        <a:cs typeface=""/>
+        <a:font script="Jpan" typeface="游ゴシック Light"/>
+        <a:font script="Hang" typeface="맑은 고딕"/>
+        <a:font script="Hans" typeface="等线 Light"/>
+        <a:font script="Hant" typeface="新細明體"/>
+        <a:font script="Arab" typeface="Times New Roman"/>
+        <a:font script="Hebr" typeface="Times New Roman"/>
+        <a:font script="Thai" typeface="Angsana New"/>
+        <a:font script="Ethi" typeface="Nyala"/>
+        <a:font script="Beng" typeface="Vrinda"/>
+        <a:font script="Gujr" typeface="Shruti"/>
+        <a:font script="Khmr" typeface="MoolBoran"/>
+        <a:font script="Knda" typeface="Tunga"/>
+        <a:font script="Guru" typeface="Raavi"/>
+        <a:font script="Cans" typeface="Euphemia"/>
+        <a:font script="Cher" typeface="Plantagenet Cherokee"/>
+        <a:font script="Yiii" typeface="Microsoft Yi Baiti"/>
+        <a:font script="Tibt" typeface="Microsoft Himalaya"/>
+        <a:font script="Thaa" typeface="MV Boli"/>
+        <a:font script="Deva" typeface="Mangal"/>
+        <a:font script="Telu" typeface="Gautami"/>
+        <a:font script="Taml" typeface="Latha"/>
+        <a:font script="Syrc" typeface="Estrangelo Edessa"/>
+        <a:font script="Orya" typeface="Kalinga"/>
+        <a:font script="Mlym" typeface="Kartika"/>
+        <a:font script="Laoo" typeface="DokChampa"/>
+        <a:font script="Sinh" typeface="Iskoola Pota"/>
+        <a:font script="Mong" typeface="Mongolian Baiti"/>
+        <a:font script="Viet" typeface="Times New Roman"/>
+        <a:font script="Uigh" typeface="Microsoft Uighur"/>
+        <a:font script="Geor" typeface="Sylfaen"/>
+        <a:font script="Armn" typeface="Arial"/>
+        <a:font script="Bugi" typeface="Leelawadee UI"/>
+        <a:font script="Bopo" typeface="Microsoft JhengHei"/>
+        <a:font script="Java" typeface="Javanese Text"/>
+        <a:font script="Lisu" typeface="Segoe UI"/>
+        <a:font script="Mymr" typeface="Myanmar Text"/>
+        <a:font script="Nkoo" typeface="Ebrima"/>
+        <a:font script="Olck" typeface="Nirmala UI"/>
+        <a:font script="Osma" typeface="Ebrima"/>
+        <a:font script="Phag" typeface="Phagspa"/>
+        <a:font script="Syrn" typeface="Estrangelo Edessa"/>
+        <a:font script="Syrj" typeface="Estrangelo Edessa"/>
+        <a:font script="Syre" typeface="Estrangelo Edessa"/>
+        <a:font script="Sora" typeface="Nirmala UI"/>
+        <a:font script="Tale" typeface="Microsoft Tai Le"/>
+        <a:font script="Talu" typeface="Microsoft New Tai Lue"/>
+        <a:font script="Tfng" typeface="Ebrima"/>
+      </a:majorFont>
+      <a:minorFont>
+        <a:latin typeface="Aptos" panose="02110004020202020204"/>
+        <a:ea typeface=""/>
+        <a:cs typeface=""/>
+        <a:font script="Jpan" typeface="游ゴシック"/>
+        <a:font script="Hang" typeface="맑은 고딕"/>
+        <a:font script="Hans" typeface="等线"/>
+        <a:font script="Hant" typeface="新細明體"/>
+        <a:font script="Arab" typeface="Arial"/>
+        <a:font script="Hebr" typeface="Arial"/>
+        <a:font script="Thai" typeface="Cordia New"/>
+        <a:font script="Ethi" typeface="Nyala"/>
+        <a:font script="Beng" typeface="Vrinda"/>
+        <a:font script="Gujr" typeface="Shruti"/>
+        <a:font script="Khmr" typeface="DaunPenh"/>
+        <a:font script="Knda" typeface="Tunga"/>
+        <a:font script="Guru" typeface="Raavi"/>
+        <a:font script="Cans" typeface="Euphemia"/>
+        <a:font script="Cher" typeface="Plantagenet Cherokee"/>
+        <a:font script="Yiii" typeface="Microsoft Yi Baiti"/>
+        <a:font script="Tibt" typeface="Microsoft Himalaya"/>
+        <a:font script="Thaa" typeface="MV Boli"/>
+        <a:font script="Deva" typeface="Mangal"/>
+        <a:font script="Telu" typeface="Gautami"/>
+        <a:font script="Taml" typeface="Latha"/>
+        <a:font script="Syrc" typeface="Estrangelo Edessa"/>
+        <a:font script="Orya" typeface="Kalinga"/>
+        <a:font script="Mlym" typeface="Kartika"/>
+        <a:font script="Laoo" typeface="DokChampa"/>
+        <a:font script="Sinh" typeface="Iskoola Pota"/>
+        <a:font script="Mong" typeface="Mongolian Baiti"/>
+        <a:font script="Viet" typeface="Arial"/>
+        <a:font script="Uigh" typeface="Microsoft Uighur"/>
+        <a:font script="Geor" typeface="Sylfaen"/>
+        <a:font script="Armn" typeface="Arial"/>
+        <a:font script="Bugi" typeface="Leelawadee UI"/>
+        <a:font script="Bopo" typeface="Microsoft JhengHei"/>
+        <a:font script="Java" typeface="Javanese Text"/>
+        <a:font script="Lisu" typeface="Segoe UI"/>
+        <a:font script="Mymr" typeface="Myanmar Text"/>
+        <a:font script="Nkoo" typeface="Ebrima"/>
+        <a:font script="Olck" typeface="Nirmala UI"/>
+        <a:font script="Osma" typeface="Ebrima"/>
+        <a:font script="Phag" typeface="Phagspa"/>
+        <a:font script="Syrn" typeface="Estrangelo Edessa"/>
+        <a:font script="Syrj" typeface="Estrangelo Edessa"/>
+        <a:font script="Syre" typeface="Estrangelo Edessa"/>
+        <a:font script="Sora" typeface="Nirmala UI"/>
+        <a:font script="Tale" typeface="Microsoft Tai Le"/>
+        <a:font script="Talu" typeface="Microsoft New Tai Lue"/>
+        <a:font script="Tfng" typeface="Ebrima"/>
+      </a:minorFont>
+    </a:fontScheme>
+    <a:fmtScheme name="Office">
+      <a:fillStyleLst>
+        <a:solidFill>
+          <a:schemeClr val="phClr"/>
+        </a:solidFill>
+        <a:gradFill rotWithShape="1">
+          <a:gsLst>
+            <a:gs pos="0">
+              <a:schemeClr val="phClr">
+                <a:lumMod val="110000"/>
+                <a:satMod val="105000"/>
+                <a:tint val="67000"/>
+              </a:schemeClr>
+            </a:gs>
+            <a:gs pos="50000">
+              <a:schemeClr val="phClr">
+                <a:lumMod val="105000"/>
+                <a:satMod val="103000"/>
+                <a:tint val="73000"/>
+              </a:schemeClr>
+            </a:gs>
+            <a:gs pos="100000">
+              <a:schemeClr val="phClr">
+                <a:lumMod val="105000"/>
+                <a:satMod val="109000"/>
+                <a:tint val="81000"/>
+              </a:schemeClr>
+            </a:gs>
+          </a:gsLst>
+          <a:lin ang="5400000" scaled="0"/>
+        </a:gradFill>
+        <a:gradFill rotWithShape="1">
+          <a:gsLst>
+            <a:gs pos="0">
+              <a:schemeClr val="phClr">
+                <a:satMod val="103000"/>
+                <a:lumMod val="102000"/>
+                <a:tint val="94000"/>
+              </a:schemeClr>
+            </a:gs>
+            <a:gs pos="50000">
+              <a:schemeClr val="phClr">
+                <a:satMod val="110000"/>
+                <a:lumMod val="100000"/>
+                <a:shade val="100000"/>
+              </a:schemeClr>
+            </a:gs>
+            <a:gs pos="100000">
+              <a:schemeClr val="phClr">
+                <a:lumMod val="99000"/>
+                <a:satMod val="120000"/>
+                <a:shade val="78000"/>
+              </a:schemeClr>
+            </a:gs>
+          </a:gsLst>
+          <a:lin ang="5400000" scaled="0"/>
+        </a:gradFill>
+      </a:fillStyleLst>
+      <a:lnStyleLst>
+        <a:ln w="12700" cap="flat" cmpd="sng" algn="ctr">
+          <a:solidFill>
+            <a:schemeClr val="phClr"/>
+          </a:solidFill>
+          <a:prstDash val="solid"/>
+          <a:miter lim="800000"/>
+        </a:ln>
+        <a:ln w="19050" cap="flat" cmpd="sng" algn="ctr">
+          <a:solidFill>
+            <a:schemeClr val="phClr"/>
+          </a:solidFill>
+          <a:prstDash val="solid"/>
+          <a:miter lim="800000"/>
+        </a:ln>
+        <a:ln w="25400" cap="flat" cmpd="sng" algn="ctr">
+          <a:solidFill>
+            <a:schemeClr val="phClr"/>
+          </a:solidFill>
+          <a:prstDash val="solid"/>
+          <a:miter lim="800000"/>
+        </a:ln>
+      </a:lnStyleLst>
+      <a:effectStyleLst>
+        <a:effectStyle>
+          <a:effectLst/>
+        </a:effectStyle>
+        <a:effectStyle>
+          <a:effectLst/>
+        </a:effectStyle>
+        <a:effectStyle>
+          <a:effectLst>
+            <a:outerShdw blurRad="57150" dist="19050" dir="5400000" algn="ctr" rotWithShape="0">
+              <a:srgbClr val="000000">
+                <a:alpha val="63000"/>
+              </a:srgbClr>
+            </a:outerShdw>
+          </a:effectLst>
+        </a:effectStyle>
+      </a:effectStyleLst>
+      <a:bgFillStyleLst>
+        <a:solidFill>
+          <a:schemeClr val="phClr"/>
+        </a:solidFill>
+        <a:solidFill>
+          <a:schemeClr val="phClr">
+            <a:tint val="95000"/>
+            <a:satMod val="170000"/>
+          </a:schemeClr>
+        </a:solidFill>
+        <a:gradFill rotWithShape="1">
+          <a:gsLst>
+            <a:gs pos="0">
+              <a:schemeClr val="phClr">
+                <a:tint val="93000"/>
+                <a:satMod val="150000"/>
+                <a:shade val="98000"/>
+                <a:lumMod val="102000"/>
+              </a:schemeClr>
+            </a:gs>
+            <a:gs pos="50000">
+              <a:schemeClr val="phClr">
+                <a:tint val="98000"/>
+                <a:satMod val="130000"/>
+                <a:shade val="90000"/>
+                <a:lumMod val="103000"/>
+              </a:schemeClr>
+            </a:gs>
+            <a:gs pos="100000">
+              <a:schemeClr val="phClr">
+                <a:shade val="63000"/>
+                <a:satMod val="120000"/>
+              </a:schemeClr>
+            </a:gs>
+          </a:gsLst>
+          <a:lin ang="5400000" scaled="0"/>
+        </a:gradFill>
+      </a:bgFillStyleLst>
+    </a:fmtScheme>
+  </a:themeElements>
+  <a:objectDefaults>
+    <a:lnDef>
+      <a:spPr/>
+      <a:bodyPr/>
+      <a:lstStyle/>
+      <a:style>
+        <a:lnRef idx="2">
+          <a:schemeClr val="accent1"/>
+        </a:lnRef>
+        <a:fillRef idx="0">
+          <a:schemeClr val="accent1"/>
+        </a:fillRef>
+        <a:effectRef idx="1">
+          <a:schemeClr val="accent1"/>
+        </a:effectRef>
+        <a:fontRef idx="minor">
+          <a:schemeClr val="tx1"/>
+        </a:fontRef>
+      </a:style>
+    </a:lnDef>
+  </a:objectDefaults>
+  <a:extraClrSchemeLst/>
+  <a:extLst>
+    <a:ext uri="{05A4C25C-085E-4340-85A3-A5531E510DB2}">
+      <thm15:themeFamily xmlns:thm15="http://schemas.microsoft.com/office/thememl/2012/main" name="Office Theme" id="{2E142A2C-CD16-42D6-873A-C26D2A0506FA}" vid="{1BDDFF52-6CD6-40A5-AB3C-68EB2F1E4D0A}"/>
+    </a:ext>
+  </a:extLst>
+</a:theme>
 </file>
</xml_diff>

<commit_message>
Add how-we-normalized slide and Q&A-grade speaker notes
New core slide after the exchange-rate beat: three-step normalization
walkthrough with the worked 1987 example (22.0 x 0.91 x 0.69 = 13.8 at
2024 design). Speaker notes expanded with exact explanations on the
slides the presenter has asked about: 2-cycle definition (hypothesis
slide), 100% join-rate meaning (data slide), the epsilon error term
(derivation slide), F = 1,401 as the ANOVA whole-model test (results
slide), and the normalization mechanics (fig45 slide). Deck: 29 slides
(21 core + 8 backup).

Co-Authored-By: Claude Fable 5 <noreply@anthropic.com>
</commit_message>
<xml_diff>
--- a/MPG Prediction Deck.pptx
+++ b/MPG Prediction Deck.pptx
@@ -33,9 +33,10 @@
     <p:sldId id="281" r:id="rId27"/>
     <p:sldId id="282" r:id="rId28"/>
     <p:sldId id="283" r:id="rId29"/>
+    <p:sldId id="284" r:id="rId30"/>
   </p:sldIdLst>
   <p:notesMasterIdLst>
-    <p:notesMasterId r:id="rId30"/>
+    <p:notesMasterId r:id="rId31"/>
   </p:notesMasterIdLst>
   <p:sldSz cx="12192000" cy="6858000"/>
   <p:notesSz cx="6858000" cy="12192000"/>
@@ -881,7 +882,7 @@
           <a:p>
             <a:r>
               <a:rPr lang="en-US" dirty="0"/>
-              <a:t>The payoff of the equation beyond prediction: it is a measuring instrument. Normalized, combustion productivity is a 50-year straight line in log space.</a:t>
+              <a:t>EXACTLY what is happening: the regression says MPG is proportional to weight^-0.304 times HP^-0.483 times a technology level. So technology level = MPG divided by those design terms. To COMPARE years, we evaluate every year's technology at one common design point (2024's fleet weight and power). The multiplication by (wt/wt2024)^0.304 and (HP/HP2024)^0.483 does that: for a light, weak 1987 fleet both ratios are below 1, so raw MPG gets scaled DOWN - 1987's 22.0 becomes ~13.8, the MPG its technology would have delivered pushing 2024 metal. Because the model is log-log (multiplicative), design separates from technology as clean ratio factors; that is WHY we fit in logs. Key assumption to volunteer: the elasticities are 2024 cross-sectional values applied historically; era refits (R-squared 0.71-0.78) support but cannot prove stability. Why 2024 as the reference: any year works mathematically - the whole curve just shifts; 2024 makes the endpoint equal today's actual fleet so the numbers read in today's terms.</a:t>
             </a:r>
             <a:endParaRPr lang="en-US" dirty="0"/>
           </a:p>
@@ -969,7 +970,7 @@
           <a:p>
             <a:r>
               <a:rPr lang="en-US" dirty="0"/>
-              <a:t>Same law per class. Pre-empt the spike question here by naming it; full decomposition sits in backup.</a:t>
+              <a:t>The payoff of the equation beyond prediction: it is a measuring instrument. Normalized, combustion productivity is a 50-year straight line in log space. The mechanics were just shown on the how-we-normalized slide; if the worked example is requested again: 1987's raw 22.0 MPG times (3221/4354)^0.304 times (118/258)^0.483 = 22.0 x 0.91 x 0.69 = ~13.8 - what 1987 technology delivers pushing 2024 weight and power. This slide additionally backs BEVs out (harmonically for MPG, arithmetically for weight/HP, Tesla series as proxy) so the line is pure combustion.</a:t>
             </a:r>
             <a:endParaRPr lang="en-US" dirty="0"/>
           </a:p>
@@ -1057,7 +1058,7 @@
           <a:p>
             <a:r>
               <a:rPr lang="en-US" dirty="0"/>
-              <a:t>Predicted MPG converts to dollars per year; payback arithmetic; the worst BEV year beats the best gasoline year.</a:t>
+              <a:t>Same law per class. Pre-empt the spike question here by naming it; full decomposition sits in backup.</a:t>
             </a:r>
             <a:endParaRPr lang="en-US" dirty="0"/>
           </a:p>
@@ -1145,7 +1146,7 @@
           <a:p>
             <a:r>
               <a:rPr lang="en-US" dirty="0"/>
-              <a:t>EVs get their own beat: automakers offer three times faster than Americans buy; adoption is visibly policy-elastic (2023 surge, 2024 hangover). Ties to beat 6: the cost advantage is the engine, incentives the throttle.</a:t>
+              <a:t>Predicted MPG converts to dollars per year; payback arithmetic; the worst BEV year beats the best gasoline year.</a:t>
             </a:r>
             <a:endParaRPr lang="en-US" dirty="0"/>
           </a:p>
@@ -1233,7 +1234,7 @@
           <a:p>
             <a:r>
               <a:rPr lang="en-US" dirty="0"/>
-              <a:t>Forward view of technology: same functional form, different clocks. Say 'believe the dashes least' about BEV.</a:t>
+              <a:t>EVs get their own beat: automakers offer three times faster than Americans buy; adoption is visibly policy-elastic (2023 surge, 2024 hangover). Ties to beat 6: the cost advantage is the engine, incentives the throttle.</a:t>
             </a:r>
             <a:endParaRPr lang="en-US" dirty="0"/>
           </a:p>
@@ -1321,7 +1322,7 @@
           <a:p>
             <a:r>
               <a:rPr lang="en-US" dirty="0"/>
-              <a:t>Land the plane: projection with and without electrification, the gap as the consumer-choice term. The chain sentence is the thesis.</a:t>
+              <a:t>Forward view of technology: same functional form, different clocks. Say 'believe the dashes least' about BEV.</a:t>
             </a:r>
             <a:endParaRPr lang="en-US" dirty="0"/>
           </a:p>
@@ -1409,7 +1410,7 @@
           <a:p>
             <a:r>
               <a:rPr lang="en-US" dirty="0"/>
-              <a:t>Four limitations, now covering the normalization and projection too. Volunteer the elasticity-stability assumption before anyone asks.</a:t>
+              <a:t>Land the plane: projection with and without electrification, the gap as the consumer-choice term. The chain sentence is the thesis.</a:t>
             </a:r>
             <a:endParaRPr lang="en-US" dirty="0"/>
           </a:p>
@@ -1585,7 +1586,7 @@
           <a:p>
             <a:r>
               <a:rPr lang="en-US" dirty="0"/>
-              <a:t>Three numbers, the chain, questions. Backups stand ready: robustness, changepoints, audits, distributions, prices, the EV clock, the spike decomposition.</a:t>
+              <a:t>Four limitations, now covering the normalization and projection too. Volunteer the elasticity-stability assumption before anyone asks.</a:t>
             </a:r>
             <a:endParaRPr lang="en-US" dirty="0"/>
           </a:p>
@@ -1673,7 +1674,7 @@
           <a:p>
             <a:r>
               <a:rPr lang="en-US" dirty="0"/>
-              <a:t>Use for any 'does it generalize?' question.</a:t>
+              <a:t>Three numbers, the chain, questions. Backups stand ready: robustness, changepoints, audits, distributions, prices, the EV clock, the spike decomposition.</a:t>
             </a:r>
             <a:endParaRPr lang="en-US" dirty="0"/>
           </a:p>
@@ -1761,7 +1762,7 @@
           <a:p>
             <a:r>
               <a:rPr lang="en-US" dirty="0"/>
-              <a:t>Use if asked how the eras were chosen.</a:t>
+              <a:t>Use for any 'does it generalize?' question.</a:t>
             </a:r>
             <a:endParaRPr lang="en-US" dirty="0"/>
           </a:p>
@@ -1849,7 +1850,7 @@
           <a:p>
             <a:r>
               <a:rPr lang="en-US" dirty="0"/>
-              <a:t>Use for causal questions about gas prices or interest rates.</a:t>
+              <a:t>Use if asked how the eras were chosen.</a:t>
             </a:r>
             <a:endParaRPr lang="en-US" dirty="0"/>
           </a:p>
@@ -1937,7 +1938,7 @@
           <a:p>
             <a:r>
               <a:rPr lang="en-US" dirty="0"/>
-              <a:t>Use for consumer-behavior questions.</a:t>
+              <a:t>Use for causal questions about gas prices or interest rates.</a:t>
             </a:r>
             <a:endParaRPr lang="en-US" dirty="0"/>
           </a:p>
@@ -2025,7 +2026,7 @@
           <a:p>
             <a:r>
               <a:rPr lang="en-US" dirty="0"/>
-              <a:t>Use for price-history questions; MSRP vs ATP distinction.</a:t>
+              <a:t>Use for consumer-behavior questions.</a:t>
             </a:r>
             <a:endParaRPr lang="en-US" dirty="0"/>
           </a:p>
@@ -2113,7 +2114,7 @@
           <a:p>
             <a:r>
               <a:rPr lang="en-US" dirty="0"/>
-              <a:t>Use for fuel-cost trend questions; energy only.</a:t>
+              <a:t>Use for price-history questions; MSRP vs ATP distinction.</a:t>
             </a:r>
             <a:endParaRPr lang="en-US" dirty="0"/>
           </a:p>
@@ -2201,7 +2202,7 @@
           <a:p>
             <a:r>
               <a:rPr lang="en-US" dirty="0"/>
-              <a:t>Use for 'do EVs improve faster?'</a:t>
+              <a:t>Use for fuel-cost trend questions; energy only.</a:t>
             </a:r>
             <a:endParaRPr lang="en-US" dirty="0"/>
           </a:p>
@@ -2289,7 +2290,7 @@
           <a:p>
             <a:r>
               <a:rPr lang="en-US" dirty="0"/>
-              <a:t>Use for 'what is that spike?' and 'is 2024 incomplete?'</a:t>
+              <a:t>Use for 'do EVs improve faster?'</a:t>
             </a:r>
             <a:endParaRPr lang="en-US" dirty="0"/>
           </a:p>
@@ -2313,6 +2314,94 @@
             <a:fld id="{F7021451-1387-4CA6-816F-3879F97B5CBC}" type="slidenum">
               <a:rPr lang="en-US"/>
               <a:t>28</a:t>
+            </a:fld>
+            <a:endParaRPr lang="en-US"/>
+          </a:p>
+        </p:txBody>
+      </p:sp>
+    </p:spTree>
+    <p:extLst>
+      <p:ext uri="{BB962C8B-B14F-4D97-AF65-F5344CB8AC3E}">
+        <p14:creationId xmlns:p14="http://schemas.microsoft.com/office/powerpoint/2010/main" val="1024086991"/>
+      </p:ext>
+    </p:extLst>
+  </p:cSld>
+  <p:clrMapOvr>
+    <a:masterClrMapping/>
+  </p:clrMapOvr>
+</p:notes>
+</file>
+
+<file path=ppt/notesSlides/notesSlide29.xml><?xml version="1.0" encoding="utf-8"?>
+<p:notes xmlns:a="http://schemas.openxmlformats.org/drawingml/2006/main" xmlns:r="http://schemas.openxmlformats.org/officeDocument/2006/relationships" xmlns:p="http://schemas.openxmlformats.org/presentationml/2006/main">
+  <p:cSld>
+    <p:spTree>
+      <p:nvGrpSpPr>
+        <p:cNvPr id="1" name=""/>
+        <p:cNvGrpSpPr/>
+        <p:nvPr/>
+      </p:nvGrpSpPr>
+      <p:grpSpPr>
+        <a:xfrm>
+          <a:off x="0" y="0"/>
+          <a:ext cx="0" cy="0"/>
+          <a:chOff x="0" y="0"/>
+          <a:chExt cx="0" cy="0"/>
+        </a:xfrm>
+      </p:grpSpPr>
+      <p:sp>
+        <p:nvSpPr>
+          <p:cNvPr id="2" name="Slide Image Placeholder 1"/>
+          <p:cNvSpPr>
+            <a:spLocks noGrp="1" noRot="1" noChangeAspect="1"/>
+          </p:cNvSpPr>
+          <p:nvPr>
+            <p:ph type="sldImg"/>
+          </p:nvPr>
+        </p:nvSpPr>
+        <p:spPr/>
+      </p:sp>
+      <p:sp>
+        <p:nvSpPr>
+          <p:cNvPr id="3" name="Notes Placeholder 2"/>
+          <p:cNvSpPr>
+            <a:spLocks noGrp="1"/>
+          </p:cNvSpPr>
+          <p:nvPr>
+            <p:ph type="body" idx="1"/>
+          </p:nvPr>
+        </p:nvSpPr>
+        <p:spPr/>
+        <p:txBody>
+          <a:bodyPr/>
+          <a:lstStyle/>
+          <a:p>
+            <a:r>
+              <a:rPr lang="en-US" dirty="0"/>
+              <a:t>Use for 'what is that spike?' and 'is 2024 incomplete?'</a:t>
+            </a:r>
+            <a:endParaRPr lang="en-US" dirty="0"/>
+          </a:p>
+        </p:txBody>
+      </p:sp>
+      <p:sp>
+        <p:nvSpPr>
+          <p:cNvPr id="4" name="Slide Number Placeholder 3"/>
+          <p:cNvSpPr>
+            <a:spLocks noGrp="1"/>
+          </p:cNvSpPr>
+          <p:nvPr>
+            <p:ph type="sldNum" sz="quarter" idx="10"/>
+          </p:nvPr>
+        </p:nvSpPr>
+        <p:spPr/>
+        <p:txBody>
+          <a:bodyPr/>
+          <a:lstStyle/>
+          <a:p>
+            <a:fld id="{F7021451-1387-4CA6-816F-3879F97B5CBC}" type="slidenum">
+              <a:rPr lang="en-US"/>
+              <a:t>29</a:t>
             </a:fld>
             <a:endParaRPr lang="en-US"/>
           </a:p>
@@ -2377,7 +2466,7 @@
           <a:p>
             <a:r>
               <a:rPr lang="en-US" dirty="0"/>
-              <a:t>MPG is the dependent variable; the four design measures are independent. Signs predicted before fitting.</a:t>
+              <a:t>MPG is the dependent variable; the four design measures are independent. Signs predicted before fitting. WHAT 2-CYCLE MEANS if asked: EPA's two laboratory dynamometer driving cycles - a simulated stop-and-go CITY drive (the FTP) and a steady ~48 mph HIGHWAY drive - blended 55/45 into 'combined'. 'Unadjusted' = the raw lab results with no correction toward real-world driving; this is the measurement CAFE compliance uses. The window sticker uses 5-cycle testing (adds high-speed, air-conditioning, and cold-weather cycles) and reads lower; real-world driving is lower still (~31% below 2-cycle by 2024, per the lab-vs-road chart). We chose 2-cycle deliberately: one consistent, physics-clean test applied identically to every vehicle.</a:t>
             </a:r>
             <a:endParaRPr lang="en-US" dirty="0"/>
           </a:p>
@@ -2465,7 +2554,7 @@
           <a:p>
             <a:r>
               <a:rPr lang="en-US" dirty="0"/>
-              <a:t>Compliance filings, not surveys. One row per model type; perfect join at carline level; checksummed chain of custody.</a:t>
+              <a:t>Compliance filings, not surveys. One row per model type; checksummed chain of custody. WHAT '100% JOIN RATE' MEANS if asked: EPA publishes the fuel-economy data and the footprint data as two SEPARATE files, so rows must be matched between them before footprint can appear in the model. The matching key is the triplet (manufacturer code, division code, carline code) - e.g., GM / Chevrolet / Silverado 4WD. 100% means every one of the 1,052 carlines in the fuel-economy file found its partner in the footprint file AND vice versa - zero orphans, no fuzzy name matching, no dropped vehicles, no imputation. That matters because merging separately published files is where data usually leaks away silently; ours lost nothing.</a:t>
             </a:r>
             <a:endParaRPr lang="en-US" dirty="0"/>
           </a:p>
@@ -2817,7 +2906,7 @@
           <a:p>
             <a:r>
               <a:rPr lang="en-US" dirty="0"/>
-              <a:t>The equation, verbatim. Why logs, why elasticities, why HC1. Slow down here.</a:t>
+              <a:t>The equation, verbatim. Why logs, why elasticities, why HC1. Slow down here. WHAT EPSILON MEANS if asked: the error term - everything that determines a vehicle's MPG that the four predictors do not capture (aero tuning, gearing, tires, calibration). Without epsilon the equation would claim four numbers determine MPG EXACTLY, which is false; with it, MPG = systematic part + vehicle-specific residual. Epsilon is why the dots on the predicted-vs-actual slide scatter around the 45-degree line rather than sitting on it, and R-squared = 0.846 literally means the predictors explain 85% of variance while epsilon carries the other 15%. Soundbite: 'epsilon is the 15%.'</a:t>
             </a:r>
             <a:endParaRPr lang="en-US" dirty="0"/>
           </a:p>
@@ -2905,7 +2994,7 @@
           <a:p>
             <a:r>
               <a:rPr lang="en-US" dirty="0"/>
-              <a:t>All four reject zero. R-squared 0.846, adjusted identical. VIF max 3.4: collinearity present but tame.</a:t>
+              <a:t>All four reject zero. R-squared 0.846, adjusted identical. VIF max 3.4: collinearity present but tame. WHAT F = 1,401 MEANS if asked: the whole-model test. Null hypothesis: all four coefficients are zero - the predictors collectively explain nothing. F is the ratio of variance explained by the model (per parameter) to variance left unexplained (per residual degree of freedom) - hence F(4, 1020): 4 parameters against 1,025 - 5 = 1,020 residual df. Under the null this ratio hovers near 1; ours is 1,401, p below 10 to the -15. This is the ANOVA machinery from Chapters 9-11 applied to regression: explained vs unexplained variation, SST vs SSE. Honest caveat if pushed: with n this large F is almost always significant - the individual t-tests and effect sizes carry the interesting information; F certifies the model is not noise.</a:t>
             </a:r>
             <a:endParaRPr lang="en-US" dirty="0"/>
           </a:p>
@@ -4250,46 +4339,42 @@
                 <a:ea typeface="Calibri" pitchFamily="34" charset="-122"/>
                 <a:cs typeface="Calibri" pitchFamily="34" charset="-120"/>
               </a:rPr>
-              <a:t>Normalize the design away, and efficiency never stalled</a:t>
+              <a:t>How we normalized: divide out the design, keep the technology</a:t>
             </a:r>
             <a:endParaRPr lang="en-US" sz="2900" dirty="0"/>
           </a:p>
         </p:txBody>
       </p:sp>
-      <p:pic>
-        <p:nvPicPr>
-          <p:cNvPr id="3" name="Image 0" descr="C:\Users\Samson\Desktop\Homework\OS3180\Final Project\charts\fig45_ice_productivity.png">    </p:cNvPr>
-          <p:cNvPicPr>
-            <a:picLocks noChangeAspect="1"/>
-          </p:cNvPicPr>
+      <p:sp>
+        <p:nvSpPr>
+          <p:cNvPr id="3" name="Shape 1"/>
+          <p:cNvSpPr/>
           <p:nvPr/>
-        </p:nvPicPr>
-        <p:blipFill>
-          <a:blip r:embed="rId1"/>
-          <a:stretch>
-            <a:fillRect/>
-          </a:stretch>
-        </p:blipFill>
+        </p:nvSpPr>
         <p:spPr>
           <a:xfrm>
-            <a:off x="502920" y="1188720"/>
-            <a:ext cx="7700963" cy="4480560"/>
+            <a:off x="502920" y="1325880"/>
+            <a:ext cx="457200" cy="457200"/>
           </a:xfrm>
-          <a:prstGeom prst="rect">
+          <a:prstGeom prst="ellipse">
             <a:avLst/>
           </a:prstGeom>
+          <a:solidFill>
+            <a:srgbClr val="2A78D6"/>
+          </a:solidFill>
+          <a:ln/>
         </p:spPr>
-      </p:pic>
-      <p:sp>
-        <p:nvSpPr>
-          <p:cNvPr id="4" name="Text 1"/>
+      </p:sp>
+      <p:sp>
+        <p:nvSpPr>
+          <p:cNvPr id="4" name="Text 2"/>
           <p:cNvSpPr txBox="1"/>
           <p:nvPr/>
         </p:nvSpPr>
         <p:spPr>
           <a:xfrm>
-            <a:off x="8366760" y="1463040"/>
-            <a:ext cx="3337560" cy="4572000"/>
+            <a:off x="502920" y="1325880"/>
+            <a:ext cx="457200" cy="457200"/>
           </a:xfrm>
           <a:prstGeom prst="rect">
             <a:avLst/>
@@ -4301,11 +4386,381 @@
           <a:bodyPr wrap="square" lIns="0" tIns="0" rIns="0" bIns="0" rtlCol="0" anchor="ctr"/>
           <a:lstStyle/>
           <a:p>
-            <a:pPr indent="0" marL="0">
-              <a:buNone/>
-            </a:pPr>
-            <a:r>
-              <a:rPr lang="en-US" sz="1400" dirty="0">
+            <a:pPr algn="ctr" indent="0" marL="0">
+              <a:buNone/>
+            </a:pPr>
+            <a:r>
+              <a:rPr lang="en-US" sz="1800" b="1" dirty="0">
+                <a:solidFill>
+                  <a:srgbClr val="FFFFFF"/>
+                </a:solidFill>
+                <a:latin typeface="Calibri" pitchFamily="34" charset="0"/>
+                <a:ea typeface="Calibri" pitchFamily="34" charset="-122"/>
+                <a:cs typeface="Calibri" pitchFamily="34" charset="-120"/>
+              </a:rPr>
+              <a:t>1</a:t>
+            </a:r>
+            <a:endParaRPr lang="en-US" sz="1800" dirty="0"/>
+          </a:p>
+        </p:txBody>
+      </p:sp>
+      <p:sp>
+        <p:nvSpPr>
+          <p:cNvPr id="5" name="Text 3"/>
+          <p:cNvSpPr txBox="1"/>
+          <p:nvPr/>
+        </p:nvSpPr>
+        <p:spPr>
+          <a:xfrm>
+            <a:off x="502920" y="1920240"/>
+            <a:ext cx="3383280" cy="2011680"/>
+          </a:xfrm>
+          <a:prstGeom prst="rect">
+            <a:avLst/>
+          </a:prstGeom>
+          <a:noFill/>
+          <a:ln/>
+        </p:spPr>
+        <p:txBody>
+          <a:bodyPr wrap="square" lIns="0" tIns="0" rIns="0" bIns="0" rtlCol="0" anchor="ctr"/>
+          <a:lstStyle/>
+          <a:p>
+            <a:pPr indent="0" marL="0">
+              <a:buNone/>
+            </a:pPr>
+            <a:r>
+              <a:rPr lang="en-US" sz="1350" b="1" dirty="0">
+                <a:solidFill>
+                  <a:srgbClr val="000000"/>
+                </a:solidFill>
+                <a:latin typeface="Calibri" pitchFamily="34" charset="0"/>
+                <a:ea typeface="Calibri" pitchFamily="34" charset="-122"/>
+                <a:cs typeface="Calibri" pitchFamily="34" charset="-120"/>
+              </a:rPr>
+              <a:t>The model gives exchange rates
+</a:t>
+            </a:r>
+            <a:pPr indent="0" marL="0">
+              <a:buNone/>
+            </a:pPr>
+            <a:r>
+              <a:rPr lang="en-US" sz="1350" dirty="0">
+                <a:solidFill>
+                  <a:srgbClr val="0B0B0B"/>
+                </a:solidFill>
+                <a:latin typeface="Calibri" pitchFamily="34" charset="0"/>
+                <a:ea typeface="Calibri" pitchFamily="34" charset="-122"/>
+                <a:cs typeface="Calibri" pitchFamily="34" charset="-120"/>
+              </a:rPr>
+              <a:t>MPG scales with weight^-0.304 and HP^-0.483 (the elasticities we just estimated). Those exponents price what design costs in fuel economy.</a:t>
+            </a:r>
+            <a:endParaRPr lang="en-US" sz="1350" dirty="0"/>
+          </a:p>
+        </p:txBody>
+      </p:sp>
+      <p:sp>
+        <p:nvSpPr>
+          <p:cNvPr id="6" name="Shape 4"/>
+          <p:cNvSpPr/>
+          <p:nvPr/>
+        </p:nvSpPr>
+        <p:spPr>
+          <a:xfrm>
+            <a:off x="4434840" y="1325880"/>
+            <a:ext cx="457200" cy="457200"/>
+          </a:xfrm>
+          <a:prstGeom prst="ellipse">
+            <a:avLst/>
+          </a:prstGeom>
+          <a:solidFill>
+            <a:srgbClr val="2A78D6"/>
+          </a:solidFill>
+          <a:ln/>
+        </p:spPr>
+      </p:sp>
+      <p:sp>
+        <p:nvSpPr>
+          <p:cNvPr id="7" name="Text 5"/>
+          <p:cNvSpPr txBox="1"/>
+          <p:nvPr/>
+        </p:nvSpPr>
+        <p:spPr>
+          <a:xfrm>
+            <a:off x="4434840" y="1325880"/>
+            <a:ext cx="457200" cy="457200"/>
+          </a:xfrm>
+          <a:prstGeom prst="rect">
+            <a:avLst/>
+          </a:prstGeom>
+          <a:noFill/>
+          <a:ln/>
+        </p:spPr>
+        <p:txBody>
+          <a:bodyPr wrap="square" lIns="0" tIns="0" rIns="0" bIns="0" rtlCol="0" anchor="ctr"/>
+          <a:lstStyle/>
+          <a:p>
+            <a:pPr algn="ctr" indent="0" marL="0">
+              <a:buNone/>
+            </a:pPr>
+            <a:r>
+              <a:rPr lang="en-US" sz="1800" b="1" dirty="0">
+                <a:solidFill>
+                  <a:srgbClr val="FFFFFF"/>
+                </a:solidFill>
+                <a:latin typeface="Calibri" pitchFamily="34" charset="0"/>
+                <a:ea typeface="Calibri" pitchFamily="34" charset="-122"/>
+                <a:cs typeface="Calibri" pitchFamily="34" charset="-120"/>
+              </a:rPr>
+              <a:t>2</a:t>
+            </a:r>
+            <a:endParaRPr lang="en-US" sz="1800" dirty="0"/>
+          </a:p>
+        </p:txBody>
+      </p:sp>
+      <p:sp>
+        <p:nvSpPr>
+          <p:cNvPr id="8" name="Text 6"/>
+          <p:cNvSpPr txBox="1"/>
+          <p:nvPr/>
+        </p:nvSpPr>
+        <p:spPr>
+          <a:xfrm>
+            <a:off x="4434840" y="1920240"/>
+            <a:ext cx="3383280" cy="2011680"/>
+          </a:xfrm>
+          <a:prstGeom prst="rect">
+            <a:avLst/>
+          </a:prstGeom>
+          <a:noFill/>
+          <a:ln/>
+        </p:spPr>
+        <p:txBody>
+          <a:bodyPr wrap="square" lIns="0" tIns="0" rIns="0" bIns="0" rtlCol="0" anchor="ctr"/>
+          <a:lstStyle/>
+          <a:p>
+            <a:pPr indent="0" marL="0">
+              <a:buNone/>
+            </a:pPr>
+            <a:r>
+              <a:rPr lang="en-US" sz="1350" b="1" dirty="0">
+                <a:solidFill>
+                  <a:srgbClr val="000000"/>
+                </a:solidFill>
+                <a:latin typeface="Calibri" pitchFamily="34" charset="0"/>
+                <a:ea typeface="Calibri" pitchFamily="34" charset="-122"/>
+                <a:cs typeface="Calibri" pitchFamily="34" charset="-120"/>
+              </a:rPr>
+              <a:t>Re-price every year at 2024 design
+</a:t>
+            </a:r>
+            <a:pPr indent="0" marL="0">
+              <a:buNone/>
+            </a:pPr>
+            <a:r>
+              <a:rPr lang="en-US" sz="1350" dirty="0">
+                <a:solidFill>
+                  <a:srgbClr val="0B0B0B"/>
+                </a:solidFill>
+                <a:latin typeface="Calibri" pitchFamily="34" charset="0"/>
+                <a:ea typeface="Calibri" pitchFamily="34" charset="-122"/>
+                <a:cs typeface="Calibri" pitchFamily="34" charset="-120"/>
+              </a:rPr>
+              <a:t>Multiply each year's fleet MPG by (weight/weight2024)^0.304 x (HP/HP2024)^0.483 — scaling away the advantage of being lighter and weaker than 2024.</a:t>
+            </a:r>
+            <a:endParaRPr lang="en-US" sz="1350" dirty="0"/>
+          </a:p>
+        </p:txBody>
+      </p:sp>
+      <p:sp>
+        <p:nvSpPr>
+          <p:cNvPr id="9" name="Shape 7"/>
+          <p:cNvSpPr/>
+          <p:nvPr/>
+        </p:nvSpPr>
+        <p:spPr>
+          <a:xfrm>
+            <a:off x="8366760" y="1325880"/>
+            <a:ext cx="457200" cy="457200"/>
+          </a:xfrm>
+          <a:prstGeom prst="ellipse">
+            <a:avLst/>
+          </a:prstGeom>
+          <a:solidFill>
+            <a:srgbClr val="2A78D6"/>
+          </a:solidFill>
+          <a:ln/>
+        </p:spPr>
+      </p:sp>
+      <p:sp>
+        <p:nvSpPr>
+          <p:cNvPr id="10" name="Text 8"/>
+          <p:cNvSpPr txBox="1"/>
+          <p:nvPr/>
+        </p:nvSpPr>
+        <p:spPr>
+          <a:xfrm>
+            <a:off x="8366760" y="1325880"/>
+            <a:ext cx="457200" cy="457200"/>
+          </a:xfrm>
+          <a:prstGeom prst="rect">
+            <a:avLst/>
+          </a:prstGeom>
+          <a:noFill/>
+          <a:ln/>
+        </p:spPr>
+        <p:txBody>
+          <a:bodyPr wrap="square" lIns="0" tIns="0" rIns="0" bIns="0" rtlCol="0" anchor="ctr"/>
+          <a:lstStyle/>
+          <a:p>
+            <a:pPr algn="ctr" indent="0" marL="0">
+              <a:buNone/>
+            </a:pPr>
+            <a:r>
+              <a:rPr lang="en-US" sz="1800" b="1" dirty="0">
+                <a:solidFill>
+                  <a:srgbClr val="FFFFFF"/>
+                </a:solidFill>
+                <a:latin typeface="Calibri" pitchFamily="34" charset="0"/>
+                <a:ea typeface="Calibri" pitchFamily="34" charset="-122"/>
+                <a:cs typeface="Calibri" pitchFamily="34" charset="-120"/>
+              </a:rPr>
+              <a:t>3</a:t>
+            </a:r>
+            <a:endParaRPr lang="en-US" sz="1800" dirty="0"/>
+          </a:p>
+        </p:txBody>
+      </p:sp>
+      <p:sp>
+        <p:nvSpPr>
+          <p:cNvPr id="11" name="Text 9"/>
+          <p:cNvSpPr txBox="1"/>
+          <p:nvPr/>
+        </p:nvSpPr>
+        <p:spPr>
+          <a:xfrm>
+            <a:off x="8366760" y="1920240"/>
+            <a:ext cx="3383280" cy="2011680"/>
+          </a:xfrm>
+          <a:prstGeom prst="rect">
+            <a:avLst/>
+          </a:prstGeom>
+          <a:noFill/>
+          <a:ln/>
+        </p:spPr>
+        <p:txBody>
+          <a:bodyPr wrap="square" lIns="0" tIns="0" rIns="0" bIns="0" rtlCol="0" anchor="ctr"/>
+          <a:lstStyle/>
+          <a:p>
+            <a:pPr indent="0" marL="0">
+              <a:buNone/>
+            </a:pPr>
+            <a:r>
+              <a:rPr lang="en-US" sz="1350" b="1" dirty="0">
+                <a:solidFill>
+                  <a:srgbClr val="000000"/>
+                </a:solidFill>
+                <a:latin typeface="Calibri" pitchFamily="34" charset="0"/>
+                <a:ea typeface="Calibri" pitchFamily="34" charset="-122"/>
+                <a:cs typeface="Calibri" pitchFamily="34" charset="-120"/>
+              </a:rPr>
+              <a:t>What remains is technology
+</a:t>
+            </a:r>
+            <a:pPr indent="0" marL="0">
+              <a:buNone/>
+            </a:pPr>
+            <a:r>
+              <a:rPr lang="en-US" sz="1350" dirty="0">
+                <a:solidFill>
+                  <a:srgbClr val="0B0B0B"/>
+                </a:solidFill>
+                <a:latin typeface="Calibri" pitchFamily="34" charset="0"/>
+                <a:ea typeface="Calibri" pitchFamily="34" charset="-122"/>
+                <a:cs typeface="Calibri" pitchFamily="34" charset="-120"/>
+              </a:rPr>
+              <a:t>Every year now describes the same hypothetical vehicle — 2024's weight and power — built with that year's engineering. One moving part instead of three.</a:t>
+            </a:r>
+            <a:endParaRPr lang="en-US" sz="1350" dirty="0"/>
+          </a:p>
+        </p:txBody>
+      </p:sp>
+      <p:sp>
+        <p:nvSpPr>
+          <p:cNvPr id="12" name="Shape 10"/>
+          <p:cNvSpPr/>
+          <p:nvPr/>
+        </p:nvSpPr>
+        <p:spPr>
+          <a:xfrm>
+            <a:off x="502920" y="4160520"/>
+            <a:ext cx="11155680" cy="1783080"/>
+          </a:xfrm>
+          <a:prstGeom prst="roundRect">
+            <a:avLst>
+              <a:gd name="adj" fmla="val 4103"/>
+            </a:avLst>
+          </a:prstGeom>
+          <a:solidFill>
+            <a:srgbClr val="F0EFEC"/>
+          </a:solidFill>
+          <a:ln/>
+        </p:spPr>
+      </p:sp>
+      <p:sp>
+        <p:nvSpPr>
+          <p:cNvPr id="13" name="Text 11"/>
+          <p:cNvSpPr txBox="1"/>
+          <p:nvPr/>
+        </p:nvSpPr>
+        <p:spPr>
+          <a:xfrm>
+            <a:off x="777240" y="4343400"/>
+            <a:ext cx="10607040" cy="1463040"/>
+          </a:xfrm>
+          <a:prstGeom prst="rect">
+            <a:avLst/>
+          </a:prstGeom>
+          <a:noFill/>
+          <a:ln/>
+        </p:spPr>
+        <p:txBody>
+          <a:bodyPr wrap="square" lIns="0" tIns="0" rIns="0" bIns="0" rtlCol="0" anchor="ctr"/>
+          <a:lstStyle/>
+          <a:p>
+            <a:pPr indent="0" marL="0">
+              <a:buNone/>
+            </a:pPr>
+            <a:r>
+              <a:rPr lang="en-US" sz="1350" b="1" dirty="0">
+                <a:solidFill>
+                  <a:srgbClr val="0B0B0B"/>
+                </a:solidFill>
+                <a:latin typeface="Calibri" pitchFamily="34" charset="0"/>
+                <a:ea typeface="Calibri" pitchFamily="34" charset="-122"/>
+                <a:cs typeface="Calibri" pitchFamily="34" charset="-120"/>
+              </a:rPr>
+              <a:t>Worked example — 1987:  </a:t>
+            </a:r>
+            <a:pPr indent="0" marL="0">
+              <a:buNone/>
+            </a:pPr>
+            <a:r>
+              <a:rPr lang="en-US" sz="1350" dirty="0">
+                <a:solidFill>
+                  <a:srgbClr val="0B0B0B"/>
+                </a:solidFill>
+                <a:latin typeface="Calibri" pitchFamily="34" charset="0"/>
+                <a:ea typeface="Calibri" pitchFamily="34" charset="-122"/>
+                <a:cs typeface="Calibri" pitchFamily="34" charset="-120"/>
+              </a:rPr>
+              <a:t>raw fleet MPG 22.0, but the fleet weighed 3,221 lbs with 118 HP vs 2024's 4,354 lbs and 258 HP.
+</a:t>
+            </a:r>
+            <a:pPr indent="0" marL="0">
+              <a:buNone/>
+            </a:pPr>
+            <a:r>
+              <a:rPr lang="en-US" sz="1700" b="1" dirty="0">
                 <a:solidFill>
                   <a:srgbClr val="0B0B0B"/>
                 </a:solidFill>
@@ -4313,14 +4768,19 @@
                 <a:ea typeface="Cambria" pitchFamily="34" charset="-122"/>
                 <a:cs typeface="Cambria" pitchFamily="34" charset="-120"/>
               </a:rPr>
-              <a:t>MPG_norm = MPG × (wt/wt₂₀₂₄)^0.304 × (HP/HP₂₀₂₄)^0.483
-</a:t>
-            </a:r>
-            <a:pPr indent="0" marL="0">
-              <a:buNone/>
-            </a:pPr>
-            <a:r>
-              <a:rPr lang="en-US" sz="1400" dirty="0">
+              <a:t>22.0  ×  (3221/4354)^0.304  ×  (118/258)^0.483   =   22.0 × 0.91 × 0.69   ≈   13.8</a:t>
+            </a:r>
+            <a:pPr indent="0" marL="0">
+              <a:buNone/>
+            </a:pPr>
+            <a:endParaRPr lang="en-US" sz="1350" dirty="0"/>
+          </a:p>
+          <a:p>
+            <a:pPr indent="0" marL="0">
+              <a:buNone/>
+            </a:pPr>
+            <a:r>
+              <a:rPr lang="en-US" sz="1350" dirty="0">
                 <a:solidFill>
                   <a:srgbClr val="0B0B0B"/>
                 </a:solidFill>
@@ -4328,44 +4788,15 @@
                 <a:ea typeface="Calibri" pitchFamily="34" charset="-122"/>
                 <a:cs typeface="Calibri" pitchFamily="34" charset="-120"/>
               </a:rPr>
-              <a:t>Every year's fleet re-expressed at 2024's weight and power, using our own coefficients — combustion only (BEVs backed out).
-</a:t>
-            </a:r>
-            <a:pPr indent="0" marL="0">
-              <a:buNone/>
-            </a:pPr>
-            <a:r>
-              <a:rPr lang="en-US" sz="1400" b="1" dirty="0">
-                <a:solidFill>
-                  <a:srgbClr val="2A78D6"/>
-                </a:solidFill>
-                <a:latin typeface="Calibri" pitchFamily="34" charset="0"/>
-                <a:ea typeface="Calibri" pitchFamily="34" charset="-122"/>
-                <a:cs typeface="Calibri" pitchFamily="34" charset="-120"/>
-              </a:rPr>
-              <a:t>+1.86%/yr for fifty years, R² = 0.984. </a:t>
-            </a:r>
-            <a:pPr indent="0" marL="0">
-              <a:buNone/>
-            </a:pPr>
-            <a:r>
-              <a:rPr lang="en-US" sz="1400" dirty="0">
-                <a:solidFill>
-                  <a:srgbClr val="0B0B0B"/>
-                </a:solidFill>
-                <a:latin typeface="Calibri" pitchFamily="34" charset="0"/>
-                <a:ea typeface="Calibri" pitchFamily="34" charset="-122"/>
-                <a:cs typeface="Calibri" pitchFamily="34" charset="-120"/>
-              </a:rPr>
-              <a:t>The trough vanishes: technology never paused; its gains were spent.</a:t>
-            </a:r>
-            <a:endParaRPr lang="en-US" sz="1400" dirty="0"/>
-          </a:p>
-        </p:txBody>
-      </p:sp>
-      <p:sp>
-        <p:nvSpPr>
-          <p:cNvPr id="5" name="Text 2"/>
+              <a:t>1987's technology, asked to move 2024's fleet, delivers ~14 MPG — not 22. That is the normalized point plotted for 1987.</a:t>
+            </a:r>
+            <a:endParaRPr lang="en-US" sz="1350" dirty="0"/>
+          </a:p>
+        </p:txBody>
+      </p:sp>
+      <p:sp>
+        <p:nvSpPr>
+          <p:cNvPr id="14" name="Text 12"/>
           <p:cNvSpPr txBox="1"/>
           <p:nvPr/>
         </p:nvSpPr>
@@ -4396,7 +4827,7 @@
                 <a:ea typeface="Calibri" pitchFamily="34" charset="-122"/>
                 <a:cs typeface="Calibri" pitchFamily="34" charset="-120"/>
               </a:rPr>
-              <a:t>Stage 31; hybrids remain; BEV share backed out harmonically via the Tesla proxy (fleet share &lt;= 7.2%). BEV-inclusive version in the projection slide.</a:t>
+              <a:t>Elasticities from the stage-19 fit; construction in 29_productivity.py. Assumption stated on the limitations slide: 2024 elasticities held across eras.</a:t>
             </a:r>
             <a:endParaRPr lang="en-US" sz="1000" dirty="0"/>
           </a:p>
@@ -4460,7 +4891,7 @@
                 <a:ea typeface="Calibri" pitchFamily="34" charset="-122"/>
                 <a:cs typeface="Calibri" pitchFamily="34" charset="-120"/>
               </a:rPr>
-              <a:t>The productivity law holds in every class of vehicle</a:t>
+              <a:t>Normalize the design away, and efficiency never stalled</a:t>
             </a:r>
             <a:endParaRPr lang="en-US" sz="2900" dirty="0"/>
           </a:p>
@@ -4468,7 +4899,7 @@
       </p:sp>
       <p:pic>
         <p:nvPicPr>
-          <p:cNvPr id="3" name="Image 0" descr="C:\Users\Samson\Desktop\Homework\OS3180\Final Project\charts\fig43_class_productivity.png">    </p:cNvPr>
+          <p:cNvPr id="3" name="Image 0" descr="C:\Users\Samson\Desktop\Homework\OS3180\Final Project\charts\fig45_ice_productivity.png">    </p:cNvPr>
           <p:cNvPicPr>
             <a:picLocks noChangeAspect="1"/>
           </p:cNvPicPr>
@@ -4483,7 +4914,7 @@
         <p:spPr>
           <a:xfrm>
             <a:off x="502920" y="1188720"/>
-            <a:ext cx="7839635" cy="4846320"/>
+            <a:ext cx="7700963" cy="4480560"/>
           </a:xfrm>
           <a:prstGeom prst="rect">
             <a:avLst/>
@@ -4498,8 +4929,8 @@
         </p:nvSpPr>
         <p:spPr>
           <a:xfrm>
-            <a:off x="8778240" y="1554480"/>
-            <a:ext cx="2926080" cy="4572000"/>
+            <a:off x="8366760" y="1463040"/>
+            <a:ext cx="3337560" cy="4572000"/>
           </a:xfrm>
           <a:prstGeom prst="rect">
             <a:avLst/>
@@ -4519,11 +4950,27 @@
                 <a:solidFill>
                   <a:srgbClr val="0B0B0B"/>
                 </a:solidFill>
-                <a:latin typeface="Calibri" pitchFamily="34" charset="0"/>
-                <a:ea typeface="Calibri" pitchFamily="34" charset="-122"/>
-                <a:cs typeface="Calibri" pitchFamily="34" charset="-120"/>
-              </a:rPr>
-              <a:t>Sedans, SUVs, pickups, minivans — each normalized to its own 2024 design: </a:t>
+                <a:latin typeface="Cambria" pitchFamily="34" charset="0"/>
+                <a:ea typeface="Cambria" pitchFamily="34" charset="-122"/>
+                <a:cs typeface="Cambria" pitchFamily="34" charset="-120"/>
+              </a:rPr>
+              <a:t>MPG_norm = MPG × (wt/wt₂₀₂₄)^0.304 × (HP/HP₂₀₂₄)^0.483
+</a:t>
+            </a:r>
+            <a:pPr indent="0" marL="0">
+              <a:buNone/>
+            </a:pPr>
+            <a:r>
+              <a:rPr lang="en-US" sz="1400" dirty="0">
+                <a:solidFill>
+                  <a:srgbClr val="0B0B0B"/>
+                </a:solidFill>
+                <a:latin typeface="Calibri" pitchFamily="34" charset="0"/>
+                <a:ea typeface="Calibri" pitchFamily="34" charset="-122"/>
+                <a:cs typeface="Calibri" pitchFamily="34" charset="-120"/>
+              </a:rPr>
+              <a:t>Every year's fleet re-expressed at 2024's weight and power, using our own coefficients — combustion only (BEVs backed out).
+</a:t>
             </a:r>
             <a:pPr indent="0" marL="0">
               <a:buNone/>
@@ -4537,8 +4984,7 @@
                 <a:ea typeface="Calibri" pitchFamily="34" charset="-122"/>
                 <a:cs typeface="Calibri" pitchFamily="34" charset="-120"/>
               </a:rPr>
-              <a:t>2.0–2.6%/yr everywhere, R² 0.93–0.99.
-</a:t>
+              <a:t>+1.86%/yr for fifty years, R² = 0.984. </a:t>
             </a:r>
             <a:pPr indent="0" marL="0">
               <a:buNone/>
@@ -4552,7 +4998,7 @@
                 <a:ea typeface="Calibri" pitchFamily="34" charset="-122"/>
                 <a:cs typeface="Calibri" pitchFamily="34" charset="-120"/>
               </a:rPr>
-              <a:t>Classes differ in level (pickup physics), barely in rate. The one outlier — Car SUV's 2023 spike — is the Model Y entering the class at 36% share; it vanishes when BEVs are removed (backup).</a:t>
+              <a:t>The trough vanishes: technology never paused; its gains were spent.</a:t>
             </a:r>
             <a:endParaRPr lang="en-US" sz="1400" dirty="0"/>
           </a:p>
@@ -4591,7 +5037,7 @@
                 <a:ea typeface="Calibri" pitchFamily="34" charset="-122"/>
                 <a:cs typeface="Calibri" pitchFamily="34" charset="-120"/>
               </a:rPr>
-              <a:t>EPA Trends by vehicle type; no coupe class exists in Trends (two-doors fold into Sedan/Wagon). reports/30_class_productivity.md.</a:t>
+              <a:t>Stage 31; hybrids remain; BEV share backed out harmonically via the Tesla proxy (fleet share &lt;= 7.2%). BEV-inclusive version in the projection slide.</a:t>
             </a:r>
             <a:endParaRPr lang="en-US" sz="1000" dirty="0"/>
           </a:p>
@@ -4655,7 +5101,7 @@
                 <a:ea typeface="Calibri" pitchFamily="34" charset="-122"/>
                 <a:cs typeface="Calibri" pitchFamily="34" charset="-120"/>
               </a:rPr>
-              <a:t>Why buyers care: MPG is a cash-flow forecast</a:t>
+              <a:t>The productivity law holds in every class of vehicle</a:t>
             </a:r>
             <a:endParaRPr lang="en-US" sz="2900" dirty="0"/>
           </a:p>
@@ -4663,7 +5109,7 @@
       </p:sp>
       <p:pic>
         <p:nvPicPr>
-          <p:cNvPr id="3" name="Image 0" descr="C:\Users\Samson\Desktop\Homework\OS3180\Final Project\charts\fig36_price_sensitivity.png">    </p:cNvPr>
+          <p:cNvPr id="3" name="Image 0" descr="C:\Users\Samson\Desktop\Homework\OS3180\Final Project\charts\fig43_class_productivity.png">    </p:cNvPr>
           <p:cNvPicPr>
             <a:picLocks noChangeAspect="1"/>
           </p:cNvPicPr>
@@ -4677,8 +5123,8 @@
         </p:blipFill>
         <p:spPr>
           <a:xfrm>
-            <a:off x="502920" y="1325880"/>
-            <a:ext cx="7184571" cy="3657600"/>
+            <a:off x="502920" y="1188720"/>
+            <a:ext cx="7839635" cy="4846320"/>
           </a:xfrm>
           <a:prstGeom prst="rect">
             <a:avLst/>
@@ -4693,8 +5139,8 @@
         </p:nvSpPr>
         <p:spPr>
           <a:xfrm>
-            <a:off x="8092440" y="1371600"/>
-            <a:ext cx="3611880" cy="868680"/>
+            <a:off x="8778240" y="1554480"/>
+            <a:ext cx="2926080" cy="4572000"/>
           </a:xfrm>
           <a:prstGeom prst="rect">
             <a:avLst/>
@@ -4710,7 +5156,21 @@
               <a:buNone/>
             </a:pPr>
             <a:r>
-              <a:rPr lang="en-US" sz="4400" b="1" dirty="0">
+              <a:rPr lang="en-US" sz="1400" dirty="0">
+                <a:solidFill>
+                  <a:srgbClr val="0B0B0B"/>
+                </a:solidFill>
+                <a:latin typeface="Calibri" pitchFamily="34" charset="0"/>
+                <a:ea typeface="Calibri" pitchFamily="34" charset="-122"/>
+                <a:cs typeface="Calibri" pitchFamily="34" charset="-120"/>
+              </a:rPr>
+              <a:t>Sedans, SUVs, pickups, minivans — each normalized to its own 2024 design: </a:t>
+            </a:r>
+            <a:pPr indent="0" marL="0">
+              <a:buNone/>
+            </a:pPr>
+            <a:r>
+              <a:rPr lang="en-US" sz="1400" b="1" dirty="0">
                 <a:solidFill>
                   <a:srgbClr val="2A78D6"/>
                 </a:solidFill>
@@ -4718,107 +5178,30 @@
                 <a:ea typeface="Calibri" pitchFamily="34" charset="-122"/>
                 <a:cs typeface="Calibri" pitchFamily="34" charset="-120"/>
               </a:rPr>
-              <a:t>4.5 years</a:t>
-            </a:r>
-            <a:endParaRPr lang="en-US" sz="4400" dirty="0"/>
+              <a:t>2.0–2.6%/yr everywhere, R² 0.93–0.99.
+</a:t>
+            </a:r>
+            <a:pPr indent="0" marL="0">
+              <a:buNone/>
+            </a:pPr>
+            <a:r>
+              <a:rPr lang="en-US" sz="1400" dirty="0">
+                <a:solidFill>
+                  <a:srgbClr val="0B0B0B"/>
+                </a:solidFill>
+                <a:latin typeface="Calibri" pitchFamily="34" charset="0"/>
+                <a:ea typeface="Calibri" pitchFamily="34" charset="-122"/>
+                <a:cs typeface="Calibri" pitchFamily="34" charset="-120"/>
+              </a:rPr>
+              <a:t>Classes differ in level (pickup physics), barely in rate. The one outlier — Car SUV's 2023 spike — is the Model Y entering the class at 36% share; it vanishes when BEVs are removed (backup).</a:t>
+            </a:r>
+            <a:endParaRPr lang="en-US" sz="1400" dirty="0"/>
           </a:p>
         </p:txBody>
       </p:sp>
       <p:sp>
         <p:nvSpPr>
           <p:cNvPr id="5" name="Text 2"/>
-          <p:cNvSpPr txBox="1"/>
-          <p:nvPr/>
-        </p:nvSpPr>
-        <p:spPr>
-          <a:xfrm>
-            <a:off x="8092440" y="2240280"/>
-            <a:ext cx="3611880" cy="685800"/>
-          </a:xfrm>
-          <a:prstGeom prst="rect">
-            <a:avLst/>
-          </a:prstGeom>
-          <a:noFill/>
-          <a:ln/>
-        </p:spPr>
-        <p:txBody>
-          <a:bodyPr wrap="square" lIns="0" tIns="0" rIns="0" bIns="0" rtlCol="0" anchor="ctr"/>
-          <a:lstStyle/>
-          <a:p>
-            <a:pPr indent="0" marL="0">
-              <a:buNone/>
-            </a:pPr>
-            <a:r>
-              <a:rPr lang="en-US" sz="1300" dirty="0">
-                <a:solidFill>
-                  <a:srgbClr val="0B0B0B"/>
-                </a:solidFill>
-                <a:latin typeface="Calibri" pitchFamily="34" charset="0"/>
-                <a:ea typeface="Calibri" pitchFamily="34" charset="-122"/>
-                <a:cs typeface="Calibri" pitchFamily="34" charset="-120"/>
-              </a:rPr>
-              <a:t>energy savings alone repay the $6,477 EV purchase premium ($1,456 saved per year)</a:t>
-            </a:r>
-            <a:endParaRPr lang="en-US" sz="1300" dirty="0"/>
-          </a:p>
-        </p:txBody>
-      </p:sp>
-      <p:sp>
-        <p:nvSpPr>
-          <p:cNvPr id="6" name="Text 3"/>
-          <p:cNvSpPr txBox="1"/>
-          <p:nvPr/>
-        </p:nvSpPr>
-        <p:spPr>
-          <a:xfrm>
-            <a:off x="8092440" y="3566160"/>
-            <a:ext cx="3611880" cy="2377440"/>
-          </a:xfrm>
-          <a:prstGeom prst="rect">
-            <a:avLst/>
-          </a:prstGeom>
-          <a:noFill/>
-          <a:ln/>
-        </p:spPr>
-        <p:txBody>
-          <a:bodyPr wrap="square" lIns="0" tIns="0" rIns="0" bIns="0" rtlCol="0" anchor="ctr"/>
-          <a:lstStyle/>
-          <a:p>
-            <a:pPr indent="0" marL="0">
-              <a:buNone/>
-            </a:pPr>
-            <a:r>
-              <a:rPr lang="en-US" sz="1500" b="1" dirty="0">
-                <a:solidFill>
-                  <a:srgbClr val="0B0B0B"/>
-                </a:solidFill>
-                <a:latin typeface="Calibri" pitchFamily="34" charset="0"/>
-                <a:ea typeface="Calibri" pitchFamily="34" charset="-122"/>
-                <a:cs typeface="Calibri" pitchFamily="34" charset="-120"/>
-              </a:rPr>
-              <a:t>And the volatility story: </a:t>
-            </a:r>
-            <a:pPr indent="0" marL="0">
-              <a:buNone/>
-            </a:pPr>
-            <a:r>
-              <a:rPr lang="en-US" sz="1500" dirty="0">
-                <a:solidFill>
-                  <a:srgbClr val="0B0B0B"/>
-                </a:solidFill>
-                <a:latin typeface="Calibri" pitchFamily="34" charset="0"/>
-                <a:ea typeface="Calibri" pitchFamily="34" charset="-122"/>
-                <a:cs typeface="Calibri" pitchFamily="34" charset="-120"/>
-              </a:rPr>
-              <a:t>across every price observed 2011–2026, the gasoline driver's annual bill swings $1,394; the BEV driver's swings $370. The efficient vehicle is also the price-shock insurance.</a:t>
-            </a:r>
-            <a:endParaRPr lang="en-US" sz="1500" dirty="0"/>
-          </a:p>
-        </p:txBody>
-      </p:sp>
-      <p:sp>
-        <p:nvSpPr>
-          <p:cNvPr id="7" name="Text 4"/>
           <p:cNvSpPr txBox="1"/>
           <p:nvPr/>
         </p:nvSpPr>
@@ -4849,7 +5232,7 @@
                 <a:ea typeface="Calibri" pitchFamily="34" charset="-122"/>
                 <a:cs typeface="Calibri" pitchFamily="34" charset="-120"/>
               </a:rPr>
-              <a:t>fig36 (price-shock exposure); premium from KBB July 2026 ATPs (fig37); savings from fig33 cost-per-mile at 2024 prices.</a:t>
+              <a:t>EPA Trends by vehicle type; no coupe class exists in Trends (two-doors fold into Sedan/Wagon). reports/30_class_productivity.md.</a:t>
             </a:r>
             <a:endParaRPr lang="en-US" sz="1000" dirty="0"/>
           </a:p>
@@ -4913,7 +5296,7 @@
                 <a:ea typeface="Calibri" pitchFamily="34" charset="-122"/>
                 <a:cs typeface="Calibri" pitchFamily="34" charset="-120"/>
               </a:rPr>
-              <a:t>EVs: offered faster than bought, and credit-sensitive</a:t>
+              <a:t>Why buyers care: MPG is a cash-flow forecast</a:t>
             </a:r>
             <a:endParaRPr lang="en-US" sz="2900" dirty="0"/>
           </a:p>
@@ -4921,7 +5304,7 @@
       </p:sp>
       <p:pic>
         <p:nvPicPr>
-          <p:cNvPr id="3" name="Image 0" descr="C:\Users\Samson\Desktop\Homework\OS3180\Final Project\charts\fig3_ev_gap.png">    </p:cNvPr>
+          <p:cNvPr id="3" name="Image 0" descr="C:\Users\Samson\Desktop\Homework\OS3180\Final Project\charts\fig36_price_sensitivity.png">    </p:cNvPr>
           <p:cNvPicPr>
             <a:picLocks noChangeAspect="1"/>
           </p:cNvPicPr>
@@ -4935,8 +5318,8 @@
         </p:blipFill>
         <p:spPr>
           <a:xfrm>
-            <a:off x="502920" y="1188720"/>
-            <a:ext cx="7462684" cy="4206240"/>
+            <a:off x="502920" y="1325880"/>
+            <a:ext cx="7184571" cy="3657600"/>
           </a:xfrm>
           <a:prstGeom prst="rect">
             <a:avLst/>
@@ -4951,8 +5334,8 @@
         </p:nvSpPr>
         <p:spPr>
           <a:xfrm>
-            <a:off x="7680960" y="1371600"/>
-            <a:ext cx="4023360" cy="4754880"/>
+            <a:off x="8092440" y="1371600"/>
+            <a:ext cx="3611880" cy="868680"/>
           </a:xfrm>
           <a:prstGeom prst="rect">
             <a:avLst/>
@@ -4968,7 +5351,7 @@
               <a:buNone/>
             </a:pPr>
             <a:r>
-              <a:rPr lang="en-US" sz="1350" b="1" dirty="0">
+              <a:rPr lang="en-US" sz="4400" b="1" dirty="0">
                 <a:solidFill>
                   <a:srgbClr val="2A78D6"/>
                 </a:solidFill>
@@ -4976,13 +5359,38 @@
                 <a:ea typeface="Calibri" pitchFamily="34" charset="-122"/>
                 <a:cs typeface="Calibri" pitchFamily="34" charset="-120"/>
               </a:rPr>
-              <a:t>2010:  </a:t>
-            </a:r>
-            <a:pPr indent="0" marL="0">
-              <a:buNone/>
-            </a:pPr>
-            <a:r>
-              <a:rPr lang="en-US" sz="1350" dirty="0">
+              <a:t>4.5 years</a:t>
+            </a:r>
+            <a:endParaRPr lang="en-US" sz="4400" dirty="0"/>
+          </a:p>
+        </p:txBody>
+      </p:sp>
+      <p:sp>
+        <p:nvSpPr>
+          <p:cNvPr id="5" name="Text 2"/>
+          <p:cNvSpPr txBox="1"/>
+          <p:nvPr/>
+        </p:nvSpPr>
+        <p:spPr>
+          <a:xfrm>
+            <a:off x="8092440" y="2240280"/>
+            <a:ext cx="3611880" cy="685800"/>
+          </a:xfrm>
+          <a:prstGeom prst="rect">
+            <a:avLst/>
+          </a:prstGeom>
+          <a:noFill/>
+          <a:ln/>
+        </p:spPr>
+        <p:txBody>
+          <a:bodyPr wrap="square" lIns="0" tIns="0" rIns="0" bIns="0" rtlCol="0" anchor="ctr"/>
+          <a:lstStyle/>
+          <a:p>
+            <a:pPr indent="0" marL="0">
+              <a:buNone/>
+            </a:pPr>
+            <a:r>
+              <a:rPr lang="en-US" sz="1300" dirty="0">
                 <a:solidFill>
                   <a:srgbClr val="0B0B0B"/>
                 </a:solidFill>
@@ -4990,28 +5398,38 @@
                 <a:ea typeface="Calibri" pitchFamily="34" charset="-122"/>
                 <a:cs typeface="Calibri" pitchFamily="34" charset="-120"/>
               </a:rPr>
-              <a:t>first mass-market EVs delivered (Leaf, Volt)
-</a:t>
-            </a:r>
-            <a:pPr indent="0" marL="0">
-              <a:buNone/>
-            </a:pPr>
-            <a:r>
-              <a:rPr lang="en-US" sz="1350" b="1" dirty="0">
-                <a:solidFill>
-                  <a:srgbClr val="2A78D6"/>
-                </a:solidFill>
-                <a:latin typeface="Calibri" pitchFamily="34" charset="0"/>
-                <a:ea typeface="Calibri" pitchFamily="34" charset="-122"/>
-                <a:cs typeface="Calibri" pitchFamily="34" charset="-120"/>
-              </a:rPr>
-              <a:t>2022:  </a:t>
-            </a:r>
-            <a:pPr indent="0" marL="0">
-              <a:buNone/>
-            </a:pPr>
-            <a:r>
-              <a:rPr lang="en-US" sz="1350" dirty="0">
+              <a:t>energy savings alone repay the $6,477 EV purchase premium ($1,456 saved per year)</a:t>
+            </a:r>
+            <a:endParaRPr lang="en-US" sz="1300" dirty="0"/>
+          </a:p>
+        </p:txBody>
+      </p:sp>
+      <p:sp>
+        <p:nvSpPr>
+          <p:cNvPr id="6" name="Text 3"/>
+          <p:cNvSpPr txBox="1"/>
+          <p:nvPr/>
+        </p:nvSpPr>
+        <p:spPr>
+          <a:xfrm>
+            <a:off x="8092440" y="3566160"/>
+            <a:ext cx="3611880" cy="2377440"/>
+          </a:xfrm>
+          <a:prstGeom prst="rect">
+            <a:avLst/>
+          </a:prstGeom>
+          <a:noFill/>
+          <a:ln/>
+        </p:spPr>
+        <p:txBody>
+          <a:bodyPr wrap="square" lIns="0" tIns="0" rIns="0" bIns="0" rtlCol="0" anchor="ctr"/>
+          <a:lstStyle/>
+          <a:p>
+            <a:pPr indent="0" marL="0">
+              <a:buNone/>
+            </a:pPr>
+            <a:r>
+              <a:rPr lang="en-US" sz="1500" b="1" dirty="0">
                 <a:solidFill>
                   <a:srgbClr val="0B0B0B"/>
                 </a:solidFill>
@@ -5019,28 +5437,13 @@
                 <a:ea typeface="Calibri" pitchFamily="34" charset="-122"/>
                 <a:cs typeface="Calibri" pitchFamily="34" charset="-120"/>
               </a:rPr>
-              <a:t>Inflation Reduction Act revamps the $7,500 credit
-</a:t>
-            </a:r>
-            <a:pPr indent="0" marL="0">
-              <a:buNone/>
-            </a:pPr>
-            <a:r>
-              <a:rPr lang="en-US" sz="1350" b="1" dirty="0">
-                <a:solidFill>
-                  <a:srgbClr val="2A78D6"/>
-                </a:solidFill>
-                <a:latin typeface="Calibri" pitchFamily="34" charset="0"/>
-                <a:ea typeface="Calibri" pitchFamily="34" charset="-122"/>
-                <a:cs typeface="Calibri" pitchFamily="34" charset="-120"/>
-              </a:rPr>
-              <a:t>2023:  </a:t>
-            </a:r>
-            <a:pPr indent="0" marL="0">
-              <a:buNone/>
-            </a:pPr>
-            <a:r>
-              <a:rPr lang="en-US" sz="1350" dirty="0">
+              <a:t>And the volatility story: </a:t>
+            </a:r>
+            <a:pPr indent="0" marL="0">
+              <a:buNone/>
+            </a:pPr>
+            <a:r>
+              <a:rPr lang="en-US" sz="1500" dirty="0">
                 <a:solidFill>
                   <a:srgbClr val="0B0B0B"/>
                 </a:solidFill>
@@ -5048,73 +5451,15 @@
                 <a:ea typeface="Calibri" pitchFamily="34" charset="-122"/>
                 <a:cs typeface="Calibri" pitchFamily="34" charset="-120"/>
               </a:rPr>
-              <a:t>credit-driven surge — BEV share of the Car SUV class hits 35.7%
-</a:t>
-            </a:r>
-            <a:pPr indent="0" marL="0">
-              <a:buNone/>
-            </a:pPr>
-            <a:r>
-              <a:rPr lang="en-US" sz="1350" b="1" dirty="0">
-                <a:solidFill>
-                  <a:srgbClr val="2A78D6"/>
-                </a:solidFill>
-                <a:latin typeface="Calibri" pitchFamily="34" charset="0"/>
-                <a:ea typeface="Calibri" pitchFamily="34" charset="-122"/>
-                <a:cs typeface="Calibri" pitchFamily="34" charset="-120"/>
-              </a:rPr>
-              <a:t>2024:  </a:t>
-            </a:r>
-            <a:pPr indent="0" marL="0">
-              <a:buNone/>
-            </a:pPr>
-            <a:r>
-              <a:rPr lang="en-US" sz="1350" dirty="0">
-                <a:solidFill>
-                  <a:srgbClr val="0B0B0B"/>
-                </a:solidFill>
-                <a:latin typeface="Calibri" pitchFamily="34" charset="0"/>
-                <a:ea typeface="Calibri" pitchFamily="34" charset="-122"/>
-                <a:cs typeface="Calibri" pitchFamily="34" charset="-120"/>
-              </a:rPr>
-              <a:t>the hangover — sedan-class BEV share halves (14.6% → 7.1%)
-</a:t>
-            </a:r>
-            <a:pPr indent="0" marL="0">
-              <a:buNone/>
-            </a:pPr>
-            <a:r>
-              <a:rPr lang="en-US" sz="1350" b="1" dirty="0">
-                <a:solidFill>
-                  <a:srgbClr val="0B0B0B"/>
-                </a:solidFill>
-                <a:latin typeface="Calibri" pitchFamily="34" charset="0"/>
-                <a:ea typeface="Calibri" pitchFamily="34" charset="-122"/>
-                <a:cs typeface="Calibri" pitchFamily="34" charset="-120"/>
-              </a:rPr>
-              <a:t>The gap persists: 21% of the 2024 catalog is electric; 7.2% of production is. </a:t>
-            </a:r>
-            <a:pPr indent="0" marL="0">
-              <a:buNone/>
-            </a:pPr>
-            <a:r>
-              <a:rPr lang="en-US" sz="1350" dirty="0">
-                <a:solidFill>
-                  <a:srgbClr val="0B0B0B"/>
-                </a:solidFill>
-                <a:latin typeface="Calibri" pitchFamily="34" charset="0"/>
-                <a:ea typeface="Calibri" pitchFamily="34" charset="-122"/>
-                <a:cs typeface="Calibri" pitchFamily="34" charset="-120"/>
-              </a:rPr>
-              <a:t>Buyer interest tracks incentives and energy-cost advantage — which is narrowing (backup).</a:t>
-            </a:r>
-            <a:endParaRPr lang="en-US" sz="1350" dirty="0"/>
-          </a:p>
-        </p:txBody>
-      </p:sp>
-      <p:sp>
-        <p:nvSpPr>
-          <p:cNvPr id="5" name="Text 2"/>
+              <a:t>across every price observed 2011–2026, the gasoline driver's annual bill swings $1,394; the BEV driver's swings $370. The efficient vehicle is also the price-shock insurance.</a:t>
+            </a:r>
+            <a:endParaRPr lang="en-US" sz="1500" dirty="0"/>
+          </a:p>
+        </p:txBody>
+      </p:sp>
+      <p:sp>
+        <p:nvSpPr>
+          <p:cNvPr id="7" name="Text 4"/>
           <p:cNvSpPr txBox="1"/>
           <p:nvPr/>
         </p:nvSpPr>
@@ -5145,7 +5490,7 @@
                 <a:ea typeface="Calibri" pitchFamily="34" charset="-122"/>
                 <a:cs typeface="Calibri" pitchFamily="34" charset="-120"/>
               </a:rPr>
-              <a:t>fig3 (offered vs bought); events from external/events_timeline.csv (dated, cited); mix shares from EPA Trends powertrain columns.</a:t>
+              <a:t>fig36 (price-shock exposure); premium from KBB July 2026 ATPs (fig37); savings from fig33 cost-per-mile at 2024 prices.</a:t>
             </a:r>
             <a:endParaRPr lang="en-US" sz="1000" dirty="0"/>
           </a:p>
@@ -5209,7 +5554,7 @@
                 <a:ea typeface="Calibri" pitchFamily="34" charset="-122"/>
                 <a:cs typeface="Calibri" pitchFamily="34" charset="-120"/>
               </a:rPr>
-              <a:t>What arrives next follows the same S-curve, at different speeds</a:t>
+              <a:t>EVs: offered faster than bought, and credit-sensitive</a:t>
             </a:r>
             <a:endParaRPr lang="en-US" sz="2900" dirty="0"/>
           </a:p>
@@ -5217,7 +5562,7 @@
       </p:sp>
       <p:pic>
         <p:nvPicPr>
-          <p:cNvPr id="3" name="Image 0" descr="C:\Users\Samson\Desktop\Homework\OS3180\Final Project\charts\fig18_diffusion_fits.png">    </p:cNvPr>
+          <p:cNvPr id="3" name="Image 0" descr="C:\Users\Samson\Desktop\Homework\OS3180\Final Project\charts\fig3_ev_gap.png">    </p:cNvPr>
           <p:cNvPicPr>
             <a:picLocks noChangeAspect="1"/>
           </p:cNvPicPr>
@@ -5232,7 +5577,7 @@
         <p:spPr>
           <a:xfrm>
             <a:off x="502920" y="1188720"/>
-            <a:ext cx="8307977" cy="4846320"/>
+            <a:ext cx="7462684" cy="4206240"/>
           </a:xfrm>
           <a:prstGeom prst="rect">
             <a:avLst/>
@@ -5247,8 +5592,8 @@
         </p:nvSpPr>
         <p:spPr>
           <a:xfrm>
-            <a:off x="8778240" y="1554480"/>
-            <a:ext cx="2926080" cy="4572000"/>
+            <a:off x="7680960" y="1371600"/>
+            <a:ext cx="4023360" cy="4754880"/>
           </a:xfrm>
           <a:prstGeom prst="rect">
             <a:avLst/>
@@ -5264,7 +5609,21 @@
               <a:buNone/>
             </a:pPr>
             <a:r>
-              <a:rPr lang="en-US" sz="1400" dirty="0">
+              <a:rPr lang="en-US" sz="1350" b="1" dirty="0">
+                <a:solidFill>
+                  <a:srgbClr val="2A78D6"/>
+                </a:solidFill>
+                <a:latin typeface="Calibri" pitchFamily="34" charset="0"/>
+                <a:ea typeface="Calibri" pitchFamily="34" charset="-122"/>
+                <a:cs typeface="Calibri" pitchFamily="34" charset="-120"/>
+              </a:rPr>
+              <a:t>2010:  </a:t>
+            </a:r>
+            <a:pPr indent="0" marL="0">
+              <a:buNone/>
+            </a:pPr>
+            <a:r>
+              <a:rPr lang="en-US" sz="1350" dirty="0">
                 <a:solidFill>
                   <a:srgbClr val="0B0B0B"/>
                 </a:solidFill>
@@ -5272,13 +5631,14 @@
                 <a:ea typeface="Calibri" pitchFamily="34" charset="-122"/>
                 <a:cs typeface="Calibri" pitchFamily="34" charset="-120"/>
               </a:rPr>
-              <a:t>Every efficiency technology diffuses on a logistic curve; only the rate constant differs. </a:t>
-            </a:r>
-            <a:pPr indent="0" marL="0">
-              <a:buNone/>
-            </a:pPr>
-            <a:r>
-              <a:rPr lang="en-US" sz="1400" b="1" dirty="0">
+              <a:t>first mass-market EVs delivered (Leaf, Volt)
+</a:t>
+            </a:r>
+            <a:pPr indent="0" marL="0">
+              <a:buNone/>
+            </a:pPr>
+            <a:r>
+              <a:rPr lang="en-US" sz="1350" b="1" dirty="0">
                 <a:solidFill>
                   <a:srgbClr val="2A78D6"/>
                 </a:solidFill>
@@ -5286,14 +5646,42 @@
                 <a:ea typeface="Calibri" pitchFamily="34" charset="-122"/>
                 <a:cs typeface="Calibri" pitchFamily="34" charset="-120"/>
               </a:rPr>
-              <a:t>GDI took over 2.1× faster than turbo.
+              <a:t>2022:  </a:t>
+            </a:r>
+            <a:pPr indent="0" marL="0">
+              <a:buNone/>
+            </a:pPr>
+            <a:r>
+              <a:rPr lang="en-US" sz="1350" dirty="0">
+                <a:solidFill>
+                  <a:srgbClr val="0B0B0B"/>
+                </a:solidFill>
+                <a:latin typeface="Calibri" pitchFamily="34" charset="0"/>
+                <a:ea typeface="Calibri" pitchFamily="34" charset="-122"/>
+                <a:cs typeface="Calibri" pitchFamily="34" charset="-120"/>
+              </a:rPr>
+              <a:t>Inflation Reduction Act revamps the $7,500 credit
 </a:t>
             </a:r>
             <a:pPr indent="0" marL="0">
               <a:buNone/>
             </a:pPr>
             <a:r>
-              <a:rPr lang="en-US" sz="1400" dirty="0">
+              <a:rPr lang="en-US" sz="1350" b="1" dirty="0">
+                <a:solidFill>
+                  <a:srgbClr val="2A78D6"/>
+                </a:solidFill>
+                <a:latin typeface="Calibri" pitchFamily="34" charset="0"/>
+                <a:ea typeface="Calibri" pitchFamily="34" charset="-122"/>
+                <a:cs typeface="Calibri" pitchFamily="34" charset="-120"/>
+              </a:rPr>
+              <a:t>2023:  </a:t>
+            </a:r>
+            <a:pPr indent="0" marL="0">
+              <a:buNone/>
+            </a:pPr>
+            <a:r>
+              <a:rPr lang="en-US" sz="1350" dirty="0">
                 <a:solidFill>
                   <a:srgbClr val="0B0B0B"/>
                 </a:solidFill>
@@ -5301,9 +5689,67 @@
                 <a:ea typeface="Calibri" pitchFamily="34" charset="-122"/>
                 <a:cs typeface="Calibri" pitchFamily="34" charset="-120"/>
               </a:rPr>
-              <a:t>The honest open question is BEV: the data cannot yet distinguish an early S-curve from a low plateau — its fitted ceiling carries the widest confidence interval on the page.</a:t>
-            </a:r>
-            <a:endParaRPr lang="en-US" sz="1400" dirty="0"/>
+              <a:t>credit-driven surge — BEV share of the Car SUV class hits 35.7%
+</a:t>
+            </a:r>
+            <a:pPr indent="0" marL="0">
+              <a:buNone/>
+            </a:pPr>
+            <a:r>
+              <a:rPr lang="en-US" sz="1350" b="1" dirty="0">
+                <a:solidFill>
+                  <a:srgbClr val="2A78D6"/>
+                </a:solidFill>
+                <a:latin typeface="Calibri" pitchFamily="34" charset="0"/>
+                <a:ea typeface="Calibri" pitchFamily="34" charset="-122"/>
+                <a:cs typeface="Calibri" pitchFamily="34" charset="-120"/>
+              </a:rPr>
+              <a:t>2024:  </a:t>
+            </a:r>
+            <a:pPr indent="0" marL="0">
+              <a:buNone/>
+            </a:pPr>
+            <a:r>
+              <a:rPr lang="en-US" sz="1350" dirty="0">
+                <a:solidFill>
+                  <a:srgbClr val="0B0B0B"/>
+                </a:solidFill>
+                <a:latin typeface="Calibri" pitchFamily="34" charset="0"/>
+                <a:ea typeface="Calibri" pitchFamily="34" charset="-122"/>
+                <a:cs typeface="Calibri" pitchFamily="34" charset="-120"/>
+              </a:rPr>
+              <a:t>the hangover — sedan-class BEV share halves (14.6% → 7.1%)
+</a:t>
+            </a:r>
+            <a:pPr indent="0" marL="0">
+              <a:buNone/>
+            </a:pPr>
+            <a:r>
+              <a:rPr lang="en-US" sz="1350" b="1" dirty="0">
+                <a:solidFill>
+                  <a:srgbClr val="0B0B0B"/>
+                </a:solidFill>
+                <a:latin typeface="Calibri" pitchFamily="34" charset="0"/>
+                <a:ea typeface="Calibri" pitchFamily="34" charset="-122"/>
+                <a:cs typeface="Calibri" pitchFamily="34" charset="-120"/>
+              </a:rPr>
+              <a:t>The gap persists: 21% of the 2024 catalog is electric; 7.2% of production is. </a:t>
+            </a:r>
+            <a:pPr indent="0" marL="0">
+              <a:buNone/>
+            </a:pPr>
+            <a:r>
+              <a:rPr lang="en-US" sz="1350" dirty="0">
+                <a:solidFill>
+                  <a:srgbClr val="0B0B0B"/>
+                </a:solidFill>
+                <a:latin typeface="Calibri" pitchFamily="34" charset="0"/>
+                <a:ea typeface="Calibri" pitchFamily="34" charset="-122"/>
+                <a:cs typeface="Calibri" pitchFamily="34" charset="-120"/>
+              </a:rPr>
+              <a:t>Buyer interest tracks incentives and energy-cost advantage — which is narrowing (backup).</a:t>
+            </a:r>
+            <a:endParaRPr lang="en-US" sz="1350" dirty="0"/>
           </a:p>
         </p:txBody>
       </p:sp>
@@ -5340,7 +5786,7 @@
                 <a:ea typeface="Calibri" pitchFamily="34" charset="-122"/>
                 <a:cs typeface="Calibri" pitchFamily="34" charset="-120"/>
               </a:rPr>
-              <a:t>Logistic fits, ceiling estimated not assumed; bootstrap CIs in reports/10_statistics.md. Dashed = extrapolation.</a:t>
+              <a:t>fig3 (offered vs bought); events from external/events_timeline.csv (dated, cited); mix shares from EPA Trends powertrain columns.</a:t>
             </a:r>
             <a:endParaRPr lang="en-US" sz="1000" dirty="0"/>
           </a:p>
@@ -5404,7 +5850,7 @@
                 <a:ea typeface="Calibri" pitchFamily="34" charset="-122"/>
                 <a:cs typeface="Calibri" pitchFamily="34" charset="-120"/>
               </a:rPr>
-              <a:t>At trend: 40–44 MPG-equivalent by 2045, and the sales mix decides</a:t>
+              <a:t>What arrives next follows the same S-curve, at different speeds</a:t>
             </a:r>
             <a:endParaRPr lang="en-US" sz="2900" dirty="0"/>
           </a:p>
@@ -5412,7 +5858,7 @@
       </p:sp>
       <p:pic>
         <p:nvPicPr>
-          <p:cNvPr id="3" name="Image 0" descr="C:\Users\Samson\Desktop\Homework\OS3180\Final Project\charts\fig42_productivity_projection.png">    </p:cNvPr>
+          <p:cNvPr id="3" name="Image 0" descr="C:\Users\Samson\Desktop\Homework\OS3180\Final Project\charts\fig18_diffusion_fits.png">    </p:cNvPr>
           <p:cNvPicPr>
             <a:picLocks noChangeAspect="1"/>
           </p:cNvPicPr>
@@ -5427,7 +5873,7 @@
         <p:spPr>
           <a:xfrm>
             <a:off x="502920" y="1188720"/>
-            <a:ext cx="7700963" cy="4480560"/>
+            <a:ext cx="8307977" cy="4846320"/>
           </a:xfrm>
           <a:prstGeom prst="rect">
             <a:avLst/>
@@ -5442,8 +5888,8 @@
         </p:nvSpPr>
         <p:spPr>
           <a:xfrm>
-            <a:off x="8366760" y="1463040"/>
-            <a:ext cx="3337560" cy="4754880"/>
+            <a:off x="8778240" y="1554480"/>
+            <a:ext cx="2926080" cy="4572000"/>
           </a:xfrm>
           <a:prstGeom prst="rect">
             <a:avLst/>
@@ -5459,73 +5905,44 @@
               <a:buNone/>
             </a:pPr>
             <a:r>
+              <a:rPr lang="en-US" sz="1400" dirty="0">
+                <a:solidFill>
+                  <a:srgbClr val="0B0B0B"/>
+                </a:solidFill>
+                <a:latin typeface="Calibri" pitchFamily="34" charset="0"/>
+                <a:ea typeface="Calibri" pitchFamily="34" charset="-122"/>
+                <a:cs typeface="Calibri" pitchFamily="34" charset="-120"/>
+              </a:rPr>
+              <a:t>Every efficiency technology diffuses on a logistic curve; only the rate constant differs. </a:t>
+            </a:r>
+            <a:pPr indent="0" marL="0">
+              <a:buNone/>
+            </a:pPr>
+            <a:r>
               <a:rPr lang="en-US" sz="1400" b="1" dirty="0">
                 <a:solidFill>
+                  <a:srgbClr val="2A78D6"/>
+                </a:solidFill>
+                <a:latin typeface="Calibri" pitchFamily="34" charset="0"/>
+                <a:ea typeface="Calibri" pitchFamily="34" charset="-122"/>
+                <a:cs typeface="Calibri" pitchFamily="34" charset="-120"/>
+              </a:rPr>
+              <a:t>GDI took over 2.1× faster than turbo.
+</a:t>
+            </a:r>
+            <a:pPr indent="0" marL="0">
+              <a:buNone/>
+            </a:pPr>
+            <a:r>
+              <a:rPr lang="en-US" sz="1400" dirty="0">
+                <a:solidFill>
                   <a:srgbClr val="0B0B0B"/>
                 </a:solidFill>
                 <a:latin typeface="Calibri" pitchFamily="34" charset="0"/>
                 <a:ea typeface="Calibri" pitchFamily="34" charset="-122"/>
                 <a:cs typeface="Calibri" pitchFamily="34" charset="-120"/>
               </a:rPr>
-              <a:t>The full-fleet projection (BEVs in): </a:t>
-            </a:r>
-            <a:pPr indent="0" marL="0">
-              <a:buNone/>
-            </a:pPr>
-            <a:r>
-              <a:rPr lang="en-US" sz="1400" dirty="0">
-                <a:solidFill>
-                  <a:srgbClr val="0B0B0B"/>
-                </a:solidFill>
-                <a:latin typeface="Calibri" pitchFamily="34" charset="0"/>
-                <a:ea typeface="Calibri" pitchFamily="34" charset="-122"/>
-                <a:cs typeface="Calibri" pitchFamily="34" charset="-120"/>
-              </a:rPr>
-              <a:t>44 by 2045 at the recent rate, 40 at the 50-year rate.
-</a:t>
-            </a:r>
-            <a:pPr indent="0" marL="0">
-              <a:buNone/>
-            </a:pPr>
-            <a:r>
-              <a:rPr lang="en-US" sz="1400" b="1" dirty="0">
-                <a:solidFill>
-                  <a:srgbClr val="1BAF7A"/>
-                </a:solidFill>
-                <a:latin typeface="Calibri" pitchFamily="34" charset="0"/>
-                <a:ea typeface="Calibri" pitchFamily="34" charset="-122"/>
-                <a:cs typeface="Calibri" pitchFamily="34" charset="-120"/>
-              </a:rPr>
-              <a:t>Combustion alone delivers 39 </a:t>
-            </a:r>
-            <a:pPr indent="0" marL="0">
-              <a:buNone/>
-            </a:pPr>
-            <a:r>
-              <a:rPr lang="en-US" sz="1400" dirty="0">
-                <a:solidFill>
-                  <a:srgbClr val="0B0B0B"/>
-                </a:solidFill>
-                <a:latin typeface="Calibri" pitchFamily="34" charset="0"/>
-                <a:ea typeface="Calibri" pitchFamily="34" charset="-122"/>
-                <a:cs typeface="Calibri" pitchFamily="34" charset="-120"/>
-              </a:rPr>
-              <a:t>(previous slide's series projected) — so ~5 MPG-equivalent of the difference is electrification's contribution, which the sales mix, not the lab, will decide.
-</a:t>
-            </a:r>
-            <a:pPr indent="0" marL="0">
-              <a:buNone/>
-            </a:pPr>
-            <a:r>
-              <a:rPr lang="en-US" sz="1400" i="1" dirty="0">
-                <a:solidFill>
-                  <a:srgbClr val="6E6C66"/>
-                </a:solidFill>
-                <a:latin typeface="Calibri" pitchFamily="34" charset="0"/>
-                <a:ea typeface="Calibri" pitchFamily="34" charset="-122"/>
-                <a:cs typeface="Calibri" pitchFamily="34" charset="-120"/>
-              </a:rPr>
-              <a:t>Design → MPG → cost/mile → what consumers buy → fleet fuel economy: with the equation in hand, each link is quantified.</a:t>
+              <a:t>The honest open question is BEV: the data cannot yet distinguish an early S-curve from a low plateau — its fitted ceiling carries the widest confidence interval on the page.</a:t>
             </a:r>
             <a:endParaRPr lang="en-US" sz="1400" dirty="0"/>
           </a:p>
@@ -5564,7 +5981,7 @@
                 <a:ea typeface="Calibri" pitchFamily="34" charset="-122"/>
                 <a:cs typeface="Calibri" pitchFamily="34" charset="-120"/>
               </a:rPr>
-              <a:t>Stage 29/31; slope-CI band shown; scenario uncertainty dominates and the two rates bracket, not bound, the future.</a:t>
+              <a:t>Logistic fits, ceiling estimated not assumed; bootstrap CIs in reports/10_statistics.md. Dashed = extrapolation.</a:t>
             </a:r>
             <a:endParaRPr lang="en-US" sz="1000" dirty="0"/>
           </a:p>
@@ -5628,227 +6045,15 @@
                 <a:ea typeface="Calibri" pitchFamily="34" charset="-122"/>
                 <a:cs typeface="Calibri" pitchFamily="34" charset="-120"/>
               </a:rPr>
-              <a:t>Limitations, stated plainly</a:t>
+              <a:t>At trend: 40–44 MPG-equivalent by 2045, and the sales mix decides</a:t>
             </a:r>
             <a:endParaRPr lang="en-US" sz="2900" dirty="0"/>
-          </a:p>
-        </p:txBody>
-      </p:sp>
-      <p:sp>
-        <p:nvSpPr>
-          <p:cNvPr id="3" name="Text 1"/>
-          <p:cNvSpPr txBox="1"/>
-          <p:nvPr/>
-        </p:nvSpPr>
-        <p:spPr>
-          <a:xfrm>
-            <a:off x="502920" y="1325880"/>
-            <a:ext cx="6400800" cy="1051560"/>
-          </a:xfrm>
-          <a:prstGeom prst="rect">
-            <a:avLst/>
-          </a:prstGeom>
-          <a:noFill/>
-          <a:ln/>
-        </p:spPr>
-        <p:txBody>
-          <a:bodyPr wrap="square" lIns="0" tIns="0" rIns="0" bIns="0" rtlCol="0" anchor="ctr"/>
-          <a:lstStyle/>
-          <a:p>
-            <a:pPr indent="0" marL="0">
-              <a:buNone/>
-            </a:pPr>
-            <a:r>
-              <a:rPr lang="en-US" sz="1450" b="1" dirty="0">
-                <a:solidFill>
-                  <a:srgbClr val="2A78D6"/>
-                </a:solidFill>
-                <a:latin typeface="Calibri" pitchFamily="34" charset="0"/>
-                <a:ea typeface="Calibri" pitchFamily="34" charset="-122"/>
-                <a:cs typeface="Calibri" pitchFamily="34" charset="-120"/>
-              </a:rPr>
-              <a:t>Cross-sectional elasticities.  </a:t>
-            </a:r>
-            <a:pPr indent="0" marL="0">
-              <a:buNone/>
-            </a:pPr>
-            <a:r>
-              <a:rPr lang="en-US" sz="1450" dirty="0">
-                <a:solidFill>
-                  <a:srgbClr val="0B0B0B"/>
-                </a:solidFill>
-                <a:latin typeface="Calibri" pitchFamily="34" charset="0"/>
-                <a:ea typeface="Calibri" pitchFamily="34" charset="-122"/>
-                <a:cs typeface="Calibri" pitchFamily="34" charset="-120"/>
-              </a:rPr>
-              <a:t>Estimated on the 2024 fleet, applied across five decades for normalization: a stability assumption, partially supported by era refits (R² 0.71-0.78).</a:t>
-            </a:r>
-            <a:endParaRPr lang="en-US" sz="1450" dirty="0"/>
-          </a:p>
-        </p:txBody>
-      </p:sp>
-      <p:sp>
-        <p:nvSpPr>
-          <p:cNvPr id="4" name="Text 2"/>
-          <p:cNvSpPr txBox="1"/>
-          <p:nvPr/>
-        </p:nvSpPr>
-        <p:spPr>
-          <a:xfrm>
-            <a:off x="502920" y="2423160"/>
-            <a:ext cx="6400800" cy="1051560"/>
-          </a:xfrm>
-          <a:prstGeom prst="rect">
-            <a:avLst/>
-          </a:prstGeom>
-          <a:noFill/>
-          <a:ln/>
-        </p:spPr>
-        <p:txBody>
-          <a:bodyPr wrap="square" lIns="0" tIns="0" rIns="0" bIns="0" rtlCol="0" anchor="ctr"/>
-          <a:lstStyle/>
-          <a:p>
-            <a:pPr indent="0" marL="0">
-              <a:buNone/>
-            </a:pPr>
-            <a:r>
-              <a:rPr lang="en-US" sz="1450" b="1" dirty="0">
-                <a:solidFill>
-                  <a:srgbClr val="2A78D6"/>
-                </a:solidFill>
-                <a:latin typeface="Calibri" pitchFamily="34" charset="0"/>
-                <a:ea typeface="Calibri" pitchFamily="34" charset="-122"/>
-                <a:cs typeface="Calibri" pitchFamily="34" charset="-120"/>
-              </a:rPr>
-              <a:t>Lab MPG, not window sticker.  </a:t>
-            </a:r>
-            <a:pPr indent="0" marL="0">
-              <a:buNone/>
-            </a:pPr>
-            <a:r>
-              <a:rPr lang="en-US" sz="1450" dirty="0">
-                <a:solidFill>
-                  <a:srgbClr val="0B0B0B"/>
-                </a:solidFill>
-                <a:latin typeface="Calibri" pitchFamily="34" charset="0"/>
-                <a:ea typeface="Calibri" pitchFamily="34" charset="-122"/>
-                <a:cs typeface="Calibri" pitchFamily="34" charset="-120"/>
-              </a:rPr>
-              <a:t>The DV is the unadjusted 2-cycle test — a consistent basis, but it runs ~31% above real-world driving by 2024 (chart at right).</a:t>
-            </a:r>
-            <a:endParaRPr lang="en-US" sz="1450" dirty="0"/>
-          </a:p>
-        </p:txBody>
-      </p:sp>
-      <p:sp>
-        <p:nvSpPr>
-          <p:cNvPr id="5" name="Text 3"/>
-          <p:cNvSpPr txBox="1"/>
-          <p:nvPr/>
-        </p:nvSpPr>
-        <p:spPr>
-          <a:xfrm>
-            <a:off x="502920" y="3520440"/>
-            <a:ext cx="6400800" cy="1051560"/>
-          </a:xfrm>
-          <a:prstGeom prst="rect">
-            <a:avLst/>
-          </a:prstGeom>
-          <a:noFill/>
-          <a:ln/>
-        </p:spPr>
-        <p:txBody>
-          <a:bodyPr wrap="square" lIns="0" tIns="0" rIns="0" bIns="0" rtlCol="0" anchor="ctr"/>
-          <a:lstStyle/>
-          <a:p>
-            <a:pPr indent="0" marL="0">
-              <a:buNone/>
-            </a:pPr>
-            <a:r>
-              <a:rPr lang="en-US" sz="1450" b="1" dirty="0">
-                <a:solidFill>
-                  <a:srgbClr val="2A78D6"/>
-                </a:solidFill>
-                <a:latin typeface="Calibri" pitchFamily="34" charset="0"/>
-                <a:ea typeface="Calibri" pitchFamily="34" charset="-122"/>
-                <a:cs typeface="Calibri" pitchFamily="34" charset="-120"/>
-              </a:rPr>
-              <a:t>Projections are trend extrapolations.  </a:t>
-            </a:r>
-            <a:pPr indent="0" marL="0">
-              <a:buNone/>
-            </a:pPr>
-            <a:r>
-              <a:rPr lang="en-US" sz="1450" dirty="0">
-                <a:solidFill>
-                  <a:srgbClr val="0B0B0B"/>
-                </a:solidFill>
-                <a:latin typeface="Calibri" pitchFamily="34" charset="0"/>
-                <a:ea typeface="Calibri" pitchFamily="34" charset="-122"/>
-                <a:cs typeface="Calibri" pitchFamily="34" charset="-120"/>
-              </a:rPr>
-              <a:t>Log-linear, no physics ceiling, no policy scenario; the CI bands carry fit uncertainty only, and scenario uncertainty dominates.</a:t>
-            </a:r>
-            <a:endParaRPr lang="en-US" sz="1450" dirty="0"/>
-          </a:p>
-        </p:txBody>
-      </p:sp>
-      <p:sp>
-        <p:nvSpPr>
-          <p:cNvPr id="6" name="Text 4"/>
-          <p:cNvSpPr txBox="1"/>
-          <p:nvPr/>
-        </p:nvSpPr>
-        <p:spPr>
-          <a:xfrm>
-            <a:off x="502920" y="4617720"/>
-            <a:ext cx="6400800" cy="1051560"/>
-          </a:xfrm>
-          <a:prstGeom prst="rect">
-            <a:avLst/>
-          </a:prstGeom>
-          <a:noFill/>
-          <a:ln/>
-        </p:spPr>
-        <p:txBody>
-          <a:bodyPr wrap="square" lIns="0" tIns="0" rIns="0" bIns="0" rtlCol="0" anchor="ctr"/>
-          <a:lstStyle/>
-          <a:p>
-            <a:pPr indent="0" marL="0">
-              <a:buNone/>
-            </a:pPr>
-            <a:r>
-              <a:rPr lang="en-US" sz="1450" b="1" dirty="0">
-                <a:solidFill>
-                  <a:srgbClr val="2A78D6"/>
-                </a:solidFill>
-                <a:latin typeface="Calibri" pitchFamily="34" charset="0"/>
-                <a:ea typeface="Calibri" pitchFamily="34" charset="-122"/>
-                <a:cs typeface="Calibri" pitchFamily="34" charset="-120"/>
-              </a:rPr>
-              <a:t>EVs modeled separately; Tesla as BEV proxy.  </a:t>
-            </a:r>
-            <a:pPr indent="0" marL="0">
-              <a:buNone/>
-            </a:pPr>
-            <a:r>
-              <a:rPr lang="en-US" sz="1450" dirty="0">
-                <a:solidFill>
-                  <a:srgbClr val="0B0B0B"/>
-                </a:solidFill>
-                <a:latin typeface="Calibri" pitchFamily="34" charset="0"/>
-                <a:ea typeface="Calibri" pitchFamily="34" charset="-122"/>
-                <a:cs typeface="Calibri" pitchFamily="34" charset="-120"/>
-              </a:rPr>
-              <a:t>MPGe is a different quantity (BEV companion model, R² 0.708); the ex-BEV series leans on the Tesla proxy, first-order only inside 2023's Car SUV class.</a:t>
-            </a:r>
-            <a:endParaRPr lang="en-US" sz="1450" dirty="0"/>
           </a:p>
         </p:txBody>
       </p:sp>
       <p:pic>
         <p:nvPicPr>
-          <p:cNvPr id="7" name="Image 0" descr="C:\Users\Samson\Desktop\Homework\OS3180\Final Project\charts\fig7_lab_vs_road.png">    </p:cNvPr>
+          <p:cNvPr id="3" name="Image 0" descr="C:\Users\Samson\Desktop\Homework\OS3180\Final Project\charts\fig42_productivity_projection.png">    </p:cNvPr>
           <p:cNvPicPr>
             <a:picLocks noChangeAspect="1"/>
           </p:cNvPicPr>
@@ -5862,8 +6067,8 @@
         </p:blipFill>
         <p:spPr>
           <a:xfrm>
-            <a:off x="7223760" y="1463040"/>
-            <a:ext cx="4434840" cy="2499637"/>
+            <a:off x="502920" y="1188720"/>
+            <a:ext cx="7700963" cy="4480560"/>
           </a:xfrm>
           <a:prstGeom prst="rect">
             <a:avLst/>
@@ -5872,14 +6077,14 @@
       </p:pic>
       <p:sp>
         <p:nvSpPr>
-          <p:cNvPr id="8" name="Text 5"/>
+          <p:cNvPr id="4" name="Text 1"/>
           <p:cNvSpPr txBox="1"/>
           <p:nvPr/>
         </p:nvSpPr>
         <p:spPr>
           <a:xfrm>
-            <a:off x="7223760" y="4206240"/>
-            <a:ext cx="4480560" cy="365760"/>
+            <a:off x="8366760" y="1463040"/>
+            <a:ext cx="3337560" cy="4754880"/>
           </a:xfrm>
           <a:prstGeom prst="rect">
             <a:avLst/>
@@ -5895,7 +6100,65 @@
               <a:buNone/>
             </a:pPr>
             <a:r>
-              <a:rPr lang="en-US" sz="1200" dirty="0">
+              <a:rPr lang="en-US" sz="1400" b="1" dirty="0">
+                <a:solidFill>
+                  <a:srgbClr val="0B0B0B"/>
+                </a:solidFill>
+                <a:latin typeface="Calibri" pitchFamily="34" charset="0"/>
+                <a:ea typeface="Calibri" pitchFamily="34" charset="-122"/>
+                <a:cs typeface="Calibri" pitchFamily="34" charset="-120"/>
+              </a:rPr>
+              <a:t>The full-fleet projection (BEVs in): </a:t>
+            </a:r>
+            <a:pPr indent="0" marL="0">
+              <a:buNone/>
+            </a:pPr>
+            <a:r>
+              <a:rPr lang="en-US" sz="1400" dirty="0">
+                <a:solidFill>
+                  <a:srgbClr val="0B0B0B"/>
+                </a:solidFill>
+                <a:latin typeface="Calibri" pitchFamily="34" charset="0"/>
+                <a:ea typeface="Calibri" pitchFamily="34" charset="-122"/>
+                <a:cs typeface="Calibri" pitchFamily="34" charset="-120"/>
+              </a:rPr>
+              <a:t>44 by 2045 at the recent rate, 40 at the 50-year rate.
+</a:t>
+            </a:r>
+            <a:pPr indent="0" marL="0">
+              <a:buNone/>
+            </a:pPr>
+            <a:r>
+              <a:rPr lang="en-US" sz="1400" b="1" dirty="0">
+                <a:solidFill>
+                  <a:srgbClr val="1BAF7A"/>
+                </a:solidFill>
+                <a:latin typeface="Calibri" pitchFamily="34" charset="0"/>
+                <a:ea typeface="Calibri" pitchFamily="34" charset="-122"/>
+                <a:cs typeface="Calibri" pitchFamily="34" charset="-120"/>
+              </a:rPr>
+              <a:t>Combustion alone delivers 39 </a:t>
+            </a:r>
+            <a:pPr indent="0" marL="0">
+              <a:buNone/>
+            </a:pPr>
+            <a:r>
+              <a:rPr lang="en-US" sz="1400" dirty="0">
+                <a:solidFill>
+                  <a:srgbClr val="0B0B0B"/>
+                </a:solidFill>
+                <a:latin typeface="Calibri" pitchFamily="34" charset="0"/>
+                <a:ea typeface="Calibri" pitchFamily="34" charset="-122"/>
+                <a:cs typeface="Calibri" pitchFamily="34" charset="-120"/>
+              </a:rPr>
+              <a:t>(previous slide's series projected) — so ~5 MPG-equivalent of the difference is electrification's contribution, which the sales mix, not the lab, will decide.
+</a:t>
+            </a:r>
+            <a:pPr indent="0" marL="0">
+              <a:buNone/>
+            </a:pPr>
+            <a:r>
+              <a:rPr lang="en-US" sz="1400" i="1" dirty="0">
                 <a:solidFill>
                   <a:srgbClr val="6E6C66"/>
                 </a:solidFill>
@@ -5903,15 +6166,15 @@
                 <a:ea typeface="Calibri" pitchFamily="34" charset="-122"/>
                 <a:cs typeface="Calibri" pitchFamily="34" charset="-120"/>
               </a:rPr>
-              <a:t>The lab-vs-road gap, 1975–2024</a:t>
-            </a:r>
-            <a:endParaRPr lang="en-US" sz="1200" dirty="0"/>
-          </a:p>
-        </p:txBody>
-      </p:sp>
-      <p:sp>
-        <p:nvSpPr>
-          <p:cNvPr id="9" name="Text 6"/>
+              <a:t>Design → MPG → cost/mile → what consumers buy → fleet fuel economy: with the equation in hand, each link is quantified.</a:t>
+            </a:r>
+            <a:endParaRPr lang="en-US" sz="1400" dirty="0"/>
+          </a:p>
+        </p:txBody>
+      </p:sp>
+      <p:sp>
+        <p:nvSpPr>
+          <p:cNvPr id="5" name="Text 2"/>
           <p:cNvSpPr txBox="1"/>
           <p:nvPr/>
         </p:nvSpPr>
@@ -5942,7 +6205,7 @@
                 <a:ea typeface="Calibri" pitchFamily="34" charset="-122"/>
                 <a:cs typeface="Calibri" pitchFamily="34" charset="-120"/>
               </a:rPr>
-              <a:t>Full limitations: reports/19_final_model.md, 29_productivity.md, 31_ice_productivity.md.</a:t>
+              <a:t>Stage 29/31; slope-CI band shown; scenario uncertainty dominates and the two rates bracket, not bound, the future.</a:t>
             </a:r>
             <a:endParaRPr lang="en-US" sz="1000" dirty="0"/>
           </a:p>
@@ -6410,6 +6673,384 @@
 <file path=ppt/slides/slide20.xml><?xml version="1.0" encoding="utf-8"?>
 <p:sld xmlns:a="http://schemas.openxmlformats.org/drawingml/2006/main" xmlns:r="http://schemas.openxmlformats.org/officeDocument/2006/relationships" xmlns:p="http://schemas.openxmlformats.org/presentationml/2006/main">
   <p:cSld name="Slide 20">
+    <p:spTree>
+      <p:nvGrpSpPr>
+        <p:cNvPr id="1" name=""/>
+        <p:cNvGrpSpPr/>
+        <p:nvPr/>
+      </p:nvGrpSpPr>
+      <p:grpSpPr>
+        <a:xfrm>
+          <a:off x="0" y="0"/>
+          <a:ext cx="0" cy="0"/>
+          <a:chOff x="0" y="0"/>
+          <a:chExt cx="0" cy="0"/>
+        </a:xfrm>
+      </p:grpSpPr>
+      <p:sp>
+        <p:nvSpPr>
+          <p:cNvPr id="2" name="Text 0"/>
+          <p:cNvSpPr txBox="1"/>
+          <p:nvPr/>
+        </p:nvSpPr>
+        <p:spPr>
+          <a:xfrm>
+            <a:off x="502920" y="292608"/>
+            <a:ext cx="11155680" cy="685800"/>
+          </a:xfrm>
+          <a:prstGeom prst="rect">
+            <a:avLst/>
+          </a:prstGeom>
+          <a:noFill/>
+          <a:ln/>
+        </p:spPr>
+        <p:txBody>
+          <a:bodyPr wrap="square" lIns="0" tIns="0" rIns="0" bIns="0" rtlCol="0" anchor="ctr"/>
+          <a:lstStyle/>
+          <a:p>
+            <a:pPr indent="0" marL="0">
+              <a:buNone/>
+            </a:pPr>
+            <a:r>
+              <a:rPr lang="en-US" sz="2900" b="1" dirty="0">
+                <a:solidFill>
+                  <a:srgbClr val="0B0B0B"/>
+                </a:solidFill>
+                <a:latin typeface="Calibri" pitchFamily="34" charset="0"/>
+                <a:ea typeface="Calibri" pitchFamily="34" charset="-122"/>
+                <a:cs typeface="Calibri" pitchFamily="34" charset="-120"/>
+              </a:rPr>
+              <a:t>Limitations, stated plainly</a:t>
+            </a:r>
+            <a:endParaRPr lang="en-US" sz="2900" dirty="0"/>
+          </a:p>
+        </p:txBody>
+      </p:sp>
+      <p:sp>
+        <p:nvSpPr>
+          <p:cNvPr id="3" name="Text 1"/>
+          <p:cNvSpPr txBox="1"/>
+          <p:nvPr/>
+        </p:nvSpPr>
+        <p:spPr>
+          <a:xfrm>
+            <a:off x="502920" y="1325880"/>
+            <a:ext cx="6400800" cy="1051560"/>
+          </a:xfrm>
+          <a:prstGeom prst="rect">
+            <a:avLst/>
+          </a:prstGeom>
+          <a:noFill/>
+          <a:ln/>
+        </p:spPr>
+        <p:txBody>
+          <a:bodyPr wrap="square" lIns="0" tIns="0" rIns="0" bIns="0" rtlCol="0" anchor="ctr"/>
+          <a:lstStyle/>
+          <a:p>
+            <a:pPr indent="0" marL="0">
+              <a:buNone/>
+            </a:pPr>
+            <a:r>
+              <a:rPr lang="en-US" sz="1450" b="1" dirty="0">
+                <a:solidFill>
+                  <a:srgbClr val="2A78D6"/>
+                </a:solidFill>
+                <a:latin typeface="Calibri" pitchFamily="34" charset="0"/>
+                <a:ea typeface="Calibri" pitchFamily="34" charset="-122"/>
+                <a:cs typeface="Calibri" pitchFamily="34" charset="-120"/>
+              </a:rPr>
+              <a:t>Cross-sectional elasticities.  </a:t>
+            </a:r>
+            <a:pPr indent="0" marL="0">
+              <a:buNone/>
+            </a:pPr>
+            <a:r>
+              <a:rPr lang="en-US" sz="1450" dirty="0">
+                <a:solidFill>
+                  <a:srgbClr val="0B0B0B"/>
+                </a:solidFill>
+                <a:latin typeface="Calibri" pitchFamily="34" charset="0"/>
+                <a:ea typeface="Calibri" pitchFamily="34" charset="-122"/>
+                <a:cs typeface="Calibri" pitchFamily="34" charset="-120"/>
+              </a:rPr>
+              <a:t>Estimated on the 2024 fleet, applied across five decades for normalization: a stability assumption, partially supported by era refits (R² 0.71-0.78).</a:t>
+            </a:r>
+            <a:endParaRPr lang="en-US" sz="1450" dirty="0"/>
+          </a:p>
+        </p:txBody>
+      </p:sp>
+      <p:sp>
+        <p:nvSpPr>
+          <p:cNvPr id="4" name="Text 2"/>
+          <p:cNvSpPr txBox="1"/>
+          <p:nvPr/>
+        </p:nvSpPr>
+        <p:spPr>
+          <a:xfrm>
+            <a:off x="502920" y="2423160"/>
+            <a:ext cx="6400800" cy="1051560"/>
+          </a:xfrm>
+          <a:prstGeom prst="rect">
+            <a:avLst/>
+          </a:prstGeom>
+          <a:noFill/>
+          <a:ln/>
+        </p:spPr>
+        <p:txBody>
+          <a:bodyPr wrap="square" lIns="0" tIns="0" rIns="0" bIns="0" rtlCol="0" anchor="ctr"/>
+          <a:lstStyle/>
+          <a:p>
+            <a:pPr indent="0" marL="0">
+              <a:buNone/>
+            </a:pPr>
+            <a:r>
+              <a:rPr lang="en-US" sz="1450" b="1" dirty="0">
+                <a:solidFill>
+                  <a:srgbClr val="2A78D6"/>
+                </a:solidFill>
+                <a:latin typeface="Calibri" pitchFamily="34" charset="0"/>
+                <a:ea typeface="Calibri" pitchFamily="34" charset="-122"/>
+                <a:cs typeface="Calibri" pitchFamily="34" charset="-120"/>
+              </a:rPr>
+              <a:t>Lab MPG, not window sticker.  </a:t>
+            </a:r>
+            <a:pPr indent="0" marL="0">
+              <a:buNone/>
+            </a:pPr>
+            <a:r>
+              <a:rPr lang="en-US" sz="1450" dirty="0">
+                <a:solidFill>
+                  <a:srgbClr val="0B0B0B"/>
+                </a:solidFill>
+                <a:latin typeface="Calibri" pitchFamily="34" charset="0"/>
+                <a:ea typeface="Calibri" pitchFamily="34" charset="-122"/>
+                <a:cs typeface="Calibri" pitchFamily="34" charset="-120"/>
+              </a:rPr>
+              <a:t>The DV is the unadjusted 2-cycle test — a consistent basis, but it runs ~31% above real-world driving by 2024 (chart at right).</a:t>
+            </a:r>
+            <a:endParaRPr lang="en-US" sz="1450" dirty="0"/>
+          </a:p>
+        </p:txBody>
+      </p:sp>
+      <p:sp>
+        <p:nvSpPr>
+          <p:cNvPr id="5" name="Text 3"/>
+          <p:cNvSpPr txBox="1"/>
+          <p:nvPr/>
+        </p:nvSpPr>
+        <p:spPr>
+          <a:xfrm>
+            <a:off x="502920" y="3520440"/>
+            <a:ext cx="6400800" cy="1051560"/>
+          </a:xfrm>
+          <a:prstGeom prst="rect">
+            <a:avLst/>
+          </a:prstGeom>
+          <a:noFill/>
+          <a:ln/>
+        </p:spPr>
+        <p:txBody>
+          <a:bodyPr wrap="square" lIns="0" tIns="0" rIns="0" bIns="0" rtlCol="0" anchor="ctr"/>
+          <a:lstStyle/>
+          <a:p>
+            <a:pPr indent="0" marL="0">
+              <a:buNone/>
+            </a:pPr>
+            <a:r>
+              <a:rPr lang="en-US" sz="1450" b="1" dirty="0">
+                <a:solidFill>
+                  <a:srgbClr val="2A78D6"/>
+                </a:solidFill>
+                <a:latin typeface="Calibri" pitchFamily="34" charset="0"/>
+                <a:ea typeface="Calibri" pitchFamily="34" charset="-122"/>
+                <a:cs typeface="Calibri" pitchFamily="34" charset="-120"/>
+              </a:rPr>
+              <a:t>Projections are trend extrapolations.  </a:t>
+            </a:r>
+            <a:pPr indent="0" marL="0">
+              <a:buNone/>
+            </a:pPr>
+            <a:r>
+              <a:rPr lang="en-US" sz="1450" dirty="0">
+                <a:solidFill>
+                  <a:srgbClr val="0B0B0B"/>
+                </a:solidFill>
+                <a:latin typeface="Calibri" pitchFamily="34" charset="0"/>
+                <a:ea typeface="Calibri" pitchFamily="34" charset="-122"/>
+                <a:cs typeface="Calibri" pitchFamily="34" charset="-120"/>
+              </a:rPr>
+              <a:t>Log-linear, no physics ceiling, no policy scenario; the CI bands carry fit uncertainty only, and scenario uncertainty dominates.</a:t>
+            </a:r>
+            <a:endParaRPr lang="en-US" sz="1450" dirty="0"/>
+          </a:p>
+        </p:txBody>
+      </p:sp>
+      <p:sp>
+        <p:nvSpPr>
+          <p:cNvPr id="6" name="Text 4"/>
+          <p:cNvSpPr txBox="1"/>
+          <p:nvPr/>
+        </p:nvSpPr>
+        <p:spPr>
+          <a:xfrm>
+            <a:off x="502920" y="4617720"/>
+            <a:ext cx="6400800" cy="1051560"/>
+          </a:xfrm>
+          <a:prstGeom prst="rect">
+            <a:avLst/>
+          </a:prstGeom>
+          <a:noFill/>
+          <a:ln/>
+        </p:spPr>
+        <p:txBody>
+          <a:bodyPr wrap="square" lIns="0" tIns="0" rIns="0" bIns="0" rtlCol="0" anchor="ctr"/>
+          <a:lstStyle/>
+          <a:p>
+            <a:pPr indent="0" marL="0">
+              <a:buNone/>
+            </a:pPr>
+            <a:r>
+              <a:rPr lang="en-US" sz="1450" b="1" dirty="0">
+                <a:solidFill>
+                  <a:srgbClr val="2A78D6"/>
+                </a:solidFill>
+                <a:latin typeface="Calibri" pitchFamily="34" charset="0"/>
+                <a:ea typeface="Calibri" pitchFamily="34" charset="-122"/>
+                <a:cs typeface="Calibri" pitchFamily="34" charset="-120"/>
+              </a:rPr>
+              <a:t>EVs modeled separately; Tesla as BEV proxy.  </a:t>
+            </a:r>
+            <a:pPr indent="0" marL="0">
+              <a:buNone/>
+            </a:pPr>
+            <a:r>
+              <a:rPr lang="en-US" sz="1450" dirty="0">
+                <a:solidFill>
+                  <a:srgbClr val="0B0B0B"/>
+                </a:solidFill>
+                <a:latin typeface="Calibri" pitchFamily="34" charset="0"/>
+                <a:ea typeface="Calibri" pitchFamily="34" charset="-122"/>
+                <a:cs typeface="Calibri" pitchFamily="34" charset="-120"/>
+              </a:rPr>
+              <a:t>MPGe is a different quantity (BEV companion model, R² 0.708); the ex-BEV series leans on the Tesla proxy, first-order only inside 2023's Car SUV class.</a:t>
+            </a:r>
+            <a:endParaRPr lang="en-US" sz="1450" dirty="0"/>
+          </a:p>
+        </p:txBody>
+      </p:sp>
+      <p:pic>
+        <p:nvPicPr>
+          <p:cNvPr id="7" name="Image 0" descr="C:\Users\Samson\Desktop\Homework\OS3180\Final Project\charts\fig7_lab_vs_road.png">    </p:cNvPr>
+          <p:cNvPicPr>
+            <a:picLocks noChangeAspect="1"/>
+          </p:cNvPicPr>
+          <p:nvPr/>
+        </p:nvPicPr>
+        <p:blipFill>
+          <a:blip r:embed="rId1"/>
+          <a:stretch>
+            <a:fillRect/>
+          </a:stretch>
+        </p:blipFill>
+        <p:spPr>
+          <a:xfrm>
+            <a:off x="7223760" y="1463040"/>
+            <a:ext cx="4434840" cy="2499637"/>
+          </a:xfrm>
+          <a:prstGeom prst="rect">
+            <a:avLst/>
+          </a:prstGeom>
+        </p:spPr>
+      </p:pic>
+      <p:sp>
+        <p:nvSpPr>
+          <p:cNvPr id="8" name="Text 5"/>
+          <p:cNvSpPr txBox="1"/>
+          <p:nvPr/>
+        </p:nvSpPr>
+        <p:spPr>
+          <a:xfrm>
+            <a:off x="7223760" y="4206240"/>
+            <a:ext cx="4480560" cy="365760"/>
+          </a:xfrm>
+          <a:prstGeom prst="rect">
+            <a:avLst/>
+          </a:prstGeom>
+          <a:noFill/>
+          <a:ln/>
+        </p:spPr>
+        <p:txBody>
+          <a:bodyPr wrap="square" lIns="0" tIns="0" rIns="0" bIns="0" rtlCol="0" anchor="ctr"/>
+          <a:lstStyle/>
+          <a:p>
+            <a:pPr indent="0" marL="0">
+              <a:buNone/>
+            </a:pPr>
+            <a:r>
+              <a:rPr lang="en-US" sz="1200" dirty="0">
+                <a:solidFill>
+                  <a:srgbClr val="6E6C66"/>
+                </a:solidFill>
+                <a:latin typeface="Calibri" pitchFamily="34" charset="0"/>
+                <a:ea typeface="Calibri" pitchFamily="34" charset="-122"/>
+                <a:cs typeface="Calibri" pitchFamily="34" charset="-120"/>
+              </a:rPr>
+              <a:t>The lab-vs-road gap, 1975–2024</a:t>
+            </a:r>
+            <a:endParaRPr lang="en-US" sz="1200" dirty="0"/>
+          </a:p>
+        </p:txBody>
+      </p:sp>
+      <p:sp>
+        <p:nvSpPr>
+          <p:cNvPr id="9" name="Text 6"/>
+          <p:cNvSpPr txBox="1"/>
+          <p:nvPr/>
+        </p:nvSpPr>
+        <p:spPr>
+          <a:xfrm>
+            <a:off x="502920" y="6446520"/>
+            <a:ext cx="11155680" cy="292608"/>
+          </a:xfrm>
+          <a:prstGeom prst="rect">
+            <a:avLst/>
+          </a:prstGeom>
+          <a:noFill/>
+          <a:ln/>
+        </p:spPr>
+        <p:txBody>
+          <a:bodyPr wrap="square" lIns="0" tIns="0" rIns="0" bIns="0" rtlCol="0" anchor="ctr"/>
+          <a:lstStyle/>
+          <a:p>
+            <a:pPr indent="0" marL="0">
+              <a:buNone/>
+            </a:pPr>
+            <a:r>
+              <a:rPr lang="en-US" sz="1000" dirty="0">
+                <a:solidFill>
+                  <a:srgbClr val="6E6C66"/>
+                </a:solidFill>
+                <a:latin typeface="Calibri" pitchFamily="34" charset="0"/>
+                <a:ea typeface="Calibri" pitchFamily="34" charset="-122"/>
+                <a:cs typeface="Calibri" pitchFamily="34" charset="-120"/>
+              </a:rPr>
+              <a:t>Full limitations: reports/19_final_model.md, 29_productivity.md, 31_ice_productivity.md.</a:t>
+            </a:r>
+            <a:endParaRPr lang="en-US" sz="1000" dirty="0"/>
+          </a:p>
+        </p:txBody>
+      </p:sp>
+    </p:spTree>
+  </p:cSld>
+  <p:clrMapOvr>
+    <a:masterClrMapping/>
+  </p:clrMapOvr>
+</p:sld>
+</file>
+
+<file path=ppt/slides/slide21.xml><?xml version="1.0" encoding="utf-8"?>
+<p:sld xmlns:a="http://schemas.openxmlformats.org/drawingml/2006/main" xmlns:r="http://schemas.openxmlformats.org/officeDocument/2006/relationships" xmlns:p="http://schemas.openxmlformats.org/presentationml/2006/main">
+  <p:cSld name="Slide 21">
     <p:bg>
       <p:bgPr>
         <a:solidFill>
@@ -6828,9 +7469,9 @@
 </p:sld>
 </file>
 
-<file path=ppt/slides/slide21.xml><?xml version="1.0" encoding="utf-8"?>
+<file path=ppt/slides/slide22.xml><?xml version="1.0" encoding="utf-8"?>
 <p:sld xmlns:a="http://schemas.openxmlformats.org/drawingml/2006/main" xmlns:r="http://schemas.openxmlformats.org/officeDocument/2006/relationships" xmlns:p="http://schemas.openxmlformats.org/presentationml/2006/main">
-  <p:cSld name="Slide 21">
+  <p:cSld name="Slide 22">
     <p:spTree>
       <p:nvGrpSpPr>
         <p:cNvPr id="1" name=""/>
@@ -6900,7 +7541,7 @@
       </p:sp>
       <p:graphicFrame>
         <p:nvGraphicFramePr>
-          <p:cNvPr id="22" name="Table 0"/>
+          <p:cNvPr id="23" name="Table 0"/>
           <p:cNvGraphicFramePr>
             <a:graphicFrameLocks noGrp="1"/>
           </p:cNvGraphicFramePr>
@@ -8972,9 +9613,9 @@
 </p:sld>
 </file>
 
-<file path=ppt/slides/slide22.xml><?xml version="1.0" encoding="utf-8"?>
+<file path=ppt/slides/slide23.xml><?xml version="1.0" encoding="utf-8"?>
 <p:sld xmlns:a="http://schemas.openxmlformats.org/drawingml/2006/main" xmlns:r="http://schemas.openxmlformats.org/officeDocument/2006/relationships" xmlns:p="http://schemas.openxmlformats.org/presentationml/2006/main">
-  <p:cSld name="Slide 22">
+  <p:cSld name="Slide 23">
     <p:spTree>
       <p:nvGrpSpPr>
         <p:cNvPr id="1" name=""/>
@@ -9139,186 +9780,6 @@
                 <a:cs typeface="Calibri" pitchFamily="34" charset="-120"/>
               </a:rPr>
               <a:t>Exhaustive SSE search over break locations, order by BIC; reports/10_statistics.md.</a:t>
-            </a:r>
-            <a:endParaRPr lang="en-US" sz="1000" dirty="0"/>
-          </a:p>
-        </p:txBody>
-      </p:sp>
-    </p:spTree>
-  </p:cSld>
-  <p:clrMapOvr>
-    <a:masterClrMapping/>
-  </p:clrMapOvr>
-</p:sld>
-</file>
-
-<file path=ppt/slides/slide23.xml><?xml version="1.0" encoding="utf-8"?>
-<p:sld xmlns:a="http://schemas.openxmlformats.org/drawingml/2006/main" xmlns:r="http://schemas.openxmlformats.org/officeDocument/2006/relationships" xmlns:p="http://schemas.openxmlformats.org/presentationml/2006/main">
-  <p:cSld name="Slide 23">
-    <p:spTree>
-      <p:nvGrpSpPr>
-        <p:cNvPr id="1" name=""/>
-        <p:cNvGrpSpPr/>
-        <p:nvPr/>
-      </p:nvGrpSpPr>
-      <p:grpSpPr>
-        <a:xfrm>
-          <a:off x="0" y="0"/>
-          <a:ext cx="0" cy="0"/>
-          <a:chOff x="0" y="0"/>
-          <a:chExt cx="0" cy="0"/>
-        </a:xfrm>
-      </p:grpSpPr>
-      <p:sp>
-        <p:nvSpPr>
-          <p:cNvPr id="2" name="Text 0"/>
-          <p:cNvSpPr txBox="1"/>
-          <p:nvPr/>
-        </p:nvSpPr>
-        <p:spPr>
-          <a:xfrm>
-            <a:off x="502920" y="292608"/>
-            <a:ext cx="11155680" cy="685800"/>
-          </a:xfrm>
-          <a:prstGeom prst="rect">
-            <a:avLst/>
-          </a:prstGeom>
-          <a:noFill/>
-          <a:ln/>
-        </p:spPr>
-        <p:txBody>
-          <a:bodyPr wrap="square" lIns="0" tIns="0" rIns="0" bIns="0" rtlCol="0" anchor="ctr"/>
-          <a:lstStyle/>
-          <a:p>
-            <a:pPr indent="0" marL="0">
-              <a:buNone/>
-            </a:pPr>
-            <a:r>
-              <a:rPr lang="en-US" sz="1300" b="1" dirty="0">
-                <a:solidFill>
-                  <a:srgbClr val="EB6834"/>
-                </a:solidFill>
-                <a:latin typeface="Calibri" pitchFamily="34" charset="0"/>
-                <a:ea typeface="Calibri" pitchFamily="34" charset="-122"/>
-                <a:cs typeface="Calibri" pitchFamily="34" charset="-120"/>
-              </a:rPr>
-              <a:t>BACKUP   </a:t>
-            </a:r>
-            <a:pPr indent="0" marL="0">
-              <a:buNone/>
-            </a:pPr>
-            <a:r>
-              <a:rPr lang="en-US" sz="2600" b="1" dirty="0">
-                <a:solidFill>
-                  <a:srgbClr val="0B0B0B"/>
-                </a:solidFill>
-                <a:latin typeface="Calibri" pitchFamily="34" charset="0"/>
-                <a:ea typeface="Calibri" pitchFamily="34" charset="-122"/>
-                <a:cs typeface="Calibri" pitchFamily="34" charset="-120"/>
-              </a:rPr>
-              <a:t>We audited our own story: gas prices explain almost none of the mix shift</a:t>
-            </a:r>
-            <a:endParaRPr lang="en-US" sz="1300" dirty="0"/>
-          </a:p>
-        </p:txBody>
-      </p:sp>
-      <p:pic>
-        <p:nvPicPr>
-          <p:cNvPr id="3" name="Image 0" descr="C:\Users\Samson\Desktop\Homework\OS3180\Final Project\charts\fig19_correlation_that_wasnt.png">    </p:cNvPr>
-          <p:cNvPicPr>
-            <a:picLocks noChangeAspect="1"/>
-          </p:cNvPicPr>
-          <p:nvPr/>
-        </p:nvPicPr>
-        <p:blipFill>
-          <a:blip r:embed="rId1"/>
-          <a:stretch>
-            <a:fillRect/>
-          </a:stretch>
-        </p:blipFill>
-        <p:spPr>
-          <a:xfrm>
-            <a:off x="502920" y="1234440"/>
-            <a:ext cx="7498080" cy="4362519"/>
-          </a:xfrm>
-          <a:prstGeom prst="rect">
-            <a:avLst/>
-          </a:prstGeom>
-        </p:spPr>
-      </p:pic>
-      <p:sp>
-        <p:nvSpPr>
-          <p:cNvPr id="4" name="Text 1"/>
-          <p:cNvSpPr txBox="1"/>
-          <p:nvPr/>
-        </p:nvSpPr>
-        <p:spPr>
-          <a:xfrm>
-            <a:off x="8321040" y="1463040"/>
-            <a:ext cx="3337560" cy="4206240"/>
-          </a:xfrm>
-          <a:prstGeom prst="rect">
-            <a:avLst/>
-          </a:prstGeom>
-          <a:noFill/>
-          <a:ln/>
-        </p:spPr>
-        <p:txBody>
-          <a:bodyPr wrap="square" lIns="0" tIns="0" rIns="0" bIns="0" rtlCol="0" anchor="ctr"/>
-          <a:lstStyle/>
-          <a:p>
-            <a:pPr indent="0" marL="0">
-              <a:buNone/>
-            </a:pPr>
-            <a:r>
-              <a:rPr lang="en-US" sz="1450" dirty="0">
-                <a:solidFill>
-                  <a:srgbClr val="0B0B0B"/>
-                </a:solidFill>
-                <a:latin typeface="Calibri" pitchFamily="34" charset="0"/>
-                <a:ea typeface="Calibri" pitchFamily="34" charset="-122"/>
-                <a:cs typeface="Calibri" pitchFamily="34" charset="-120"/>
-              </a:rPr>
-              <a:t>The overlay everyone believes: cheap gas killed the sedan. The regression: levels r-squared 0.007, differenced 0.003. The same audit killed the cheap-credit story (levels 0.57, differenced not significant). One episode survived testing: 1979.</a:t>
-            </a:r>
-            <a:endParaRPr lang="en-US" sz="1450" dirty="0"/>
-          </a:p>
-        </p:txBody>
-      </p:sp>
-      <p:sp>
-        <p:nvSpPr>
-          <p:cNvPr id="5" name="Text 2"/>
-          <p:cNvSpPr txBox="1"/>
-          <p:nvPr/>
-        </p:nvSpPr>
-        <p:spPr>
-          <a:xfrm>
-            <a:off x="502920" y="6446520"/>
-            <a:ext cx="11155680" cy="292608"/>
-          </a:xfrm>
-          <a:prstGeom prst="rect">
-            <a:avLst/>
-          </a:prstGeom>
-          <a:noFill/>
-          <a:ln/>
-        </p:spPr>
-        <p:txBody>
-          <a:bodyPr wrap="square" lIns="0" tIns="0" rIns="0" bIns="0" rtlCol="0" anchor="ctr"/>
-          <a:lstStyle/>
-          <a:p>
-            <a:pPr indent="0" marL="0">
-              <a:buNone/>
-            </a:pPr>
-            <a:r>
-              <a:rPr lang="en-US" sz="1000" dirty="0">
-                <a:solidFill>
-                  <a:srgbClr val="6E6C66"/>
-                </a:solidFill>
-                <a:latin typeface="Calibri" pitchFamily="34" charset="0"/>
-                <a:ea typeface="Calibri" pitchFamily="34" charset="-122"/>
-                <a:cs typeface="Calibri" pitchFamily="34" charset="-120"/>
-              </a:rPr>
-              <a:t>1976-2024 annual; reports/10_statistics.md section 4.</a:t>
             </a:r>
             <a:endParaRPr lang="en-US" sz="1000" dirty="0"/>
           </a:p>
@@ -9396,7 +9857,7 @@
                 <a:ea typeface="Calibri" pitchFamily="34" charset="-122"/>
                 <a:cs typeface="Calibri" pitchFamily="34" charset="-120"/>
               </a:rPr>
-              <a:t>Buyers systematically choose better MPG than the catalog median</a:t>
+              <a:t>We audited our own story: gas prices explain almost none of the mix shift</a:t>
             </a:r>
             <a:endParaRPr lang="en-US" sz="1300" dirty="0"/>
           </a:p>
@@ -9404,7 +9865,7 @@
       </p:sp>
       <p:pic>
         <p:nvPicPr>
-          <p:cNvPr id="3" name="Image 0" descr="C:\Users\Samson\Desktop\Homework\OS3180\Final Project\charts\fig17_distribution_shift.png">    </p:cNvPr>
+          <p:cNvPr id="3" name="Image 0" descr="C:\Users\Samson\Desktop\Homework\OS3180\Final Project\charts\fig19_correlation_that_wasnt.png">    </p:cNvPr>
           <p:cNvPicPr>
             <a:picLocks noChangeAspect="1"/>
           </p:cNvPicPr>
@@ -9419,7 +9880,7 @@
         <p:spPr>
           <a:xfrm>
             <a:off x="502920" y="1234440"/>
-            <a:ext cx="7498080" cy="3953533"/>
+            <a:ext cx="7498080" cy="4362519"/>
           </a:xfrm>
           <a:prstGeom prst="rect">
             <a:avLst/>
@@ -9459,7 +9920,7 @@
                 <a:ea typeface="Calibri" pitchFamily="34" charset="-122"/>
                 <a:cs typeface="Calibri" pitchFamily="34" charset="-120"/>
               </a:rPr>
-              <a:t>Offered vs production-weighted MPG, MY2024: KS D = 0.211, a 3.5-MPG median shift toward efficiency, Wasserstein 3.06 MPG. Production is concentrated: Gini 0.731; 23% of carlines carry 80% of volume.</a:t>
+              <a:t>The overlay everyone believes: cheap gas killed the sedan. The regression: levels r-squared 0.007, differenced 0.003. The same audit killed the cheap-credit story (levels 0.57, differenced not significant). One episode survived testing: 1979.</a:t>
             </a:r>
             <a:endParaRPr lang="en-US" sz="1450" dirty="0"/>
           </a:p>
@@ -9498,7 +9959,7 @@
                 <a:ea typeface="Calibri" pitchFamily="34" charset="-122"/>
                 <a:cs typeface="Calibri" pitchFamily="34" charset="-120"/>
               </a:rPr>
-              <a:t>MY2024 combustion model types; reports/10_statistics.md section 2.</a:t>
+              <a:t>1976-2024 annual; reports/10_statistics.md section 4.</a:t>
             </a:r>
             <a:endParaRPr lang="en-US" sz="1000" dirty="0"/>
           </a:p>
@@ -9576,7 +10037,7 @@
                 <a:ea typeface="Calibri" pitchFamily="34" charset="-122"/>
                 <a:cs typeface="Calibri" pitchFamily="34" charset="-120"/>
               </a:rPr>
-              <a:t>Sticker history: the era when electric meant expensive</a:t>
+              <a:t>Buyers systematically choose better MPG than the catalog median</a:t>
             </a:r>
             <a:endParaRPr lang="en-US" sz="1300" dirty="0"/>
           </a:p>
@@ -9584,7 +10045,7 @@
       </p:sp>
       <p:pic>
         <p:nvPicPr>
-          <p:cNvPr id="3" name="Image 0" descr="C:\Users\Samson\Desktop\Homework\OS3180\Final Project\charts\fig41_msrp_by_powertrain.png">    </p:cNvPr>
+          <p:cNvPr id="3" name="Image 0" descr="C:\Users\Samson\Desktop\Homework\OS3180\Final Project\charts\fig17_distribution_shift.png">    </p:cNvPr>
           <p:cNvPicPr>
             <a:picLocks noChangeAspect="1"/>
           </p:cNvPicPr>
@@ -9599,7 +10060,7 @@
         <p:spPr>
           <a:xfrm>
             <a:off x="502920" y="1234440"/>
-            <a:ext cx="7498080" cy="4362519"/>
+            <a:ext cx="7498080" cy="3953533"/>
           </a:xfrm>
           <a:prstGeom prst="rect">
             <a:avLst/>
@@ -9639,7 +10100,7 @@
                 <a:ea typeface="Calibri" pitchFamily="34" charset="-122"/>
                 <a:cs typeface="Calibri" pitchFamily="34" charset="-120"/>
               </a:rPr>
-              <a:t>Trim-level MSRPs 2015-2020 (17.5k trims): hybrids the budget powertrain at $24-39k, gasoline $35-40k, the Mirai parked at $58.5k, BEV medians swinging $29-60k on 11-31 trims a year. By July 2026 the EV transaction premium compressed to $6,477.</a:t>
+              <a:t>Offered vs production-weighted MPG, MY2024: KS D = 0.211, a 3.5-MPG median shift toward efficiency, Wasserstein 3.06 MPG. Production is concentrated: Gini 0.731; 23% of carlines carry 80% of volume.</a:t>
             </a:r>
             <a:endParaRPr lang="en-US" sz="1450" dirty="0"/>
           </a:p>
@@ -9678,7 +10139,7 @@
                 <a:ea typeface="Calibri" pitchFamily="34" charset="-122"/>
                 <a:cs typeface="Calibri" pitchFamily="34" charset="-120"/>
               </a:rPr>
-              <a:t>CarAPI sample feed, powertrain via fueleconomy.gov join (80.1%); reports/28_msrp.md.</a:t>
+              <a:t>MY2024 combustion model types; reports/10_statistics.md section 2.</a:t>
             </a:r>
             <a:endParaRPr lang="en-US" sz="1000" dirty="0"/>
           </a:p>
@@ -9756,7 +10217,7 @@
                 <a:ea typeface="Calibri" pitchFamily="34" charset="-122"/>
                 <a:cs typeface="Calibri" pitchFamily="34" charset="-120"/>
               </a:rPr>
-              <a:t>Driving on electrons has cost half as much for a decade</a:t>
+              <a:t>Sticker history: the era when electric meant expensive</a:t>
             </a:r>
             <a:endParaRPr lang="en-US" sz="1300" dirty="0"/>
           </a:p>
@@ -9764,7 +10225,7 @@
       </p:sp>
       <p:pic>
         <p:nvPicPr>
-          <p:cNvPr id="3" name="Image 0" descr="C:\Users\Samson\Desktop\Homework\OS3180\Final Project\charts\fig33_cost_trends.png">    </p:cNvPr>
+          <p:cNvPr id="3" name="Image 0" descr="C:\Users\Samson\Desktop\Homework\OS3180\Final Project\charts\fig41_msrp_by_powertrain.png">    </p:cNvPr>
           <p:cNvPicPr>
             <a:picLocks noChangeAspect="1"/>
           </p:cNvPicPr>
@@ -9819,7 +10280,7 @@
                 <a:ea typeface="Calibri" pitchFamily="34" charset="-122"/>
                 <a:cs typeface="Calibri" pitchFamily="34" charset="-120"/>
               </a:rPr>
-              <a:t>Median energy cost per mile at each year's national prices: BEV 5-7 cents, gasoline 10-19. The 2024 gap is $1,007 vs $2,463 per 15,000 miles, and it narrows late as electricity prices climb while gas cars improve.</a:t>
+              <a:t>Trim-level MSRPs 2015-2020 (17.5k trims): hybrids the budget powertrain at $24-39k, gasoline $35-40k, the Mirai parked at $58.5k, BEV medians swinging $29-60k on 11-31 trims a year. By July 2026 the EV transaction premium compressed to $6,477.</a:t>
             </a:r>
             <a:endParaRPr lang="en-US" sz="1450" dirty="0"/>
           </a:p>
@@ -9858,7 +10319,7 @@
                 <a:ea typeface="Calibri" pitchFamily="34" charset="-122"/>
                 <a:cs typeface="Calibri" pitchFamily="34" charset="-120"/>
               </a:rPr>
-              <a:t>fueleconomy.gov catalog x BLS prices; reports/23_powertrain.md.</a:t>
+              <a:t>CarAPI sample feed, powertrain via fueleconomy.gov join (80.1%); reports/28_msrp.md.</a:t>
             </a:r>
             <a:endParaRPr lang="en-US" sz="1000" dirty="0"/>
           </a:p>
@@ -9936,6 +10397,186 @@
                 <a:ea typeface="Calibri" pitchFamily="34" charset="-122"/>
                 <a:cs typeface="Calibri" pitchFamily="34" charset="-120"/>
               </a:rPr>
+              <a:t>Driving on electrons has cost half as much for a decade</a:t>
+            </a:r>
+            <a:endParaRPr lang="en-US" sz="1300" dirty="0"/>
+          </a:p>
+        </p:txBody>
+      </p:sp>
+      <p:pic>
+        <p:nvPicPr>
+          <p:cNvPr id="3" name="Image 0" descr="C:\Users\Samson\Desktop\Homework\OS3180\Final Project\charts\fig33_cost_trends.png">    </p:cNvPr>
+          <p:cNvPicPr>
+            <a:picLocks noChangeAspect="1"/>
+          </p:cNvPicPr>
+          <p:nvPr/>
+        </p:nvPicPr>
+        <p:blipFill>
+          <a:blip r:embed="rId1"/>
+          <a:stretch>
+            <a:fillRect/>
+          </a:stretch>
+        </p:blipFill>
+        <p:spPr>
+          <a:xfrm>
+            <a:off x="502920" y="1234440"/>
+            <a:ext cx="7498080" cy="4362519"/>
+          </a:xfrm>
+          <a:prstGeom prst="rect">
+            <a:avLst/>
+          </a:prstGeom>
+        </p:spPr>
+      </p:pic>
+      <p:sp>
+        <p:nvSpPr>
+          <p:cNvPr id="4" name="Text 1"/>
+          <p:cNvSpPr txBox="1"/>
+          <p:nvPr/>
+        </p:nvSpPr>
+        <p:spPr>
+          <a:xfrm>
+            <a:off x="8321040" y="1463040"/>
+            <a:ext cx="3337560" cy="4206240"/>
+          </a:xfrm>
+          <a:prstGeom prst="rect">
+            <a:avLst/>
+          </a:prstGeom>
+          <a:noFill/>
+          <a:ln/>
+        </p:spPr>
+        <p:txBody>
+          <a:bodyPr wrap="square" lIns="0" tIns="0" rIns="0" bIns="0" rtlCol="0" anchor="ctr"/>
+          <a:lstStyle/>
+          <a:p>
+            <a:pPr indent="0" marL="0">
+              <a:buNone/>
+            </a:pPr>
+            <a:r>
+              <a:rPr lang="en-US" sz="1450" dirty="0">
+                <a:solidFill>
+                  <a:srgbClr val="0B0B0B"/>
+                </a:solidFill>
+                <a:latin typeface="Calibri" pitchFamily="34" charset="0"/>
+                <a:ea typeface="Calibri" pitchFamily="34" charset="-122"/>
+                <a:cs typeface="Calibri" pitchFamily="34" charset="-120"/>
+              </a:rPr>
+              <a:t>Median energy cost per mile at each year's national prices: BEV 5-7 cents, gasoline 10-19. The 2024 gap is $1,007 vs $2,463 per 15,000 miles, and it narrows late as electricity prices climb while gas cars improve.</a:t>
+            </a:r>
+            <a:endParaRPr lang="en-US" sz="1450" dirty="0"/>
+          </a:p>
+        </p:txBody>
+      </p:sp>
+      <p:sp>
+        <p:nvSpPr>
+          <p:cNvPr id="5" name="Text 2"/>
+          <p:cNvSpPr txBox="1"/>
+          <p:nvPr/>
+        </p:nvSpPr>
+        <p:spPr>
+          <a:xfrm>
+            <a:off x="502920" y="6446520"/>
+            <a:ext cx="11155680" cy="292608"/>
+          </a:xfrm>
+          <a:prstGeom prst="rect">
+            <a:avLst/>
+          </a:prstGeom>
+          <a:noFill/>
+          <a:ln/>
+        </p:spPr>
+        <p:txBody>
+          <a:bodyPr wrap="square" lIns="0" tIns="0" rIns="0" bIns="0" rtlCol="0" anchor="ctr"/>
+          <a:lstStyle/>
+          <a:p>
+            <a:pPr indent="0" marL="0">
+              <a:buNone/>
+            </a:pPr>
+            <a:r>
+              <a:rPr lang="en-US" sz="1000" dirty="0">
+                <a:solidFill>
+                  <a:srgbClr val="6E6C66"/>
+                </a:solidFill>
+                <a:latin typeface="Calibri" pitchFamily="34" charset="0"/>
+                <a:ea typeface="Calibri" pitchFamily="34" charset="-122"/>
+                <a:cs typeface="Calibri" pitchFamily="34" charset="-120"/>
+              </a:rPr>
+              <a:t>fueleconomy.gov catalog x BLS prices; reports/23_powertrain.md.</a:t>
+            </a:r>
+            <a:endParaRPr lang="en-US" sz="1000" dirty="0"/>
+          </a:p>
+        </p:txBody>
+      </p:sp>
+    </p:spTree>
+  </p:cSld>
+  <p:clrMapOvr>
+    <a:masterClrMapping/>
+  </p:clrMapOvr>
+</p:sld>
+</file>
+
+<file path=ppt/slides/slide28.xml><?xml version="1.0" encoding="utf-8"?>
+<p:sld xmlns:a="http://schemas.openxmlformats.org/drawingml/2006/main" xmlns:r="http://schemas.openxmlformats.org/officeDocument/2006/relationships" xmlns:p="http://schemas.openxmlformats.org/presentationml/2006/main">
+  <p:cSld name="Slide 28">
+    <p:spTree>
+      <p:nvGrpSpPr>
+        <p:cNvPr id="1" name=""/>
+        <p:cNvGrpSpPr/>
+        <p:nvPr/>
+      </p:nvGrpSpPr>
+      <p:grpSpPr>
+        <a:xfrm>
+          <a:off x="0" y="0"/>
+          <a:ext cx="0" cy="0"/>
+          <a:chOff x="0" y="0"/>
+          <a:chExt cx="0" cy="0"/>
+        </a:xfrm>
+      </p:grpSpPr>
+      <p:sp>
+        <p:nvSpPr>
+          <p:cNvPr id="2" name="Text 0"/>
+          <p:cNvSpPr txBox="1"/>
+          <p:nvPr/>
+        </p:nvSpPr>
+        <p:spPr>
+          <a:xfrm>
+            <a:off x="502920" y="292608"/>
+            <a:ext cx="11155680" cy="685800"/>
+          </a:xfrm>
+          <a:prstGeom prst="rect">
+            <a:avLst/>
+          </a:prstGeom>
+          <a:noFill/>
+          <a:ln/>
+        </p:spPr>
+        <p:txBody>
+          <a:bodyPr wrap="square" lIns="0" tIns="0" rIns="0" bIns="0" rtlCol="0" anchor="ctr"/>
+          <a:lstStyle/>
+          <a:p>
+            <a:pPr indent="0" marL="0">
+              <a:buNone/>
+            </a:pPr>
+            <a:r>
+              <a:rPr lang="en-US" sz="1300" b="1" dirty="0">
+                <a:solidFill>
+                  <a:srgbClr val="EB6834"/>
+                </a:solidFill>
+                <a:latin typeface="Calibri" pitchFamily="34" charset="0"/>
+                <a:ea typeface="Calibri" pitchFamily="34" charset="-122"/>
+                <a:cs typeface="Calibri" pitchFamily="34" charset="-120"/>
+              </a:rPr>
+              <a:t>BACKUP   </a:t>
+            </a:r>
+            <a:pPr indent="0" marL="0">
+              <a:buNone/>
+            </a:pPr>
+            <a:r>
+              <a:rPr lang="en-US" sz="2600" b="1" dirty="0">
+                <a:solidFill>
+                  <a:srgbClr val="0B0B0B"/>
+                </a:solidFill>
+                <a:latin typeface="Calibri" pitchFamily="34" charset="0"/>
+                <a:ea typeface="Calibri" pitchFamily="34" charset="-122"/>
+                <a:cs typeface="Calibri" pitchFamily="34" charset="-120"/>
+              </a:rPr>
               <a:t>EVs ride the same productivity clock</a:t>
             </a:r>
             <a:endParaRPr lang="en-US" sz="1300" dirty="0"/>
@@ -10052,9 +10693,9 @@
 </p:sld>
 </file>
 
-<file path=ppt/slides/slide28.xml><?xml version="1.0" encoding="utf-8"?>
+<file path=ppt/slides/slide29.xml><?xml version="1.0" encoding="utf-8"?>
 <p:sld xmlns:a="http://schemas.openxmlformats.org/drawingml/2006/main" xmlns:r="http://schemas.openxmlformats.org/officeDocument/2006/relationships" xmlns:p="http://schemas.openxmlformats.org/presentationml/2006/main">
-  <p:cSld name="Slide 28">
+  <p:cSld name="Slide 29">
     <p:spTree>
       <p:nvGrpSpPr>
         <p:cNvPr id="1" name=""/>

</xml_diff>